<commit_message>
docs: script v4, deck in story order with fresh live screenshots and the masked safety example, video re-recorded (5:58)
Co-Authored-By: Claude Opus 5.5 <noreply@anthropic.com>
</commit_message>
<xml_diff>
--- a/docs/submission/assets/aura-health-deck.pptx
+++ b/docs/submission/assets/aura-health-deck.pptx
@@ -607,13 +607,13 @@
           <a:p/>
           <a:p>
             <a:r>
-              <a:t>[Screen: patient → I want to mention something → Safety handoff fixture → safety panel.]</a:t>
+              <a:t>[Screen: finish card → Show the safety example → the note box opens with A worrying message (masked on screen) → Send to AURA → safety panel → the card explains, with Reset the demo.]</a:t>
             </a:r>
           </a:p>
           <a:p/>
           <a:p>
             <a:r>
-              <a:t>"Anything a patient types is safety-checked first. If there's a concern, fixed safety resources take over the screen and the AI steps back. Those messages are never AI-written. The same applies to medication questions: asking to double a dose goes to safety, not to an answer."</a:t>
+              <a:t>"Anything a patient types is safety-checked first. If there's a concern, fixed safety resources take over the screen and the AI steps back. Those messages are never AI-written, and the patient can't dismiss them. The clinician sees the same safety state when they open the record. This prototype doesn't send alerts: who is told, and how fast, is for the care team to decide. The same applies to medication questions: asking to double a dose goes to safety, not to an answer."</a:t>
             </a:r>
           </a:p>
         </p:txBody>
@@ -1539,7 +1539,7 @@
           <a:p/>
           <a:p>
             <a:r>
-              <a:t>[Screen: landing → See the patient's day → "Take a breath" → Continue → summary.]</a:t>
+              <a:t>[Screen: landing → Play the 3-minute story → Start (the in-app guided story; each step highlights one thing and AURA does the tapping) → "Take a breath" → summary.]</a:t>
             </a:r>
           </a:p>
           <a:p/>
@@ -1627,7 +1627,7 @@
           <a:p/>
           <a:p>
             <a:r>
-              <a:t>[Screen: landing → See the patient's day → "Take a breath" → Continue → summary.]</a:t>
+              <a:t>[Screen: landing → Play the 3-minute story → Start (the in-app guided story; each step highlights one thing and AURA does the tapping) → "Take a breath" → summary.]</a:t>
             </a:r>
           </a:p>
           <a:p/>
@@ -1797,19 +1797,19 @@
           <a:lstStyle/>
           <a:p>
             <a:r>
-              <a:t>Scene 5 · Something changes — 2:35–3:15</a:t>
+              <a:t>Scene 5 · Ready for the appointment — 2:35–3:05</a:t>
             </a:r>
           </a:p>
           <a:p/>
           <a:p>
             <a:r>
-              <a:t>[Screen: Demo guide → Simulate: flu 3 days → back to the patient home.]</a:t>
+              <a:t>[Screen: Prepare for my appointment → missed doses → Not sent.]</a:t>
             </a:r>
           </a:p>
           <a:p/>
           <a:p>
             <a:r>
-              <a:t>"Now a flu, simulated over three days. AURA notices resting heart rate is higher than in the person's recent records, and says exactly that: a recent change, not a change from their usual. And when a change shows up, it offers a small idea for today: a short walk, a message to someone you trust, or planning a session. Optional, never about medication."</a:t>
+              <a:t>"Before the visit, everything is in one place: what changed, when, and the missed dose with its reason, ready to discuss with the doctor or pharmacist. Nothing is sent automatically. It stays Not sent until the patient decides."</a:t>
             </a:r>
           </a:p>
         </p:txBody>
@@ -1879,19 +1879,31 @@
           <a:lstStyle/>
           <a:p>
             <a:r>
-              <a:t>Scene 6 · Ready for the appointment — 3:15–3:45</a:t>
+              <a:t>Scene 6 · What the clinician sees — the agent at work — 3:05–4:10</a:t>
             </a:r>
           </a:p>
           <a:p/>
           <a:p>
             <a:r>
-              <a:t>[Screen: Prepare for my appointment → missed doses → Not sent.]</a:t>
+              <a:t>[Screen: Clinician → assessment cards → Ask about this record:]</a:t>
             </a:r>
           </a:p>
           <a:p/>
           <a:p>
             <a:r>
-              <a:t>"Before the visit, everything is in one place: what changed, when, and the missed dose with its reason, ready to discuss with the doctor or pharmacist. Nothing is sent automatically. It stays Not sent until the patient decides."</a:t>
+              <a:t>"If the patient shares, their clinician sees what changed and when, with exact values and sources. And the clinician can ask. Here AURA works as an agent: it decides which signals, tools and dates to look at, reads the record, and drafts an answer where every statement cites its source. A second, independent check then reviews each statement and removes anything unsupported. How AURA looked shows exactly what it did. It can only read; it never changes the record or the treatment."</a:t>
+            </a:r>
+          </a:p>
+          <a:p/>
+          <a:p>
+            <a:r>
+              <a:t>[If it falls back:]</a:t>
+            </a:r>
+          </a:p>
+          <a:p/>
+          <a:p>
+            <a:r>
+              <a:t>"This time the draft didn't pass the checks, so AURA shows the related facts and says why."</a:t>
             </a:r>
           </a:p>
         </p:txBody>
@@ -1961,31 +1973,19 @@
           <a:lstStyle/>
           <a:p>
             <a:r>
-              <a:t>Scene 7 · What the clinician sees — the agent at work — 3:45–4:50</a:t>
+              <a:t>Scene 7 · Something changes — 4:10–4:50</a:t>
             </a:r>
           </a:p>
           <a:p/>
           <a:p>
             <a:r>
-              <a:t>[Screen: Clinician → assessment cards → Ask about this record:]</a:t>
+              <a:t>[Screen: guided story step 9 → simulated flu → the patient home with the new summary and a small idea for today.]</a:t>
             </a:r>
           </a:p>
           <a:p/>
           <a:p>
             <a:r>
-              <a:t>"If the patient shares, their clinician sees what changed and when, with exact values and sources. And the clinician can ask. Here AURA works as an agent: it decides which signals, tools and dates to look at, reads the record, and drafts an answer where every statement cites its source. A second, independent check then reviews each statement and removes anything unsupported. How AURA looked shows exactly what it did. It can only read; it never changes the record or the treatment."</a:t>
-            </a:r>
-          </a:p>
-          <a:p/>
-          <a:p>
-            <a:r>
-              <a:t>[If it falls back:]</a:t>
-            </a:r>
-          </a:p>
-          <a:p/>
-          <a:p>
-            <a:r>
-              <a:t>"This time the draft didn't pass the checks, so AURA shows the related facts and says why."</a:t>
+              <a:t>"Now a flu, simulated over three days. AURA notices resting heart rate is higher than in the person's recent records, and says exactly that: a recent change, not a change from their usual. And when a change shows up, it offers a small idea for today: a short walk, a message to someone you trust, or planning a session. Optional, never about medication."</a:t>
             </a:r>
           </a:p>
         </p:txBody>
@@ -5214,7 +5214,7 @@
         <p:spPr>
           <a:xfrm>
             <a:off x="609600" y="952500"/>
-            <a:ext cx="5969000" cy="203200"/>
+            <a:ext cx="5440680" cy="203200"/>
           </a:xfrm>
           <a:prstGeom prst="rect">
             <a:avLst/>
@@ -5251,7 +5251,7 @@
         <p:spPr>
           <a:xfrm>
             <a:off x="609600" y="1384300"/>
-            <a:ext cx="5969000" cy="810220"/>
+            <a:ext cx="5440680" cy="810220"/>
           </a:xfrm>
           <a:prstGeom prst="rect">
             <a:avLst/>
@@ -5288,7 +5288,7 @@
         <p:spPr>
           <a:xfrm>
             <a:off x="876300" y="2512020"/>
-            <a:ext cx="5691632" cy="568920"/>
+            <a:ext cx="5163312" cy="853380"/>
           </a:xfrm>
           <a:prstGeom prst="rect">
             <a:avLst/>
@@ -5311,21 +5311,21 @@
                 </a:solidFill>
                 <a:latin typeface="Nunito"/>
               </a:rPr>
-              <a:t>If there is a concern, fixed safety resources take over the screen and the AI steps back.</a:t>
-            </a:r>
-          </a:p>
-        </p:txBody>
-      </p:sp>
-      <p:sp>
-        <p:nvSpPr>
-          <p:cNvPr id="7" name="Text: Those messages are never AI-written."/>
-          <p:cNvSpPr txBox="1"/>
-          <p:nvPr/>
-        </p:nvSpPr>
-        <p:spPr>
-          <a:xfrm>
-            <a:off x="876300" y="3246040"/>
-            <a:ext cx="3584956" cy="284480"/>
+              <a:t>If there is a concern, fixed safety resources take over the screen and the AI steps back. They are never AI-written.</a:t>
+            </a:r>
+          </a:p>
+        </p:txBody>
+      </p:sp>
+      <p:sp>
+        <p:nvSpPr>
+          <p:cNvPr id="7" name="Text: The patient can't dismiss them. The clin"/>
+          <p:cNvSpPr txBox="1"/>
+          <p:nvPr/>
+        </p:nvSpPr>
+        <p:spPr>
+          <a:xfrm>
+            <a:off x="876300" y="3530500"/>
+            <a:ext cx="5163312" cy="568920"/>
           </a:xfrm>
           <a:prstGeom prst="rect">
             <a:avLst/>
@@ -5348,21 +5348,21 @@
                 </a:solidFill>
                 <a:latin typeface="Nunito"/>
               </a:rPr>
-              <a:t>Those messages are never AI-written.</a:t>
-            </a:r>
-          </a:p>
-        </p:txBody>
-      </p:sp>
-      <p:sp>
-        <p:nvSpPr>
-          <p:cNvPr id="8" name="Text: Asking to double a dose goes to safety, "/>
-          <p:cNvSpPr txBox="1"/>
-          <p:nvPr/>
-        </p:nvSpPr>
-        <p:spPr>
-          <a:xfrm>
-            <a:off x="876300" y="3695600"/>
-            <a:ext cx="5394452" cy="284480"/>
+              <a:t>The patient can't dismiss them. The clinician sees the same safety state when they open the record.</a:t>
+            </a:r>
+          </a:p>
+        </p:txBody>
+      </p:sp>
+      <p:sp>
+        <p:nvSpPr>
+          <p:cNvPr id="8" name="Text: No alerts are sent in this prototype: wh"/>
+          <p:cNvSpPr txBox="1"/>
+          <p:nvPr/>
+        </p:nvSpPr>
+        <p:spPr>
+          <a:xfrm>
+            <a:off x="876300" y="4264521"/>
+            <a:ext cx="5163312" cy="568920"/>
           </a:xfrm>
           <a:prstGeom prst="rect">
             <a:avLst/>
@@ -5385,6 +5385,43 @@
                 </a:solidFill>
                 <a:latin typeface="Nunito"/>
               </a:rPr>
+              <a:t>No alerts are sent in this prototype: who is told, and how fast, is for the care team to decide.</a:t>
+            </a:r>
+          </a:p>
+        </p:txBody>
+      </p:sp>
+      <p:sp>
+        <p:nvSpPr>
+          <p:cNvPr id="9" name="Text: Asking to double a dose goes to safety, "/>
+          <p:cNvSpPr txBox="1"/>
+          <p:nvPr/>
+        </p:nvSpPr>
+        <p:spPr>
+          <a:xfrm>
+            <a:off x="876300" y="4998541"/>
+            <a:ext cx="5163312" cy="568920"/>
+          </a:xfrm>
+          <a:prstGeom prst="rect">
+            <a:avLst/>
+          </a:prstGeom>
+          <a:noFill/>
+        </p:spPr>
+        <p:txBody>
+          <a:bodyPr wrap="square" anchor="t" lIns="0" rIns="0" tIns="0" bIns="0"/>
+          <a:lstStyle/>
+          <a:p>
+            <a:pPr algn="l">
+              <a:lnSpc>
+                <a:spcPts val="2240"/>
+              </a:lnSpc>
+            </a:pPr>
+            <a:r>
+              <a:rPr sz="1600" b="0">
+                <a:solidFill>
+                  <a:srgbClr val="2A2320"/>
+                </a:solidFill>
+                <a:latin typeface="Nunito"/>
+              </a:rPr>
               <a:t>Asking to double a dose goes to safety, not to an answer.</a:t>
             </a:r>
           </a:p>
@@ -5392,7 +5429,81 @@
       </p:sp>
       <p:sp>
         <p:nvSpPr>
-          <p:cNvPr id="9" name="Text: Healthcare track · Challenge Statement 2"/>
+          <p:cNvPr id="10" name="Text: The example, masked"/>
+          <p:cNvSpPr txBox="1"/>
+          <p:nvPr/>
+        </p:nvSpPr>
+        <p:spPr>
+          <a:xfrm>
+            <a:off x="6343650" y="5392539"/>
+            <a:ext cx="1834896" cy="248920"/>
+          </a:xfrm>
+          <a:prstGeom prst="rect">
+            <a:avLst/>
+          </a:prstGeom>
+          <a:noFill/>
+        </p:spPr>
+        <p:txBody>
+          <a:bodyPr wrap="square" anchor="t" lIns="0" rIns="0" tIns="0" bIns="0"/>
+          <a:lstStyle/>
+          <a:p>
+            <a:pPr algn="l">
+              <a:lnSpc>
+                <a:spcPts val="1960"/>
+              </a:lnSpc>
+            </a:pPr>
+            <a:r>
+              <a:rPr sz="1400" b="0">
+                <a:solidFill>
+                  <a:srgbClr val="4A413B"/>
+                </a:solidFill>
+                <a:latin typeface="Nunito"/>
+              </a:rPr>
+              <a:t>The example, masked</a:t>
+            </a:r>
+          </a:p>
+        </p:txBody>
+      </p:sp>
+      <p:sp>
+        <p:nvSpPr>
+          <p:cNvPr id="11" name="Text: Safety takes over"/>
+          <p:cNvSpPr txBox="1"/>
+          <p:nvPr/>
+        </p:nvSpPr>
+        <p:spPr>
+          <a:xfrm>
+            <a:off x="8966200" y="5392539"/>
+            <a:ext cx="1451864" cy="248920"/>
+          </a:xfrm>
+          <a:prstGeom prst="rect">
+            <a:avLst/>
+          </a:prstGeom>
+          <a:noFill/>
+        </p:spPr>
+        <p:txBody>
+          <a:bodyPr wrap="square" anchor="t" lIns="0" rIns="0" tIns="0" bIns="0"/>
+          <a:lstStyle/>
+          <a:p>
+            <a:pPr algn="l">
+              <a:lnSpc>
+                <a:spcPts val="1960"/>
+              </a:lnSpc>
+            </a:pPr>
+            <a:r>
+              <a:rPr sz="1400" b="0">
+                <a:solidFill>
+                  <a:srgbClr val="4A413B"/>
+                </a:solidFill>
+                <a:latin typeface="Nunito"/>
+              </a:rPr>
+              <a:t>Safety takes over</a:t>
+            </a:r>
+          </a:p>
+        </p:txBody>
+      </p:sp>
+      <p:sp>
+        <p:nvSpPr>
+          <p:cNvPr id="12" name="Text: Healthcare track · Challenge Statement 2"/>
           <p:cNvSpPr txBox="1"/>
           <p:nvPr/>
         </p:nvSpPr>
@@ -5429,7 +5540,7 @@
       </p:sp>
       <p:sp>
         <p:nvSpPr>
-          <p:cNvPr id="10" name="Text: Synthetic demo data · aura-health.makode"/>
+          <p:cNvPr id="13" name="Text: Synthetic demo data · aura-health.makode"/>
           <p:cNvSpPr txBox="1"/>
           <p:nvPr/>
         </p:nvSpPr>
@@ -9917,14 +10028,14 @@
       </p:sp>
       <p:sp>
         <p:nvSpPr>
-          <p:cNvPr id="4" name="Text: SOMETHING CHANGES"/>
+          <p:cNvPr id="4" name="Text: READY FOR THE APPOINTMENT"/>
           <p:cNvSpPr txBox="1"/>
           <p:nvPr/>
         </p:nvSpPr>
         <p:spPr>
           <a:xfrm>
             <a:off x="609600" y="952500"/>
-            <a:ext cx="3987800" cy="203200"/>
+            <a:ext cx="4780280" cy="203200"/>
           </a:xfrm>
           <a:prstGeom prst="rect">
             <a:avLst/>
@@ -9947,21 +10058,21 @@
                 </a:solidFill>
                 <a:latin typeface="Nunito"/>
               </a:rPr>
-              <a:t>SOMETHING CHANGES</a:t>
-            </a:r>
-          </a:p>
-        </p:txBody>
-      </p:sp>
-      <p:sp>
-        <p:nvSpPr>
-          <p:cNvPr id="5" name="Text: A simulated three-day flu"/>
+              <a:t>READY FOR THE APPOINTMENT</a:t>
+            </a:r>
+          </a:p>
+        </p:txBody>
+      </p:sp>
+      <p:sp>
+        <p:nvSpPr>
+          <p:cNvPr id="5" name="Text: Everything for the visit, in one place"/>
           <p:cNvSpPr txBox="1"/>
           <p:nvPr/>
         </p:nvSpPr>
         <p:spPr>
           <a:xfrm>
             <a:off x="609600" y="1384300"/>
-            <a:ext cx="3987800" cy="810220"/>
+            <a:ext cx="4780280" cy="810220"/>
           </a:xfrm>
           <a:prstGeom prst="rect">
             <a:avLst/>
@@ -9984,21 +10095,21 @@
                 </a:solidFill>
                 <a:latin typeface="Nunito"/>
               </a:rPr>
-              <a:t>A simulated three-day flu</a:t>
-            </a:r>
-          </a:p>
-        </p:txBody>
-      </p:sp>
-      <p:sp>
-        <p:nvSpPr>
-          <p:cNvPr id="6" name="Text: AURA notices resting heart rate is highe"/>
+              <a:t>Everything for the visit, in one place</a:t>
+            </a:r>
+          </a:p>
+        </p:txBody>
+      </p:sp>
+      <p:sp>
+        <p:nvSpPr>
+          <p:cNvPr id="6" name="Text: What changed, when, and the missed dose "/>
           <p:cNvSpPr txBox="1"/>
           <p:nvPr/>
         </p:nvSpPr>
         <p:spPr>
           <a:xfrm>
             <a:off x="609600" y="2448520"/>
-            <a:ext cx="3987800" cy="995362"/>
+            <a:ext cx="4780280" cy="497681"/>
           </a:xfrm>
           <a:prstGeom prst="rect">
             <a:avLst/>
@@ -10021,80 +10132,44 @@
                 </a:solidFill>
                 <a:latin typeface="Nunito"/>
               </a:rPr>
-              <a:t>AURA notices resting heart rate is higher than in the person's </a:t>
-            </a:r>
-            <a:r>
-              <a:rPr sz="1400" b="1">
+              <a:t>What changed, when, and the missed dose with its reason, ready to discuss with the doctor or pharmacist.</a:t>
+            </a:r>
+          </a:p>
+        </p:txBody>
+      </p:sp>
+      <p:sp>
+        <p:nvSpPr>
+          <p:cNvPr id="7" name="Text: Nothing is sent automatically · Not sent"/>
+          <p:cNvSpPr txBox="1"/>
+          <p:nvPr/>
+        </p:nvSpPr>
+        <p:spPr>
+          <a:xfrm>
+            <a:off x="787400" y="5394027"/>
+            <a:ext cx="3175508" cy="222250"/>
+          </a:xfrm>
+          <a:prstGeom prst="rect">
+            <a:avLst/>
+          </a:prstGeom>
+          <a:noFill/>
+        </p:spPr>
+        <p:txBody>
+          <a:bodyPr wrap="square" anchor="t" lIns="0" rIns="0" tIns="0" bIns="0"/>
+          <a:lstStyle/>
+          <a:p>
+            <a:pPr algn="l">
+              <a:lnSpc>
+                <a:spcPts val="1560"/>
+              </a:lnSpc>
+            </a:pPr>
+            <a:r>
+              <a:rPr sz="1300" b="1">
                 <a:solidFill>
                   <a:srgbClr val="2A2320"/>
                 </a:solidFill>
                 <a:latin typeface="Nunito"/>
               </a:rPr>
-              <a:t>recent</a:t>
-            </a:r>
-            <a:r>
-              <a:rPr sz="1400" b="0">
-                <a:solidFill>
-                  <a:srgbClr val="4A413B"/>
-                </a:solidFill>
-                <a:latin typeface="Nunito"/>
-              </a:rPr>
-              <a:t> records, and says exactly that: a recent change, not a change from their usual.</a:t>
-            </a:r>
-          </a:p>
-        </p:txBody>
-      </p:sp>
-      <p:sp>
-        <p:nvSpPr>
-          <p:cNvPr id="7" name="Text: When a change shows up, it offers a smal"/>
-          <p:cNvSpPr txBox="1"/>
-          <p:nvPr/>
-        </p:nvSpPr>
-        <p:spPr>
-          <a:xfrm>
-            <a:off x="609600" y="3583582"/>
-            <a:ext cx="3987800" cy="497681"/>
-          </a:xfrm>
-          <a:prstGeom prst="rect">
-            <a:avLst/>
-          </a:prstGeom>
-          <a:noFill/>
-        </p:spPr>
-        <p:txBody>
-          <a:bodyPr wrap="square" anchor="t" lIns="0" rIns="0" tIns="0" bIns="0"/>
-          <a:lstStyle/>
-          <a:p>
-            <a:pPr algn="l">
-              <a:lnSpc>
-                <a:spcPts val="1960"/>
-              </a:lnSpc>
-            </a:pPr>
-            <a:r>
-              <a:rPr sz="1400" b="0">
-                <a:solidFill>
-                  <a:srgbClr val="4A413B"/>
-                </a:solidFill>
-                <a:latin typeface="Nunito"/>
-              </a:rPr>
-              <a:t>When a change shows up, it offers </a:t>
-            </a:r>
-            <a:r>
-              <a:rPr sz="1400" b="1">
-                <a:solidFill>
-                  <a:srgbClr val="2A2320"/>
-                </a:solidFill>
-                <a:latin typeface="Nunito"/>
-              </a:rPr>
-              <a:t>a small idea for today</a:t>
-            </a:r>
-            <a:r>
-              <a:rPr sz="1400" b="0">
-                <a:solidFill>
-                  <a:srgbClr val="4A413B"/>
-                </a:solidFill>
-                <a:latin typeface="Nunito"/>
-              </a:rPr>
-              <a:t>. Optional, never about medication.</a:t>
+              <a:t>Nothing is sent automatically · Not sent</a:t>
             </a:r>
           </a:p>
         </p:txBody>
@@ -10254,14 +10329,14 @@
       </p:sp>
       <p:sp>
         <p:nvSpPr>
-          <p:cNvPr id="4" name="Text: READY FOR THE APPOINTMENT"/>
+          <p:cNvPr id="4" name="Text: WHAT THE CLINICIAN SEES · THE AGENT AT W"/>
           <p:cNvSpPr txBox="1"/>
           <p:nvPr/>
         </p:nvSpPr>
         <p:spPr>
           <a:xfrm>
             <a:off x="609600" y="952500"/>
-            <a:ext cx="4780280" cy="203200"/>
+            <a:ext cx="11437112" cy="203200"/>
           </a:xfrm>
           <a:prstGeom prst="rect">
             <a:avLst/>
@@ -10284,58 +10359,58 @@
                 </a:solidFill>
                 <a:latin typeface="Nunito"/>
               </a:rPr>
-              <a:t>READY FOR THE APPOINTMENT</a:t>
-            </a:r>
-          </a:p>
-        </p:txBody>
-      </p:sp>
-      <p:sp>
-        <p:nvSpPr>
-          <p:cNvPr id="5" name="Text: Everything for the visit, in one place"/>
-          <p:cNvSpPr txBox="1"/>
-          <p:nvPr/>
-        </p:nvSpPr>
-        <p:spPr>
-          <a:xfrm>
-            <a:off x="609600" y="1384300"/>
-            <a:ext cx="4780280" cy="810220"/>
-          </a:xfrm>
-          <a:prstGeom prst="rect">
-            <a:avLst/>
-          </a:prstGeom>
-          <a:noFill/>
-        </p:spPr>
-        <p:txBody>
-          <a:bodyPr wrap="square" anchor="t" lIns="0" rIns="0" tIns="0" bIns="0"/>
-          <a:lstStyle/>
-          <a:p>
-            <a:pPr algn="l">
-              <a:lnSpc>
-                <a:spcPts val="3190"/>
-              </a:lnSpc>
-            </a:pPr>
-            <a:r>
-              <a:rPr sz="2900" b="1" spc="-44">
+              <a:t>WHAT THE CLINICIAN SEES · THE AGENT AT WORK</a:t>
+            </a:r>
+          </a:p>
+        </p:txBody>
+      </p:sp>
+      <p:sp>
+        <p:nvSpPr>
+          <p:cNvPr id="5" name="Text: It decides what to look at, cites every "/>
+          <p:cNvSpPr txBox="1"/>
+          <p:nvPr/>
+        </p:nvSpPr>
+        <p:spPr>
+          <a:xfrm>
+            <a:off x="609600" y="1244600"/>
+            <a:ext cx="11437112" cy="349250"/>
+          </a:xfrm>
+          <a:prstGeom prst="rect">
+            <a:avLst/>
+          </a:prstGeom>
+          <a:noFill/>
+        </p:spPr>
+        <p:txBody>
+          <a:bodyPr wrap="square" anchor="t" lIns="0" rIns="0" tIns="0" bIns="0"/>
+          <a:lstStyle/>
+          <a:p>
+            <a:pPr algn="l">
+              <a:lnSpc>
+                <a:spcPts val="2750"/>
+              </a:lnSpc>
+            </a:pPr>
+            <a:r>
+              <a:rPr sz="2500" b="1" spc="-38">
                 <a:solidFill>
                   <a:srgbClr val="2A2320"/>
                 </a:solidFill>
                 <a:latin typeface="Nunito"/>
               </a:rPr>
-              <a:t>Everything for the visit, in one place</a:t>
-            </a:r>
-          </a:p>
-        </p:txBody>
-      </p:sp>
-      <p:sp>
-        <p:nvSpPr>
-          <p:cNvPr id="6" name="Text: What changed, when, and the missed dose "/>
-          <p:cNvSpPr txBox="1"/>
-          <p:nvPr/>
-        </p:nvSpPr>
-        <p:spPr>
-          <a:xfrm>
-            <a:off x="609600" y="2448520"/>
-            <a:ext cx="4780280" cy="497681"/>
+              <a:t>It decides what to look at, cites every statement, and is checked</a:t>
+            </a:r>
+          </a:p>
+        </p:txBody>
+      </p:sp>
+      <p:sp>
+        <p:nvSpPr>
+          <p:cNvPr id="6" name="Text: What changed and when, with exact values"/>
+          <p:cNvSpPr txBox="1"/>
+          <p:nvPr/>
+        </p:nvSpPr>
+        <p:spPr>
+          <a:xfrm>
+            <a:off x="609600" y="4486275"/>
+            <a:ext cx="4251960" cy="497681"/>
           </a:xfrm>
           <a:prstGeom prst="rect">
             <a:avLst/>
@@ -10358,34 +10433,34 @@
                 </a:solidFill>
                 <a:latin typeface="Nunito"/>
               </a:rPr>
-              <a:t>What changed, when, and the missed dose with its reason, ready to discuss with the doctor or pharmacist.</a:t>
-            </a:r>
-          </a:p>
-        </p:txBody>
-      </p:sp>
-      <p:sp>
-        <p:nvSpPr>
-          <p:cNvPr id="7" name="Text: Nothing is sent automatically · Not sent"/>
-          <p:cNvSpPr txBox="1"/>
-          <p:nvPr/>
-        </p:nvSpPr>
-        <p:spPr>
-          <a:xfrm>
-            <a:off x="787400" y="5394027"/>
-            <a:ext cx="3175508" cy="222250"/>
-          </a:xfrm>
-          <a:prstGeom prst="rect">
-            <a:avLst/>
-          </a:prstGeom>
-          <a:noFill/>
-        </p:spPr>
-        <p:txBody>
-          <a:bodyPr wrap="square" anchor="t" lIns="0" rIns="0" tIns="0" bIns="0"/>
-          <a:lstStyle/>
-          <a:p>
-            <a:pPr algn="l">
-              <a:lnSpc>
-                <a:spcPts val="1560"/>
+              <a:t>What changed and when, with exact values and sources.</a:t>
+            </a:r>
+          </a:p>
+        </p:txBody>
+      </p:sp>
+      <p:sp>
+        <p:nvSpPr>
+          <p:cNvPr id="7" name="Text: How AURA looked: which records it read, "/>
+          <p:cNvSpPr txBox="1"/>
+          <p:nvPr/>
+        </p:nvSpPr>
+        <p:spPr>
+          <a:xfrm>
+            <a:off x="5099050" y="4826000"/>
+            <a:ext cx="6801104" cy="668535"/>
+          </a:xfrm>
+          <a:prstGeom prst="rect">
+            <a:avLst/>
+          </a:prstGeom>
+          <a:noFill/>
+        </p:spPr>
+        <p:txBody>
+          <a:bodyPr wrap="square" anchor="t" lIns="0" rIns="0" tIns="0" bIns="0"/>
+          <a:lstStyle/>
+          <a:p>
+            <a:pPr algn="l">
+              <a:lnSpc>
+                <a:spcPts val="1755"/>
               </a:lnSpc>
             </a:pPr>
             <a:r>
@@ -10395,7 +10470,16 @@
                 </a:solidFill>
                 <a:latin typeface="Nunito"/>
               </a:rPr>
-              <a:t>Nothing is sent automatically · Not sent</a:t>
+              <a:t>How AURA looked</a:t>
+            </a:r>
+            <a:r>
+              <a:rPr sz="1300" b="0">
+                <a:solidFill>
+                  <a:srgbClr val="2A2320"/>
+                </a:solidFill>
+                <a:latin typeface="Nunito"/>
+              </a:rPr>
+              <a:t>: which records it read, then “A second check reviewed 3 statements; all supported”. It can only read; it never changes the record or the treatment.</a:t>
             </a:r>
           </a:p>
         </p:txBody>
@@ -10555,14 +10639,14 @@
       </p:sp>
       <p:sp>
         <p:nvSpPr>
-          <p:cNvPr id="4" name="Text: WHAT THE CLINICIAN SEES · THE AGENT AT W"/>
+          <p:cNvPr id="4" name="Text: SOMETHING CHANGES"/>
           <p:cNvSpPr txBox="1"/>
           <p:nvPr/>
         </p:nvSpPr>
         <p:spPr>
           <a:xfrm>
             <a:off x="609600" y="952500"/>
-            <a:ext cx="11437112" cy="203200"/>
+            <a:ext cx="3987800" cy="203200"/>
           </a:xfrm>
           <a:prstGeom prst="rect">
             <a:avLst/>
@@ -10585,58 +10669,58 @@
                 </a:solidFill>
                 <a:latin typeface="Nunito"/>
               </a:rPr>
-              <a:t>WHAT THE CLINICIAN SEES · THE AGENT AT WORK</a:t>
-            </a:r>
-          </a:p>
-        </p:txBody>
-      </p:sp>
-      <p:sp>
-        <p:nvSpPr>
-          <p:cNvPr id="5" name="Text: It decides what to look at, cites every "/>
-          <p:cNvSpPr txBox="1"/>
-          <p:nvPr/>
-        </p:nvSpPr>
-        <p:spPr>
-          <a:xfrm>
-            <a:off x="609600" y="1244600"/>
-            <a:ext cx="11437112" cy="349250"/>
-          </a:xfrm>
-          <a:prstGeom prst="rect">
-            <a:avLst/>
-          </a:prstGeom>
-          <a:noFill/>
-        </p:spPr>
-        <p:txBody>
-          <a:bodyPr wrap="square" anchor="t" lIns="0" rIns="0" tIns="0" bIns="0"/>
-          <a:lstStyle/>
-          <a:p>
-            <a:pPr algn="l">
-              <a:lnSpc>
-                <a:spcPts val="2750"/>
-              </a:lnSpc>
-            </a:pPr>
-            <a:r>
-              <a:rPr sz="2500" b="1" spc="-38">
+              <a:t>SOMETHING CHANGES</a:t>
+            </a:r>
+          </a:p>
+        </p:txBody>
+      </p:sp>
+      <p:sp>
+        <p:nvSpPr>
+          <p:cNvPr id="5" name="Text: A simulated three-day flu"/>
+          <p:cNvSpPr txBox="1"/>
+          <p:nvPr/>
+        </p:nvSpPr>
+        <p:spPr>
+          <a:xfrm>
+            <a:off x="609600" y="1384300"/>
+            <a:ext cx="3987800" cy="810220"/>
+          </a:xfrm>
+          <a:prstGeom prst="rect">
+            <a:avLst/>
+          </a:prstGeom>
+          <a:noFill/>
+        </p:spPr>
+        <p:txBody>
+          <a:bodyPr wrap="square" anchor="t" lIns="0" rIns="0" tIns="0" bIns="0"/>
+          <a:lstStyle/>
+          <a:p>
+            <a:pPr algn="l">
+              <a:lnSpc>
+                <a:spcPts val="3190"/>
+              </a:lnSpc>
+            </a:pPr>
+            <a:r>
+              <a:rPr sz="2900" b="1" spc="-44">
                 <a:solidFill>
                   <a:srgbClr val="2A2320"/>
                 </a:solidFill>
                 <a:latin typeface="Nunito"/>
               </a:rPr>
-              <a:t>It decides what to look at, cites every statement, and is checked</a:t>
-            </a:r>
-          </a:p>
-        </p:txBody>
-      </p:sp>
-      <p:sp>
-        <p:nvSpPr>
-          <p:cNvPr id="6" name="Text: What changed and when, with exact values"/>
-          <p:cNvSpPr txBox="1"/>
-          <p:nvPr/>
-        </p:nvSpPr>
-        <p:spPr>
-          <a:xfrm>
-            <a:off x="609600" y="4486275"/>
-            <a:ext cx="4251960" cy="497681"/>
+              <a:t>A simulated three-day flu</a:t>
+            </a:r>
+          </a:p>
+        </p:txBody>
+      </p:sp>
+      <p:sp>
+        <p:nvSpPr>
+          <p:cNvPr id="6" name="Text: AURA notices resting heart rate is highe"/>
+          <p:cNvSpPr txBox="1"/>
+          <p:nvPr/>
+        </p:nvSpPr>
+        <p:spPr>
+          <a:xfrm>
+            <a:off x="609600" y="2448520"/>
+            <a:ext cx="3987800" cy="995362"/>
           </a:xfrm>
           <a:prstGeom prst="rect">
             <a:avLst/>
@@ -10659,53 +10743,80 @@
                 </a:solidFill>
                 <a:latin typeface="Nunito"/>
               </a:rPr>
-              <a:t>What changed and when, with exact values and sources.</a:t>
-            </a:r>
-          </a:p>
-        </p:txBody>
-      </p:sp>
-      <p:sp>
-        <p:nvSpPr>
-          <p:cNvPr id="7" name="Text: How AURA looked: which records it read, "/>
-          <p:cNvSpPr txBox="1"/>
-          <p:nvPr/>
-        </p:nvSpPr>
-        <p:spPr>
-          <a:xfrm>
-            <a:off x="5099050" y="4572000"/>
-            <a:ext cx="6801104" cy="668535"/>
-          </a:xfrm>
-          <a:prstGeom prst="rect">
-            <a:avLst/>
-          </a:prstGeom>
-          <a:noFill/>
-        </p:spPr>
-        <p:txBody>
-          <a:bodyPr wrap="square" anchor="t" lIns="0" rIns="0" tIns="0" bIns="0"/>
-          <a:lstStyle/>
-          <a:p>
-            <a:pPr algn="l">
-              <a:lnSpc>
-                <a:spcPts val="1755"/>
-              </a:lnSpc>
-            </a:pPr>
-            <a:r>
-              <a:rPr sz="1300" b="1">
+              <a:t>AURA notices resting heart rate is higher than in the person's </a:t>
+            </a:r>
+            <a:r>
+              <a:rPr sz="1400" b="1">
                 <a:solidFill>
                   <a:srgbClr val="2A2320"/>
                 </a:solidFill>
                 <a:latin typeface="Nunito"/>
               </a:rPr>
-              <a:t>How AURA looked</a:t>
-            </a:r>
-            <a:r>
-              <a:rPr sz="1300" b="0">
+              <a:t>recent</a:t>
+            </a:r>
+            <a:r>
+              <a:rPr sz="1400" b="0">
+                <a:solidFill>
+                  <a:srgbClr val="4A413B"/>
+                </a:solidFill>
+                <a:latin typeface="Nunito"/>
+              </a:rPr>
+              <a:t> records, and says exactly that: a recent change, not a change from their usual.</a:t>
+            </a:r>
+          </a:p>
+        </p:txBody>
+      </p:sp>
+      <p:sp>
+        <p:nvSpPr>
+          <p:cNvPr id="7" name="Text: When a change shows up, it offers a smal"/>
+          <p:cNvSpPr txBox="1"/>
+          <p:nvPr/>
+        </p:nvSpPr>
+        <p:spPr>
+          <a:xfrm>
+            <a:off x="609600" y="3583582"/>
+            <a:ext cx="3987800" cy="497681"/>
+          </a:xfrm>
+          <a:prstGeom prst="rect">
+            <a:avLst/>
+          </a:prstGeom>
+          <a:noFill/>
+        </p:spPr>
+        <p:txBody>
+          <a:bodyPr wrap="square" anchor="t" lIns="0" rIns="0" tIns="0" bIns="0"/>
+          <a:lstStyle/>
+          <a:p>
+            <a:pPr algn="l">
+              <a:lnSpc>
+                <a:spcPts val="1960"/>
+              </a:lnSpc>
+            </a:pPr>
+            <a:r>
+              <a:rPr sz="1400" b="0">
+                <a:solidFill>
+                  <a:srgbClr val="4A413B"/>
+                </a:solidFill>
+                <a:latin typeface="Nunito"/>
+              </a:rPr>
+              <a:t>When a change shows up, it offers </a:t>
+            </a:r>
+            <a:r>
+              <a:rPr sz="1400" b="1">
                 <a:solidFill>
                   <a:srgbClr val="2A2320"/>
                 </a:solidFill>
                 <a:latin typeface="Nunito"/>
               </a:rPr>
-              <a:t>: which records it read, then “A second check reviewed 10 statements; 1 removed as unsupported”. It can only read; it never changes the record or the treatment.</a:t>
+              <a:t>a small idea for today</a:t>
+            </a:r>
+            <a:r>
+              <a:rPr sz="1400" b="0">
+                <a:solidFill>
+                  <a:srgbClr val="4A413B"/>
+                </a:solidFill>
+                <a:latin typeface="Nunito"/>
+              </a:rPr>
+              <a:t>. Optional, never about medication.</a:t>
             </a:r>
           </a:p>
         </p:txBody>

</xml_diff>

<commit_message>
docs: native PowerPoint diagrams with glued connectors (slides 11-13); history PDF builder; manifest for cover/history uploads
Co-Authored-By: Claude Opus 5.5 <noreply@anthropic.com>
</commit_message>
<xml_diff>
--- a/docs/submission/assets/aura-health-deck.pptx
+++ b/docs/submission/assets/aura-health-deck.pptx
@@ -5586,6 +5586,14 @@
 <file path=ppt/slides/slide11.xml><?xml version="1.0" encoding="utf-8"?>
 <p:sld xmlns:a="http://schemas.openxmlformats.org/drawingml/2006/main" xmlns:p="http://schemas.openxmlformats.org/presentationml/2006/main" xmlns:r="http://schemas.openxmlformats.org/officeDocument/2006/relationships">
   <p:cSld>
+    <p:bg>
+      <p:bgPr>
+        <a:solidFill>
+          <a:srgbClr val="FBFAF7"/>
+        </a:solidFill>
+        <a:effectLst/>
+      </p:bgPr>
+    </p:bg>
     <p:spTree>
       <p:nvGrpSpPr>
         <p:cNvPr id="1" name=""/>
@@ -5593,30 +5601,1283 @@
         <p:nvPr/>
       </p:nvGrpSpPr>
       <p:grpSpPr/>
-      <p:pic>
-        <p:nvPicPr>
-          <p:cNvPr id="2" name="Background (art, cards, screenshots)" descr="image.jpg"/>
-          <p:cNvPicPr>
-            <a:picLocks noChangeAspect="1"/>
-          </p:cNvPicPr>
-          <p:nvPr/>
-        </p:nvPicPr>
-        <p:blipFill>
-          <a:blip r:embed="rId2"/>
-          <a:stretch>
-            <a:fillRect/>
-          </a:stretch>
-        </p:blipFill>
-        <p:spPr>
-          <a:xfrm>
-            <a:off x="0" y="0"/>
-            <a:ext cx="12192000" cy="6858000"/>
-          </a:xfrm>
-          <a:prstGeom prst="rect">
-            <a:avLst/>
-          </a:prstGeom>
-        </p:spPr>
-      </p:pic>
+      <p:sp>
+        <p:nvSpPr>
+          <p:cNvPr id="2" name="Text: AURA Health · system architecture"/>
+          <p:cNvSpPr txBox="1"/>
+          <p:nvPr/>
+        </p:nvSpPr>
+        <p:spPr>
+          <a:xfrm>
+            <a:off x="508000" y="292100"/>
+            <a:ext cx="11176000" cy="444500"/>
+          </a:xfrm>
+          <a:prstGeom prst="rect">
+            <a:avLst/>
+          </a:prstGeom>
+          <a:noFill/>
+        </p:spPr>
+        <p:txBody>
+          <a:bodyPr wrap="square" anchor="t" lIns="0" rIns="0" tIns="0" bIns="0"/>
+          <a:lstStyle/>
+          <a:p>
+            <a:pPr algn="l">
+              <a:spcAft>
+                <a:spcPts val="1215"/>
+              </a:spcAft>
+            </a:pPr>
+            <a:r>
+              <a:rPr sz="2700" b="1">
+                <a:solidFill>
+                  <a:srgbClr val="2A2320"/>
+                </a:solidFill>
+                <a:latin typeface="Nunito"/>
+              </a:rPr>
+              <a:t>AURA Health · system architecture</a:t>
+            </a:r>
+          </a:p>
+        </p:txBody>
+      </p:sp>
+      <p:sp>
+        <p:nvSpPr>
+          <p:cNvPr id="3" name="Text: Challenge 2 · Scenario 1: mental health "/>
+          <p:cNvSpPr txBox="1"/>
+          <p:nvPr/>
+        </p:nvSpPr>
+        <p:spPr>
+          <a:xfrm>
+            <a:off x="508000" y="774700"/>
+            <a:ext cx="11176000" cy="254000"/>
+          </a:xfrm>
+          <a:prstGeom prst="rect">
+            <a:avLst/>
+          </a:prstGeom>
+          <a:noFill/>
+        </p:spPr>
+        <p:txBody>
+          <a:bodyPr wrap="square" anchor="t" lIns="0" rIns="0" tIns="0" bIns="0"/>
+          <a:lstStyle/>
+          <a:p>
+            <a:pPr algn="l">
+              <a:spcAft>
+                <a:spcPts val="585"/>
+              </a:spcAft>
+            </a:pPr>
+            <a:r>
+              <a:rPr sz="1300" b="0">
+                <a:solidFill>
+                  <a:srgbClr val="6B6258"/>
+                </a:solidFill>
+                <a:latin typeface="Nunito"/>
+              </a:rPr>
+              <a:t>Challenge 2 · Scenario 1: mental health maintenance for working adults on antidepressants</a:t>
+            </a:r>
+          </a:p>
+        </p:txBody>
+      </p:sp>
+      <p:sp>
+        <p:nvSpPr>
+          <p:cNvPr id="4" name="Box: Web experience"/>
+          <p:cNvSpPr/>
+          <p:nvPr/>
+        </p:nvSpPr>
+        <p:spPr>
+          <a:xfrm>
+            <a:off x="508000" y="1206500"/>
+            <a:ext cx="2286000" cy="3175000"/>
+          </a:xfrm>
+          <a:prstGeom prst="roundRect">
+            <a:avLst>
+              <a:gd name="adj" fmla="val 6111"/>
+            </a:avLst>
+          </a:prstGeom>
+          <a:solidFill>
+            <a:srgbClr val="FFFFFF"/>
+          </a:solidFill>
+          <a:ln w="15875">
+            <a:solidFill>
+              <a:srgbClr val="CFC8BD"/>
+            </a:solidFill>
+            <a:prstDash val="lgDash"/>
+          </a:ln>
+        </p:spPr>
+        <p:txBody>
+          <a:bodyPr rtlCol="0" anchor="t" wrap="square" lIns="152400" rIns="152400" tIns="152400" bIns="152400"/>
+          <a:lstStyle/>
+          <a:p>
+            <a:pPr algn="l">
+              <a:spcAft>
+                <a:spcPts val="630"/>
+              </a:spcAft>
+            </a:pPr>
+            <a:r>
+              <a:rPr sz="1400" b="1">
+                <a:solidFill>
+                  <a:srgbClr val="2A2320"/>
+                </a:solidFill>
+                <a:latin typeface="Nunito"/>
+              </a:rPr>
+              <a:t>Web experience</a:t>
+            </a:r>
+          </a:p>
+        </p:txBody>
+      </p:sp>
+      <p:sp>
+        <p:nvSpPr>
+          <p:cNvPr id="5" name="Box: Python app · owns the state"/>
+          <p:cNvSpPr/>
+          <p:nvPr/>
+        </p:nvSpPr>
+        <p:spPr>
+          <a:xfrm>
+            <a:off x="3302000" y="1206500"/>
+            <a:ext cx="3810000" cy="3175000"/>
+          </a:xfrm>
+          <a:prstGeom prst="roundRect">
+            <a:avLst>
+              <a:gd name="adj" fmla="val 4400"/>
+            </a:avLst>
+          </a:prstGeom>
+          <a:solidFill>
+            <a:srgbClr val="FFFFFF"/>
+          </a:solidFill>
+          <a:ln w="15875">
+            <a:solidFill>
+              <a:srgbClr val="CFC8BD"/>
+            </a:solidFill>
+            <a:prstDash val="lgDash"/>
+          </a:ln>
+        </p:spPr>
+        <p:txBody>
+          <a:bodyPr rtlCol="0" anchor="t" wrap="square" lIns="152400" rIns="152400" tIns="152400" bIns="152400"/>
+          <a:lstStyle/>
+          <a:p>
+            <a:pPr algn="l">
+              <a:spcAft>
+                <a:spcPts val="630"/>
+              </a:spcAft>
+            </a:pPr>
+            <a:r>
+              <a:rPr sz="1400" b="1">
+                <a:solidFill>
+                  <a:srgbClr val="2A2320"/>
+                </a:solidFill>
+                <a:latin typeface="Nunito"/>
+              </a:rPr>
+              <a:t>Python app · owns the state</a:t>
+            </a:r>
+          </a:p>
+        </p:txBody>
+      </p:sp>
+      <p:sp>
+        <p:nvSpPr>
+          <p:cNvPr id="6" name="Box: Bounded AI · read-only"/>
+          <p:cNvSpPr/>
+          <p:nvPr/>
+        </p:nvSpPr>
+        <p:spPr>
+          <a:xfrm>
+            <a:off x="7620000" y="1206500"/>
+            <a:ext cx="4064000" cy="3175000"/>
+          </a:xfrm>
+          <a:prstGeom prst="roundRect">
+            <a:avLst>
+              <a:gd name="adj" fmla="val 4400"/>
+            </a:avLst>
+          </a:prstGeom>
+          <a:solidFill>
+            <a:srgbClr val="FFFFFF"/>
+          </a:solidFill>
+          <a:ln w="15875">
+            <a:solidFill>
+              <a:srgbClr val="CFC8BD"/>
+            </a:solidFill>
+            <a:prstDash val="lgDash"/>
+          </a:ln>
+        </p:spPr>
+        <p:txBody>
+          <a:bodyPr rtlCol="0" anchor="t" wrap="square" lIns="152400" rIns="152400" tIns="152400" bIns="152400"/>
+          <a:lstStyle/>
+          <a:p>
+            <a:pPr algn="l">
+              <a:spcAft>
+                <a:spcPts val="630"/>
+              </a:spcAft>
+            </a:pPr>
+            <a:r>
+              <a:rPr sz="1400" b="1">
+                <a:solidFill>
+                  <a:srgbClr val="2A2320"/>
+                </a:solidFill>
+                <a:latin typeface="Nunito"/>
+              </a:rPr>
+              <a:t>Bounded AI · read-only</a:t>
+            </a:r>
+          </a:p>
+        </p:txBody>
+      </p:sp>
+      <p:sp>
+        <p:nvSpPr>
+          <p:cNvPr id="7" name="Box: Patient companion"/>
+          <p:cNvSpPr/>
+          <p:nvPr/>
+        </p:nvSpPr>
+        <p:spPr>
+          <a:xfrm>
+            <a:off x="660400" y="1625600"/>
+            <a:ext cx="1981200" cy="1270000"/>
+          </a:xfrm>
+          <a:prstGeom prst="roundRect">
+            <a:avLst>
+              <a:gd name="adj" fmla="val 11000"/>
+            </a:avLst>
+          </a:prstGeom>
+          <a:solidFill>
+            <a:srgbClr val="F3F0EA"/>
+          </a:solidFill>
+          <a:ln>
+            <a:noFill/>
+          </a:ln>
+        </p:spPr>
+        <p:txBody>
+          <a:bodyPr rtlCol="0" anchor="t" wrap="square" lIns="152400" rIns="152400" tIns="152400" bIns="152400"/>
+          <a:lstStyle/>
+          <a:p>
+            <a:pPr algn="l">
+              <a:spcAft>
+                <a:spcPts val="562"/>
+              </a:spcAft>
+            </a:pPr>
+            <a:r>
+              <a:rPr sz="1250" b="1">
+                <a:solidFill>
+                  <a:srgbClr val="2A2320"/>
+                </a:solidFill>
+                <a:latin typeface="Nunito"/>
+              </a:rPr>
+              <a:t>Patient companion</a:t>
+            </a:r>
+          </a:p>
+          <a:p>
+            <a:pPr algn="l">
+              <a:spcAft>
+                <a:spcPts val="250"/>
+              </a:spcAft>
+            </a:pPr>
+            <a:r>
+              <a:rPr sz="1000" b="0">
+                <a:solidFill>
+                  <a:srgbClr val="2A2320"/>
+                </a:solidFill>
+                <a:latin typeface="Nunito"/>
+              </a:rPr>
+              <a:t>Breath + short recap</a:t>
+            </a:r>
+          </a:p>
+          <a:p>
+            <a:pPr algn="l">
+              <a:spcAft>
+                <a:spcPts val="250"/>
+              </a:spcAft>
+            </a:pPr>
+            <a:r>
+              <a:rPr sz="1000" b="0">
+                <a:solidFill>
+                  <a:srgbClr val="2A2320"/>
+                </a:solidFill>
+                <a:latin typeface="Nunito"/>
+              </a:rPr>
+              <a:t>Today's dose + reasons</a:t>
+            </a:r>
+          </a:p>
+          <a:p>
+            <a:pPr algn="l">
+              <a:spcAft>
+                <a:spcPts val="250"/>
+              </a:spcAft>
+            </a:pPr>
+            <a:r>
+              <a:rPr sz="1000" b="0">
+                <a:solidFill>
+                  <a:srgbClr val="2A2320"/>
+                </a:solidFill>
+                <a:latin typeface="Nunito"/>
+              </a:rPr>
+              <a:t>Medication, Coming up</a:t>
+            </a:r>
+          </a:p>
+        </p:txBody>
+      </p:sp>
+      <p:sp>
+        <p:nvSpPr>
+          <p:cNvPr id="8" name="Box: Clinician view"/>
+          <p:cNvSpPr/>
+          <p:nvPr/>
+        </p:nvSpPr>
+        <p:spPr>
+          <a:xfrm>
+            <a:off x="660400" y="2997200"/>
+            <a:ext cx="1981200" cy="952500"/>
+          </a:xfrm>
+          <a:prstGeom prst="roundRect">
+            <a:avLst>
+              <a:gd name="adj" fmla="val 14666"/>
+            </a:avLst>
+          </a:prstGeom>
+          <a:solidFill>
+            <a:srgbClr val="F3F0EA"/>
+          </a:solidFill>
+          <a:ln>
+            <a:noFill/>
+          </a:ln>
+        </p:spPr>
+        <p:txBody>
+          <a:bodyPr rtlCol="0" anchor="t" wrap="square" lIns="152400" rIns="152400" tIns="152400" bIns="152400"/>
+          <a:lstStyle/>
+          <a:p>
+            <a:pPr algn="l">
+              <a:spcAft>
+                <a:spcPts val="562"/>
+              </a:spcAft>
+            </a:pPr>
+            <a:r>
+              <a:rPr sz="1250" b="1">
+                <a:solidFill>
+                  <a:srgbClr val="2A2320"/>
+                </a:solidFill>
+                <a:latin typeface="Nunito"/>
+              </a:rPr>
+              <a:t>Clinician view</a:t>
+            </a:r>
+          </a:p>
+          <a:p>
+            <a:pPr algn="l">
+              <a:spcAft>
+                <a:spcPts val="250"/>
+              </a:spcAft>
+            </a:pPr>
+            <a:r>
+              <a:rPr sz="1000" b="0">
+                <a:solidFill>
+                  <a:srgbClr val="2A2320"/>
+                </a:solidFill>
+                <a:latin typeface="Nunito"/>
+              </a:rPr>
+              <a:t>Findings with sources</a:t>
+            </a:r>
+          </a:p>
+          <a:p>
+            <a:pPr algn="l">
+              <a:spcAft>
+                <a:spcPts val="250"/>
+              </a:spcAft>
+            </a:pPr>
+            <a:r>
+              <a:rPr sz="1000" b="0">
+                <a:solidFill>
+                  <a:srgbClr val="2A2320"/>
+                </a:solidFill>
+                <a:latin typeface="Nunito"/>
+              </a:rPr>
+              <a:t>Ask about the record</a:t>
+            </a:r>
+          </a:p>
+        </p:txBody>
+      </p:sp>
+      <p:sp>
+        <p:nvSpPr>
+          <p:cNvPr id="9" name="Text: Presentation, not policy"/>
+          <p:cNvSpPr txBox="1"/>
+          <p:nvPr/>
+        </p:nvSpPr>
+        <p:spPr>
+          <a:xfrm>
+            <a:off x="660400" y="4064000"/>
+            <a:ext cx="1981200" cy="254000"/>
+          </a:xfrm>
+          <a:prstGeom prst="rect">
+            <a:avLst/>
+          </a:prstGeom>
+          <a:noFill/>
+        </p:spPr>
+        <p:txBody>
+          <a:bodyPr wrap="square" anchor="t" lIns="0" rIns="0" tIns="0" bIns="0"/>
+          <a:lstStyle/>
+          <a:p>
+            <a:pPr algn="l">
+              <a:spcAft>
+                <a:spcPts val="472"/>
+              </a:spcAft>
+            </a:pPr>
+            <a:r>
+              <a:rPr sz="1050" b="0">
+                <a:solidFill>
+                  <a:srgbClr val="6B6258"/>
+                </a:solidFill>
+                <a:latin typeface="Nunito"/>
+              </a:rPr>
+              <a:t>Presentation, not policy</a:t>
+            </a:r>
+          </a:p>
+        </p:txBody>
+      </p:sp>
+      <p:sp>
+        <p:nvSpPr>
+          <p:cNvPr id="10" name="Box: FastAPI application services"/>
+          <p:cNvSpPr/>
+          <p:nvPr/>
+        </p:nvSpPr>
+        <p:spPr>
+          <a:xfrm>
+            <a:off x="3454400" y="1625600"/>
+            <a:ext cx="3505200" cy="711200"/>
+          </a:xfrm>
+          <a:prstGeom prst="roundRect">
+            <a:avLst>
+              <a:gd name="adj" fmla="val 19642"/>
+            </a:avLst>
+          </a:prstGeom>
+          <a:solidFill>
+            <a:srgbClr val="DCEEF7"/>
+          </a:solidFill>
+          <a:ln>
+            <a:noFill/>
+          </a:ln>
+        </p:spPr>
+        <p:txBody>
+          <a:bodyPr rtlCol="0" anchor="t" wrap="square" lIns="152400" rIns="152400" tIns="152400" bIns="152400"/>
+          <a:lstStyle/>
+          <a:p>
+            <a:pPr algn="l">
+              <a:spcAft>
+                <a:spcPts val="607"/>
+              </a:spcAft>
+            </a:pPr>
+            <a:r>
+              <a:rPr sz="1350" b="1">
+                <a:solidFill>
+                  <a:srgbClr val="2A2320"/>
+                </a:solidFill>
+                <a:latin typeface="Nunito"/>
+              </a:rPr>
+              <a:t>FastAPI application services</a:t>
+            </a:r>
+          </a:p>
+          <a:p>
+            <a:pPr algn="l">
+              <a:spcAft>
+                <a:spcPts val="262"/>
+              </a:spcAft>
+            </a:pPr>
+            <a:r>
+              <a:rPr sz="1050" b="0">
+                <a:solidFill>
+                  <a:srgbClr val="2A2320"/>
+                </a:solidFill>
+                <a:latin typeface="Nunito"/>
+              </a:rPr>
+              <a:t>Consent, atomic events · SQLite repository</a:t>
+            </a:r>
+          </a:p>
+        </p:txBody>
+      </p:sp>
+      <p:sp>
+        <p:nvSpPr>
+          <p:cNvPr id="11" name="Box: Curated medication content"/>
+          <p:cNvSpPr/>
+          <p:nvPr/>
+        </p:nvSpPr>
+        <p:spPr>
+          <a:xfrm>
+            <a:off x="3454400" y="2438400"/>
+            <a:ext cx="3505200" cy="711200"/>
+          </a:xfrm>
+          <a:prstGeom prst="roundRect">
+            <a:avLst>
+              <a:gd name="adj" fmla="val 19642"/>
+            </a:avLst>
+          </a:prstGeom>
+          <a:solidFill>
+            <a:srgbClr val="DCEEF7"/>
+          </a:solidFill>
+          <a:ln>
+            <a:noFill/>
+          </a:ln>
+        </p:spPr>
+        <p:txBody>
+          <a:bodyPr rtlCol="0" anchor="t" wrap="square" lIns="152400" rIns="152400" tIns="152400" bIns="152400"/>
+          <a:lstStyle/>
+          <a:p>
+            <a:pPr algn="l">
+              <a:spcAft>
+                <a:spcPts val="607"/>
+              </a:spcAft>
+            </a:pPr>
+            <a:r>
+              <a:rPr sz="1350" b="1">
+                <a:solidFill>
+                  <a:srgbClr val="2A2320"/>
+                </a:solidFill>
+                <a:latin typeface="Nunito"/>
+              </a:rPr>
+              <a:t>Curated medication content</a:t>
+            </a:r>
+          </a:p>
+          <a:p>
+            <a:pPr algn="l">
+              <a:spcAft>
+                <a:spcPts val="262"/>
+              </a:spcAft>
+            </a:pPr>
+            <a:r>
+              <a:rPr sz="1050" b="0">
+                <a:solidFill>
+                  <a:srgbClr val="2A2320"/>
+                </a:solidFill>
+                <a:latin typeface="Nunito"/>
+              </a:rPr>
+              <a:t>Typed questions: safety first, fixed answers</a:t>
+            </a:r>
+          </a:p>
+        </p:txBody>
+      </p:sp>
+      <p:sp>
+        <p:nvSpPr>
+          <p:cNvPr id="12" name="Box: Safety engine"/>
+          <p:cNvSpPr/>
+          <p:nvPr/>
+        </p:nvSpPr>
+        <p:spPr>
+          <a:xfrm>
+            <a:off x="3454400" y="3251200"/>
+            <a:ext cx="1701800" cy="952500"/>
+          </a:xfrm>
+          <a:prstGeom prst="roundRect">
+            <a:avLst>
+              <a:gd name="adj" fmla="val 14666"/>
+            </a:avLst>
+          </a:prstGeom>
+          <a:solidFill>
+            <a:srgbClr val="FDE3DF"/>
+          </a:solidFill>
+          <a:ln>
+            <a:noFill/>
+          </a:ln>
+        </p:spPr>
+        <p:txBody>
+          <a:bodyPr rtlCol="0" anchor="t" wrap="square" lIns="152400" rIns="152400" tIns="152400" bIns="152400"/>
+          <a:lstStyle/>
+          <a:p>
+            <a:pPr algn="l">
+              <a:spcAft>
+                <a:spcPts val="607"/>
+              </a:spcAft>
+            </a:pPr>
+            <a:r>
+              <a:rPr sz="1350" b="1">
+                <a:solidFill>
+                  <a:srgbClr val="2A2320"/>
+                </a:solidFill>
+                <a:latin typeface="Nunito"/>
+              </a:rPr>
+              <a:t>Safety engine</a:t>
+            </a:r>
+          </a:p>
+          <a:p>
+            <a:pPr algn="l">
+              <a:spcAft>
+                <a:spcPts val="262"/>
+              </a:spcAft>
+            </a:pPr>
+            <a:r>
+              <a:rPr sz="1050" b="0">
+                <a:solidFill>
+                  <a:srgbClr val="2A2320"/>
+                </a:solidFill>
+                <a:latin typeface="Nunito"/>
+              </a:rPr>
+              <a:t>T0–T4, fails closed</a:t>
+            </a:r>
+          </a:p>
+        </p:txBody>
+      </p:sp>
+      <p:sp>
+        <p:nvSpPr>
+          <p:cNvPr id="13" name="Box: Longitudinal"/>
+          <p:cNvSpPr/>
+          <p:nvPr/>
+        </p:nvSpPr>
+        <p:spPr>
+          <a:xfrm>
+            <a:off x="5257800" y="3251200"/>
+            <a:ext cx="1701800" cy="952500"/>
+          </a:xfrm>
+          <a:prstGeom prst="roundRect">
+            <a:avLst>
+              <a:gd name="adj" fmla="val 14666"/>
+            </a:avLst>
+          </a:prstGeom>
+          <a:solidFill>
+            <a:srgbClr val="DCEEF7"/>
+          </a:solidFill>
+          <a:ln>
+            <a:noFill/>
+          </a:ln>
+        </p:spPr>
+        <p:txBody>
+          <a:bodyPr rtlCol="0" anchor="t" wrap="square" lIns="152400" rIns="152400" tIns="152400" bIns="152400"/>
+          <a:lstStyle/>
+          <a:p>
+            <a:pPr algn="l">
+              <a:spcAft>
+                <a:spcPts val="607"/>
+              </a:spcAft>
+            </a:pPr>
+            <a:r>
+              <a:rPr sz="1350" b="1">
+                <a:solidFill>
+                  <a:srgbClr val="2A2320"/>
+                </a:solidFill>
+                <a:latin typeface="Nunito"/>
+              </a:rPr>
+              <a:t>Longitudinal</a:t>
+            </a:r>
+          </a:p>
+          <a:p>
+            <a:pPr algn="l">
+              <a:spcAft>
+                <a:spcPts val="262"/>
+              </a:spcAft>
+            </a:pPr>
+            <a:r>
+              <a:rPr sz="1050" b="0">
+                <a:solidFill>
+                  <a:srgbClr val="2A2320"/>
+                </a:solidFill>
+                <a:latin typeface="Nunito"/>
+              </a:rPr>
+              <a:t>Personal + recent baselines</a:t>
+            </a:r>
+          </a:p>
+        </p:txBody>
+      </p:sp>
+      <p:sp>
+        <p:nvSpPr>
+          <p:cNvPr id="14" name="Box: Aura-Agent + patient-scoped tools"/>
+          <p:cNvSpPr/>
+          <p:nvPr/>
+        </p:nvSpPr>
+        <p:spPr>
+          <a:xfrm>
+            <a:off x="7772400" y="1625600"/>
+            <a:ext cx="3759200" cy="825500"/>
+          </a:xfrm>
+          <a:prstGeom prst="roundRect">
+            <a:avLst>
+              <a:gd name="adj" fmla="val 16923"/>
+            </a:avLst>
+          </a:prstGeom>
+          <a:solidFill>
+            <a:srgbClr val="E8E1F3"/>
+          </a:solidFill>
+          <a:ln>
+            <a:noFill/>
+          </a:ln>
+        </p:spPr>
+        <p:txBody>
+          <a:bodyPr rtlCol="0" anchor="t" wrap="square" lIns="152400" rIns="152400" tIns="152400" bIns="152400"/>
+          <a:lstStyle/>
+          <a:p>
+            <a:pPr algn="l">
+              <a:spcAft>
+                <a:spcPts val="607"/>
+              </a:spcAft>
+            </a:pPr>
+            <a:r>
+              <a:rPr sz="1350" b="1">
+                <a:solidFill>
+                  <a:srgbClr val="2A2320"/>
+                </a:solidFill>
+                <a:latin typeface="Nunito"/>
+              </a:rPr>
+              <a:t>Aura-Agent + patient-scoped tools</a:t>
+            </a:r>
+          </a:p>
+          <a:p>
+            <a:pPr algn="l">
+              <a:spcAft>
+                <a:spcPts val="262"/>
+              </a:spcAft>
+            </a:pPr>
+            <a:r>
+              <a:rPr sz="1050" b="0">
+                <a:solidFill>
+                  <a:srgbClr val="2A2320"/>
+                </a:solidFill>
+                <a:latin typeface="Nunito"/>
+              </a:rPr>
+              <a:t>The model chooses tools, dates and comparisons</a:t>
+            </a:r>
+          </a:p>
+        </p:txBody>
+      </p:sp>
+      <p:sp>
+        <p:nvSpPr>
+          <p:cNvPr id="15" name="Box: Ground → verify → recheck"/>
+          <p:cNvSpPr/>
+          <p:nvPr/>
+        </p:nvSpPr>
+        <p:spPr>
+          <a:xfrm>
+            <a:off x="7772400" y="2832100"/>
+            <a:ext cx="3759200" cy="825500"/>
+          </a:xfrm>
+          <a:prstGeom prst="roundRect">
+            <a:avLst>
+              <a:gd name="adj" fmla="val 16923"/>
+            </a:avLst>
+          </a:prstGeom>
+          <a:solidFill>
+            <a:srgbClr val="E8E1F3"/>
+          </a:solidFill>
+          <a:ln>
+            <a:noFill/>
+          </a:ln>
+        </p:spPr>
+        <p:txBody>
+          <a:bodyPr rtlCol="0" anchor="t" wrap="square" lIns="152400" rIns="152400" tIns="152400" bIns="152400"/>
+          <a:lstStyle/>
+          <a:p>
+            <a:pPr algn="l">
+              <a:spcAft>
+                <a:spcPts val="607"/>
+              </a:spcAft>
+            </a:pPr>
+            <a:r>
+              <a:rPr sz="1350" b="1">
+                <a:solidFill>
+                  <a:srgbClr val="2A2320"/>
+                </a:solidFill>
+                <a:latin typeface="Nunito"/>
+              </a:rPr>
+              <a:t>Ground → verify → recheck</a:t>
+            </a:r>
+          </a:p>
+          <a:p>
+            <a:pPr algn="l">
+              <a:spcAft>
+                <a:spcPts val="262"/>
+              </a:spcAft>
+            </a:pPr>
+            <a:r>
+              <a:rPr sz="1050" b="0">
+                <a:solidFill>
+                  <a:srgbClr val="2A2320"/>
+                </a:solidFill>
+                <a:latin typeface="Nunito"/>
+              </a:rPr>
+              <a:t>Cited answer, or a labelled fallback + trace</a:t>
+            </a:r>
+          </a:p>
+        </p:txBody>
+      </p:sp>
+      <p:sp>
+        <p:nvSpPr>
+          <p:cNvPr id="16" name="Text: Model gateway: provider configurable"/>
+          <p:cNvSpPr txBox="1"/>
+          <p:nvPr/>
+        </p:nvSpPr>
+        <p:spPr>
+          <a:xfrm>
+            <a:off x="7772400" y="3746500"/>
+            <a:ext cx="3759200" cy="635000"/>
+          </a:xfrm>
+          <a:prstGeom prst="rect">
+            <a:avLst/>
+          </a:prstGeom>
+          <a:noFill/>
+        </p:spPr>
+        <p:txBody>
+          <a:bodyPr wrap="square" anchor="t" lIns="0" rIns="0" tIns="0" bIns="0"/>
+          <a:lstStyle/>
+          <a:p>
+            <a:pPr algn="l">
+              <a:spcAft>
+                <a:spcPts val="495"/>
+              </a:spcAft>
+            </a:pPr>
+            <a:r>
+              <a:rPr sz="1100" b="1">
+                <a:solidFill>
+                  <a:srgbClr val="2A2320"/>
+                </a:solidFill>
+                <a:latin typeface="Nunito"/>
+              </a:rPr>
+              <a:t>Model gateway: provider configurable</a:t>
+            </a:r>
+          </a:p>
+          <a:p>
+            <a:pPr algn="l">
+              <a:spcAft>
+                <a:spcPts val="262"/>
+              </a:spcAft>
+            </a:pPr>
+            <a:r>
+              <a:rPr sz="1050" b="0">
+                <a:solidFill>
+                  <a:srgbClr val="6B6258"/>
+                </a:solidFill>
+                <a:latin typeface="Nunito"/>
+              </a:rPr>
+              <a:t>Operator picks model + reasoning level</a:t>
+            </a:r>
+          </a:p>
+          <a:p>
+            <a:pPr algn="l">
+              <a:spcAft>
+                <a:spcPts val="262"/>
+              </a:spcAft>
+            </a:pPr>
+            <a:r>
+              <a:rPr sz="1050" b="0">
+                <a:solidFill>
+                  <a:srgbClr val="6B6258"/>
+                </a:solidFill>
+                <a:latin typeface="Nunito"/>
+              </a:rPr>
+              <a:t>Synthetic data only</a:t>
+            </a:r>
+          </a:p>
+        </p:txBody>
+      </p:sp>
+      <p:sp>
+        <p:nvSpPr>
+          <p:cNvPr id="17" name="Box: Independent safety display"/>
+          <p:cNvSpPr/>
+          <p:nvPr/>
+        </p:nvSpPr>
+        <p:spPr>
+          <a:xfrm>
+            <a:off x="3162300" y="4826000"/>
+            <a:ext cx="2286000" cy="1270000"/>
+          </a:xfrm>
+          <a:prstGeom prst="roundRect">
+            <a:avLst>
+              <a:gd name="adj" fmla="val 11000"/>
+            </a:avLst>
+          </a:prstGeom>
+          <a:solidFill>
+            <a:srgbClr val="FDE3DF"/>
+          </a:solidFill>
+          <a:ln>
+            <a:noFill/>
+          </a:ln>
+        </p:spPr>
+        <p:txBody>
+          <a:bodyPr rtlCol="0" anchor="t" wrap="square" lIns="152400" rIns="152400" tIns="152400" bIns="152400"/>
+          <a:lstStyle/>
+          <a:p>
+            <a:pPr algn="l">
+              <a:spcAft>
+                <a:spcPts val="562"/>
+              </a:spcAft>
+            </a:pPr>
+            <a:r>
+              <a:rPr sz="1250" b="1">
+                <a:solidFill>
+                  <a:srgbClr val="2A2320"/>
+                </a:solidFill>
+                <a:latin typeface="Nunito"/>
+              </a:rPr>
+              <a:t>Independent safety display</a:t>
+            </a:r>
+          </a:p>
+          <a:p>
+            <a:pPr algn="l">
+              <a:spcAft>
+                <a:spcPts val="250"/>
+              </a:spcAft>
+            </a:pPr>
+            <a:r>
+              <a:rPr sz="1000" b="0">
+                <a:solidFill>
+                  <a:srgbClr val="2A2320"/>
+                </a:solidFill>
+                <a:latin typeface="Nunito"/>
+              </a:rPr>
+              <a:t>Pinned resources + fallback</a:t>
+            </a:r>
+          </a:p>
+          <a:p>
+            <a:pPr algn="l">
+              <a:spcAft>
+                <a:spcPts val="250"/>
+              </a:spcAft>
+            </a:pPr>
+            <a:r>
+              <a:rPr sz="1000" b="0">
+                <a:solidFill>
+                  <a:srgbClr val="2A2320"/>
+                </a:solidFill>
+                <a:latin typeface="Nunito"/>
+              </a:rPr>
+              <a:t>Never AI-written</a:t>
+            </a:r>
+          </a:p>
+        </p:txBody>
+      </p:sp>
+      <p:sp>
+        <p:nvSpPr>
+          <p:cNvPr id="18" name="Box: Separate simulation plane"/>
+          <p:cNvSpPr/>
+          <p:nvPr/>
+        </p:nvSpPr>
+        <p:spPr>
+          <a:xfrm>
+            <a:off x="5715000" y="4826000"/>
+            <a:ext cx="2667000" cy="1270000"/>
+          </a:xfrm>
+          <a:prstGeom prst="roundRect">
+            <a:avLst>
+              <a:gd name="adj" fmla="val 11000"/>
+            </a:avLst>
+          </a:prstGeom>
+          <a:solidFill>
+            <a:srgbClr val="FFF0D0"/>
+          </a:solidFill>
+          <a:ln>
+            <a:noFill/>
+          </a:ln>
+        </p:spPr>
+        <p:txBody>
+          <a:bodyPr rtlCol="0" anchor="t" wrap="square" lIns="152400" rIns="152400" tIns="152400" bIns="152400"/>
+          <a:lstStyle/>
+          <a:p>
+            <a:pPr algn="l">
+              <a:spcAft>
+                <a:spcPts val="562"/>
+              </a:spcAft>
+            </a:pPr>
+            <a:r>
+              <a:rPr sz="1250" b="1">
+                <a:solidFill>
+                  <a:srgbClr val="2A2320"/>
+                </a:solidFill>
+                <a:latin typeface="Nunito"/>
+              </a:rPr>
+              <a:t>Separate simulation plane</a:t>
+            </a:r>
+          </a:p>
+          <a:p>
+            <a:pPr algn="l">
+              <a:spcAft>
+                <a:spcPts val="250"/>
+              </a:spcAft>
+            </a:pPr>
+            <a:r>
+              <a:rPr sz="1000" b="0">
+                <a:solidFill>
+                  <a:srgbClr val="2A2320"/>
+                </a:solidFill>
+                <a:latin typeface="Nunito"/>
+              </a:rPr>
+              <a:t>Plans → seeded synthetic data</a:t>
+            </a:r>
+          </a:p>
+          <a:p>
+            <a:pPr algn="l">
+              <a:spcAft>
+                <a:spcPts val="250"/>
+              </a:spcAft>
+            </a:pPr>
+            <a:r>
+              <a:rPr sz="1000" b="0">
+                <a:solidFill>
+                  <a:srgbClr val="2A2320"/>
+                </a:solidFill>
+                <a:latin typeface="Nunito"/>
+              </a:rPr>
+              <a:t>Only observable events enter</a:t>
+            </a:r>
+          </a:p>
+        </p:txBody>
+      </p:sp>
+      <p:cxnSp>
+        <p:nvCxnSpPr>
+          <p:cNvPr id="19" name="Arrow: Web experience → Python app · owns th"/>
+          <p:cNvCxnSpPr>
+            <a:stCxn id="4" idx="3"/>
+            <a:endCxn id="5" idx="1"/>
+          </p:cNvCxnSpPr>
+          <p:nvPr/>
+        </p:nvCxnSpPr>
+        <p:spPr>
+          <a:xfrm>
+            <a:off x="2794000" y="2794000"/>
+            <a:ext cx="508000" cy="1"/>
+          </a:xfrm>
+          <a:prstGeom prst="line">
+            <a:avLst/>
+          </a:prstGeom>
+          <a:ln w="25400">
+            <a:solidFill>
+              <a:srgbClr val="6B6258"/>
+            </a:solidFill>
+            <a:headEnd type="triangle" w="med" len="med"/>
+            <a:tailEnd type="triangle" w="med" len="med"/>
+          </a:ln>
+        </p:spPr>
+      </p:cxnSp>
+      <p:cxnSp>
+        <p:nvCxnSpPr>
+          <p:cNvPr id="20" name="Arrow: Python app · owns th → Bounded AI · read-on"/>
+          <p:cNvCxnSpPr>
+            <a:stCxn id="5" idx="3"/>
+            <a:endCxn id="6" idx="1"/>
+          </p:cNvCxnSpPr>
+          <p:nvPr/>
+        </p:nvCxnSpPr>
+        <p:spPr>
+          <a:xfrm>
+            <a:off x="7112000" y="2794000"/>
+            <a:ext cx="508000" cy="1"/>
+          </a:xfrm>
+          <a:prstGeom prst="line">
+            <a:avLst/>
+          </a:prstGeom>
+          <a:ln w="25400">
+            <a:solidFill>
+              <a:srgbClr val="6B6258"/>
+            </a:solidFill>
+            <a:tailEnd type="triangle" w="med" len="med"/>
+          </a:ln>
+        </p:spPr>
+      </p:cxnSp>
+      <p:cxnSp>
+        <p:nvCxnSpPr>
+          <p:cNvPr id="21" name="Arrow: Aura-Agent + patient → Ground → verify → re"/>
+          <p:cNvCxnSpPr>
+            <a:stCxn id="14" idx="2"/>
+            <a:endCxn id="15" idx="0"/>
+          </p:cNvCxnSpPr>
+          <p:nvPr/>
+        </p:nvCxnSpPr>
+        <p:spPr>
+          <a:xfrm>
+            <a:off x="9652000" y="2451100"/>
+            <a:ext cx="1" cy="381000"/>
+          </a:xfrm>
+          <a:prstGeom prst="line">
+            <a:avLst/>
+          </a:prstGeom>
+          <a:ln w="25400">
+            <a:solidFill>
+              <a:srgbClr val="6B6258"/>
+            </a:solidFill>
+            <a:tailEnd type="triangle" w="med" len="med"/>
+          </a:ln>
+        </p:spPr>
+      </p:cxnSp>
+      <p:cxnSp>
+        <p:nvCxnSpPr>
+          <p:cNvPr id="22" name="Arrow: Safety engine → Independent safety d"/>
+          <p:cNvCxnSpPr>
+            <a:stCxn id="12" idx="2"/>
+            <a:endCxn id="17" idx="0"/>
+          </p:cNvCxnSpPr>
+          <p:nvPr/>
+        </p:nvCxnSpPr>
+        <p:spPr>
+          <a:xfrm>
+            <a:off x="4305300" y="4203700"/>
+            <a:ext cx="1" cy="622300"/>
+          </a:xfrm>
+          <a:prstGeom prst="line">
+            <a:avLst/>
+          </a:prstGeom>
+          <a:ln w="25400">
+            <a:solidFill>
+              <a:srgbClr val="6B6258"/>
+            </a:solidFill>
+            <a:tailEnd type="triangle" w="med" len="med"/>
+          </a:ln>
+        </p:spPr>
+      </p:cxnSp>
+      <p:cxnSp>
+        <p:nvCxnSpPr>
+          <p:cNvPr id="23" name="Arrow: Separate simulation  → Python app · owns th"/>
+          <p:cNvCxnSpPr>
+            <a:stCxn id="18" idx="0"/>
+            <a:endCxn id="5" idx="2"/>
+          </p:cNvCxnSpPr>
+          <p:nvPr/>
+        </p:nvCxnSpPr>
+        <p:spPr>
+          <a:xfrm rot="5400000" flipH="1">
+            <a:off x="5905500" y="3683000"/>
+            <a:ext cx="444500" cy="1841500"/>
+          </a:xfrm>
+          <a:prstGeom prst="bentConnector3">
+            <a:avLst>
+              <a:gd name="adj1" fmla="val 50000"/>
+            </a:avLst>
+          </a:prstGeom>
+          <a:ln w="25400">
+            <a:solidFill>
+              <a:srgbClr val="6B6258"/>
+            </a:solidFill>
+            <a:tailEnd type="triangle" w="med" len="med"/>
+          </a:ln>
+        </p:spPr>
+      </p:cxnSp>
+      <p:sp>
+        <p:nvSpPr>
+          <p:cNvPr id="24" name="Text: inputs"/>
+          <p:cNvSpPr txBox="1"/>
+          <p:nvPr/>
+        </p:nvSpPr>
+        <p:spPr>
+          <a:xfrm>
+            <a:off x="2819400" y="2540000"/>
+            <a:ext cx="457200" cy="190500"/>
+          </a:xfrm>
+          <a:prstGeom prst="rect">
+            <a:avLst/>
+          </a:prstGeom>
+          <a:noFill/>
+        </p:spPr>
+        <p:txBody>
+          <a:bodyPr wrap="square" anchor="t" lIns="0" rIns="0" tIns="0" bIns="0"/>
+          <a:lstStyle/>
+          <a:p>
+            <a:pPr algn="ctr">
+              <a:spcAft>
+                <a:spcPts val="405"/>
+              </a:spcAft>
+            </a:pPr>
+            <a:r>
+              <a:rPr sz="900" b="0">
+                <a:solidFill>
+                  <a:srgbClr val="6B6258"/>
+                </a:solidFill>
+                <a:latin typeface="Nunito"/>
+              </a:rPr>
+              <a:t>inputs</a:t>
+            </a:r>
+          </a:p>
+        </p:txBody>
+      </p:sp>
+      <p:sp>
+        <p:nvSpPr>
+          <p:cNvPr id="25" name="Text: reads"/>
+          <p:cNvSpPr txBox="1"/>
+          <p:nvPr/>
+        </p:nvSpPr>
+        <p:spPr>
+          <a:xfrm>
+            <a:off x="7124700" y="2540000"/>
+            <a:ext cx="482600" cy="190500"/>
+          </a:xfrm>
+          <a:prstGeom prst="rect">
+            <a:avLst/>
+          </a:prstGeom>
+          <a:noFill/>
+        </p:spPr>
+        <p:txBody>
+          <a:bodyPr wrap="square" anchor="t" lIns="0" rIns="0" tIns="0" bIns="0"/>
+          <a:lstStyle/>
+          <a:p>
+            <a:pPr algn="ctr">
+              <a:spcAft>
+                <a:spcPts val="405"/>
+              </a:spcAft>
+            </a:pPr>
+            <a:r>
+              <a:rPr sz="900" b="0">
+                <a:solidFill>
+                  <a:srgbClr val="6B6258"/>
+                </a:solidFill>
+                <a:latin typeface="Nunito"/>
+              </a:rPr>
+              <a:t>reads</a:t>
+            </a:r>
+          </a:p>
+        </p:txBody>
+      </p:sp>
+      <p:sp>
+        <p:nvSpPr>
+          <p:cNvPr id="26" name="Text: Signals propose. Rules decide. AI words "/>
+          <p:cNvSpPr txBox="1"/>
+          <p:nvPr/>
+        </p:nvSpPr>
+        <p:spPr>
+          <a:xfrm>
+            <a:off x="508000" y="4826000"/>
+            <a:ext cx="2413000" cy="1143000"/>
+          </a:xfrm>
+          <a:prstGeom prst="rect">
+            <a:avLst/>
+          </a:prstGeom>
+          <a:noFill/>
+        </p:spPr>
+        <p:txBody>
+          <a:bodyPr wrap="square" anchor="t" lIns="0" rIns="0" tIns="0" bIns="0"/>
+          <a:lstStyle/>
+          <a:p>
+            <a:pPr algn="l">
+              <a:spcAft>
+                <a:spcPts val="675"/>
+              </a:spcAft>
+            </a:pPr>
+            <a:r>
+              <a:rPr sz="1500" b="1">
+                <a:solidFill>
+                  <a:srgbClr val="2A2320"/>
+                </a:solidFill>
+                <a:latin typeface="Nunito"/>
+              </a:rPr>
+              <a:t>Signals propose. Rules decide. AI words it.</a:t>
+            </a:r>
+          </a:p>
+        </p:txBody>
+      </p:sp>
+      <p:sp>
+        <p:nvSpPr>
+          <p:cNvPr id="27" name="Text: Implemented demo · one application deplo"/>
+          <p:cNvSpPr txBox="1"/>
+          <p:nvPr/>
+        </p:nvSpPr>
+        <p:spPr>
+          <a:xfrm>
+            <a:off x="8636000" y="4826000"/>
+            <a:ext cx="3048000" cy="1143000"/>
+          </a:xfrm>
+          <a:prstGeom prst="rect">
+            <a:avLst/>
+          </a:prstGeom>
+          <a:noFill/>
+        </p:spPr>
+        <p:txBody>
+          <a:bodyPr wrap="square" anchor="t" lIns="0" rIns="0" tIns="0" bIns="0"/>
+          <a:lstStyle/>
+          <a:p>
+            <a:pPr algn="l">
+              <a:spcAft>
+                <a:spcPts val="472"/>
+              </a:spcAft>
+            </a:pPr>
+            <a:r>
+              <a:rPr sz="1050" b="0">
+                <a:solidFill>
+                  <a:srgbClr val="6B6258"/>
+                </a:solidFill>
+                <a:latin typeface="Nunito"/>
+              </a:rPr>
+              <a:t>Implemented demo · one application deployment · development storage · institutional hosting is future work</a:t>
+            </a:r>
+          </a:p>
+        </p:txBody>
+      </p:sp>
     </p:spTree>
   </p:cSld>
   <p:clrMapOvr>
@@ -5628,6 +6889,14 @@
 <file path=ppt/slides/slide12.xml><?xml version="1.0" encoding="utf-8"?>
 <p:sld xmlns:a="http://schemas.openxmlformats.org/drawingml/2006/main" xmlns:p="http://schemas.openxmlformats.org/presentationml/2006/main" xmlns:r="http://schemas.openxmlformats.org/officeDocument/2006/relationships">
   <p:cSld>
+    <p:bg>
+      <p:bgPr>
+        <a:solidFill>
+          <a:srgbClr val="FBFAF7"/>
+        </a:solidFill>
+        <a:effectLst/>
+      </p:bgPr>
+    </p:bg>
     <p:spTree>
       <p:nvGrpSpPr>
         <p:cNvPr id="1" name=""/>
@@ -5635,30 +6904,943 @@
         <p:nvPr/>
       </p:nvGrpSpPr>
       <p:grpSpPr/>
-      <p:pic>
-        <p:nvPicPr>
-          <p:cNvPr id="2" name="Background (art, cards, screenshots)" descr="image.jpg"/>
-          <p:cNvPicPr>
-            <a:picLocks noChangeAspect="1"/>
-          </p:cNvPicPr>
-          <p:nvPr/>
-        </p:nvPicPr>
-        <p:blipFill>
-          <a:blip r:embed="rId2"/>
-          <a:stretch>
-            <a:fillRect/>
-          </a:stretch>
-        </p:blipFill>
-        <p:spPr>
-          <a:xfrm>
-            <a:off x="0" y="0"/>
-            <a:ext cx="12192000" cy="6858000"/>
-          </a:xfrm>
-          <a:prstGeom prst="rect">
-            <a:avLst/>
-          </a:prstGeom>
-        </p:spPr>
-      </p:pic>
+      <p:sp>
+        <p:nvSpPr>
+          <p:cNvPr id="2" name="Text: Aura-Agent · investigate, cite, check"/>
+          <p:cNvSpPr txBox="1"/>
+          <p:nvPr/>
+        </p:nvSpPr>
+        <p:spPr>
+          <a:xfrm>
+            <a:off x="508000" y="292100"/>
+            <a:ext cx="11176000" cy="444500"/>
+          </a:xfrm>
+          <a:prstGeom prst="rect">
+            <a:avLst/>
+          </a:prstGeom>
+          <a:noFill/>
+        </p:spPr>
+        <p:txBody>
+          <a:bodyPr wrap="square" anchor="t" lIns="0" rIns="0" tIns="0" bIns="0"/>
+          <a:lstStyle/>
+          <a:p>
+            <a:pPr algn="l">
+              <a:spcAft>
+                <a:spcPts val="1215"/>
+              </a:spcAft>
+            </a:pPr>
+            <a:r>
+              <a:rPr sz="2700" b="1">
+                <a:solidFill>
+                  <a:srgbClr val="2A2320"/>
+                </a:solidFill>
+                <a:latin typeface="Nunito"/>
+              </a:rPr>
+              <a:t>Aura-Agent · investigate, cite, check</a:t>
+            </a:r>
+          </a:p>
+        </p:txBody>
+      </p:sp>
+      <p:sp>
+        <p:nvSpPr>
+          <p:cNvPr id="3" name="Text: Challenge 2 · Scenario 1: mental health "/>
+          <p:cNvSpPr txBox="1"/>
+          <p:nvPr/>
+        </p:nvSpPr>
+        <p:spPr>
+          <a:xfrm>
+            <a:off x="508000" y="774700"/>
+            <a:ext cx="11176000" cy="254000"/>
+          </a:xfrm>
+          <a:prstGeom prst="rect">
+            <a:avLst/>
+          </a:prstGeom>
+          <a:noFill/>
+        </p:spPr>
+        <p:txBody>
+          <a:bodyPr wrap="square" anchor="t" lIns="0" rIns="0" tIns="0" bIns="0"/>
+          <a:lstStyle/>
+          <a:p>
+            <a:pPr algn="l">
+              <a:spcAft>
+                <a:spcPts val="585"/>
+              </a:spcAft>
+            </a:pPr>
+            <a:r>
+              <a:rPr sz="1300" b="0">
+                <a:solidFill>
+                  <a:srgbClr val="6B6258"/>
+                </a:solidFill>
+                <a:latin typeface="Nunito"/>
+              </a:rPr>
+              <a:t>Challenge 2 · Scenario 1: mental health maintenance for working adults on antidepressants</a:t>
+            </a:r>
+          </a:p>
+        </p:txBody>
+      </p:sp>
+      <p:sp>
+        <p:nvSpPr>
+          <p:cNvPr id="4" name="Box: 1 · Approve the request"/>
+          <p:cNvSpPr/>
+          <p:nvPr/>
+        </p:nvSpPr>
+        <p:spPr>
+          <a:xfrm>
+            <a:off x="508000" y="1270000"/>
+            <a:ext cx="3048000" cy="1206500"/>
+          </a:xfrm>
+          <a:prstGeom prst="roundRect">
+            <a:avLst>
+              <a:gd name="adj" fmla="val 11578"/>
+            </a:avLst>
+          </a:prstGeom>
+          <a:solidFill>
+            <a:srgbClr val="DCEEF7"/>
+          </a:solidFill>
+          <a:ln>
+            <a:noFill/>
+          </a:ln>
+        </p:spPr>
+        <p:txBody>
+          <a:bodyPr rtlCol="0" anchor="t" wrap="square" lIns="152400" rIns="152400" tIns="152400" bIns="152400"/>
+          <a:lstStyle/>
+          <a:p>
+            <a:pPr algn="l">
+              <a:spcAft>
+                <a:spcPts val="607"/>
+              </a:spcAft>
+            </a:pPr>
+            <a:r>
+              <a:rPr sz="1350" b="1">
+                <a:solidFill>
+                  <a:srgbClr val="2A2320"/>
+                </a:solidFill>
+                <a:latin typeface="Nunito"/>
+              </a:rPr>
+              <a:t>1 · Approve the request</a:t>
+            </a:r>
+          </a:p>
+          <a:p>
+            <a:pPr algn="l">
+              <a:spcAft>
+                <a:spcPts val="275"/>
+              </a:spcAft>
+            </a:pPr>
+            <a:r>
+              <a:rPr sz="1100" b="0">
+                <a:solidFill>
+                  <a:srgbClr val="2A2320"/>
+                </a:solidFill>
+                <a:latin typeface="Nunito"/>
+              </a:rPr>
+              <a:t>Skill, selected patient, current safety</a:t>
+            </a:r>
+          </a:p>
+          <a:p>
+            <a:pPr algn="l">
+              <a:spcAft>
+                <a:spcPts val="275"/>
+              </a:spcAft>
+            </a:pPr>
+            <a:r>
+              <a:rPr sz="1100" b="0">
+                <a:solidFill>
+                  <a:srgbClr val="2A2320"/>
+                </a:solidFill>
+                <a:latin typeface="Nunito"/>
+              </a:rPr>
+              <a:t>Read-only record + permitted window</a:t>
+            </a:r>
+          </a:p>
+        </p:txBody>
+      </p:sp>
+      <p:sp>
+        <p:nvSpPr>
+          <p:cNvPr id="5" name="Box: 2 · Model chooses a step"/>
+          <p:cNvSpPr/>
+          <p:nvPr/>
+        </p:nvSpPr>
+        <p:spPr>
+          <a:xfrm>
+            <a:off x="4572000" y="1270000"/>
+            <a:ext cx="3048000" cy="1206500"/>
+          </a:xfrm>
+          <a:prstGeom prst="roundRect">
+            <a:avLst>
+              <a:gd name="adj" fmla="val 11578"/>
+            </a:avLst>
+          </a:prstGeom>
+          <a:solidFill>
+            <a:srgbClr val="E8E1F3"/>
+          </a:solidFill>
+          <a:ln>
+            <a:noFill/>
+          </a:ln>
+        </p:spPr>
+        <p:txBody>
+          <a:bodyPr rtlCol="0" anchor="t" wrap="square" lIns="152400" rIns="152400" tIns="152400" bIns="152400"/>
+          <a:lstStyle/>
+          <a:p>
+            <a:pPr algn="l">
+              <a:spcAft>
+                <a:spcPts val="607"/>
+              </a:spcAft>
+            </a:pPr>
+            <a:r>
+              <a:rPr sz="1350" b="1">
+                <a:solidFill>
+                  <a:srgbClr val="2A2320"/>
+                </a:solidFill>
+                <a:latin typeface="Nunito"/>
+              </a:rPr>
+              <a:t>2 · Model chooses a step</a:t>
+            </a:r>
+          </a:p>
+          <a:p>
+            <a:pPr algn="l">
+              <a:spcAft>
+                <a:spcPts val="275"/>
+              </a:spcAft>
+            </a:pPr>
+            <a:r>
+              <a:rPr sz="1100" b="0">
+                <a:solidFill>
+                  <a:srgbClr val="2A2320"/>
+                </a:solidFill>
+                <a:latin typeface="Nunito"/>
+              </a:rPr>
+              <a:t>Which tool? Which dates? Which signal?</a:t>
+            </a:r>
+          </a:p>
+          <a:p>
+            <a:pPr algn="l">
+              <a:spcAft>
+                <a:spcPts val="275"/>
+              </a:spcAft>
+            </a:pPr>
+            <a:r>
+              <a:rPr sz="1100" b="0">
+                <a:solidFill>
+                  <a:srgbClr val="2A2320"/>
+                </a:solidFill>
+                <a:latin typeface="Nunito"/>
+              </a:rPr>
+              <a:t>Read more, or draft a cited answer</a:t>
+            </a:r>
+          </a:p>
+        </p:txBody>
+      </p:sp>
+      <p:sp>
+        <p:nvSpPr>
+          <p:cNvPr id="6" name="Box: 3 · Execute scoped tools"/>
+          <p:cNvSpPr/>
+          <p:nvPr/>
+        </p:nvSpPr>
+        <p:spPr>
+          <a:xfrm>
+            <a:off x="8636000" y="1270000"/>
+            <a:ext cx="3048000" cy="1206500"/>
+          </a:xfrm>
+          <a:prstGeom prst="roundRect">
+            <a:avLst>
+              <a:gd name="adj" fmla="val 11578"/>
+            </a:avLst>
+          </a:prstGeom>
+          <a:solidFill>
+            <a:srgbClr val="DCEEF7"/>
+          </a:solidFill>
+          <a:ln>
+            <a:noFill/>
+          </a:ln>
+        </p:spPr>
+        <p:txBody>
+          <a:bodyPr rtlCol="0" anchor="t" wrap="square" lIns="152400" rIns="152400" tIns="152400" bIns="152400"/>
+          <a:lstStyle/>
+          <a:p>
+            <a:pPr algn="l">
+              <a:spcAft>
+                <a:spcPts val="607"/>
+              </a:spcAft>
+            </a:pPr>
+            <a:r>
+              <a:rPr sz="1350" b="1">
+                <a:solidFill>
+                  <a:srgbClr val="2A2320"/>
+                </a:solidFill>
+                <a:latin typeface="Nunito"/>
+              </a:rPr>
+              <a:t>3 · Execute scoped tools</a:t>
+            </a:r>
+          </a:p>
+          <a:p>
+            <a:pPr algn="l">
+              <a:spcAft>
+                <a:spcPts val="275"/>
+              </a:spcAft>
+            </a:pPr>
+            <a:r>
+              <a:rPr sz="1100" b="0">
+                <a:solidFill>
+                  <a:srgbClr val="2A2320"/>
+                </a:solidFill>
+                <a:latin typeface="Nunito"/>
+              </a:rPr>
+              <a:t>Series, context, gaps, routine records</a:t>
+            </a:r>
+          </a:p>
+          <a:p>
+            <a:pPr algn="l">
+              <a:spcAft>
+                <a:spcPts val="275"/>
+              </a:spcAft>
+            </a:pPr>
+            <a:r>
+              <a:rPr sz="1100" b="0">
+                <a:solidFill>
+                  <a:srgbClr val="2A2320"/>
+                </a:solidFill>
+                <a:latin typeface="Nunito"/>
+              </a:rPr>
+              <a:t>Return facts, sources and calculations</a:t>
+            </a:r>
+          </a:p>
+        </p:txBody>
+      </p:sp>
+      <p:sp>
+        <p:nvSpPr>
+          <p:cNvPr id="7" name="Box: “When did sleep timing change, and was a"/>
+          <p:cNvSpPr/>
+          <p:nvPr/>
+        </p:nvSpPr>
+        <p:spPr>
+          <a:xfrm>
+            <a:off x="508000" y="2984500"/>
+            <a:ext cx="3048000" cy="1206500"/>
+          </a:xfrm>
+          <a:prstGeom prst="roundRect">
+            <a:avLst>
+              <a:gd name="adj" fmla="val 11578"/>
+            </a:avLst>
+          </a:prstGeom>
+          <a:solidFill>
+            <a:srgbClr val="F3F0EA"/>
+          </a:solidFill>
+          <a:ln>
+            <a:noFill/>
+          </a:ln>
+        </p:spPr>
+        <p:txBody>
+          <a:bodyPr rtlCol="0" anchor="t" wrap="square" lIns="152400" rIns="152400" tIns="152400" bIns="152400"/>
+          <a:lstStyle/>
+          <a:p>
+            <a:pPr algn="l">
+              <a:spcAft>
+                <a:spcPts val="540"/>
+              </a:spcAft>
+            </a:pPr>
+            <a:r>
+              <a:rPr sz="1200" b="1">
+                <a:solidFill>
+                  <a:srgbClr val="2A2320"/>
+                </a:solidFill>
+                <a:latin typeface="Nunito"/>
+              </a:rPr>
+              <a:t>“When did sleep timing change, and was anything reported around then?”</a:t>
+            </a:r>
+          </a:p>
+          <a:p>
+            <a:pPr algn="l">
+              <a:spcAft>
+                <a:spcPts val="250"/>
+              </a:spcAft>
+            </a:pPr>
+            <a:r>
+              <a:rPr sz="1000" b="0">
+                <a:solidFill>
+                  <a:srgbClr val="2A2320"/>
+                </a:solidFill>
+                <a:latin typeface="Nunito"/>
+              </a:rPr>
+              <a:t>A clinician's question. Patient-typed text is safety-checked first.</a:t>
+            </a:r>
+          </a:p>
+        </p:txBody>
+      </p:sp>
+      <p:sp>
+        <p:nvSpPr>
+          <p:cNvPr id="8" name="Box: 4 · Ground and verify"/>
+          <p:cNvSpPr/>
+          <p:nvPr/>
+        </p:nvSpPr>
+        <p:spPr>
+          <a:xfrm>
+            <a:off x="4572000" y="2984500"/>
+            <a:ext cx="3048000" cy="1206500"/>
+          </a:xfrm>
+          <a:prstGeom prst="roundRect">
+            <a:avLst>
+              <a:gd name="adj" fmla="val 11578"/>
+            </a:avLst>
+          </a:prstGeom>
+          <a:solidFill>
+            <a:srgbClr val="E8E1F3"/>
+          </a:solidFill>
+          <a:ln>
+            <a:noFill/>
+          </a:ln>
+        </p:spPr>
+        <p:txBody>
+          <a:bodyPr rtlCol="0" anchor="t" wrap="square" lIns="152400" rIns="152400" tIns="152400" bIns="152400"/>
+          <a:lstStyle/>
+          <a:p>
+            <a:pPr algn="l">
+              <a:spcAft>
+                <a:spcPts val="607"/>
+              </a:spcAft>
+            </a:pPr>
+            <a:r>
+              <a:rPr sz="1350" b="1">
+                <a:solidFill>
+                  <a:srgbClr val="2A2320"/>
+                </a:solidFill>
+                <a:latin typeface="Nunito"/>
+              </a:rPr>
+              <a:t>4 · Ground and verify</a:t>
+            </a:r>
+          </a:p>
+          <a:p>
+            <a:pPr algn="l">
+              <a:spcAft>
+                <a:spcPts val="275"/>
+              </a:spcAft>
+            </a:pPr>
+            <a:r>
+              <a:rPr sz="1100" b="0">
+                <a:solidFill>
+                  <a:srgbClr val="2A2320"/>
+                </a:solidFill>
+                <a:latin typeface="Nunito"/>
+              </a:rPr>
+              <a:t>Exact facts, citations, allowed claims</a:t>
+            </a:r>
+          </a:p>
+          <a:p>
+            <a:pPr algn="l">
+              <a:spcAft>
+                <a:spcPts val="275"/>
+              </a:spcAft>
+            </a:pPr>
+            <a:r>
+              <a:rPr sz="1100" b="0">
+                <a:solidFill>
+                  <a:srgbClr val="2A2320"/>
+                </a:solidFill>
+                <a:latin typeface="Nunito"/>
+              </a:rPr>
+              <a:t>A separate model call checks each statement</a:t>
+            </a:r>
+          </a:p>
+        </p:txBody>
+      </p:sp>
+      <p:sp>
+        <p:nvSpPr>
+          <p:cNvPr id="9" name="Box: 5 · Recheck current state"/>
+          <p:cNvSpPr/>
+          <p:nvPr/>
+        </p:nvSpPr>
+        <p:spPr>
+          <a:xfrm>
+            <a:off x="8636000" y="2984500"/>
+            <a:ext cx="3048000" cy="1206500"/>
+          </a:xfrm>
+          <a:prstGeom prst="roundRect">
+            <a:avLst>
+              <a:gd name="adj" fmla="val 11578"/>
+            </a:avLst>
+          </a:prstGeom>
+          <a:solidFill>
+            <a:srgbClr val="DCEEF7"/>
+          </a:solidFill>
+          <a:ln>
+            <a:noFill/>
+          </a:ln>
+        </p:spPr>
+        <p:txBody>
+          <a:bodyPr rtlCol="0" anchor="t" wrap="square" lIns="152400" rIns="152400" tIns="152400" bIns="152400"/>
+          <a:lstStyle/>
+          <a:p>
+            <a:pPr algn="l">
+              <a:spcAft>
+                <a:spcPts val="607"/>
+              </a:spcAft>
+            </a:pPr>
+            <a:r>
+              <a:rPr sz="1350" b="1">
+                <a:solidFill>
+                  <a:srgbClr val="2A2320"/>
+                </a:solidFill>
+                <a:latin typeface="Nunito"/>
+              </a:rPr>
+              <a:t>5 · Recheck current state</a:t>
+            </a:r>
+          </a:p>
+          <a:p>
+            <a:pPr algn="l">
+              <a:spcAft>
+                <a:spcPts val="275"/>
+              </a:spcAft>
+            </a:pPr>
+            <a:r>
+              <a:rPr sz="1100" b="0">
+                <a:solidFill>
+                  <a:srgbClr val="2A2320"/>
+                </a:solidFill>
+                <a:latin typeface="Nunito"/>
+              </a:rPr>
+              <a:t>Has the record or safety state changed?</a:t>
+            </a:r>
+          </a:p>
+          <a:p>
+            <a:pPr algn="l">
+              <a:spcAft>
+                <a:spcPts val="275"/>
+              </a:spcAft>
+            </a:pPr>
+            <a:r>
+              <a:rPr sz="1100" b="0">
+                <a:solidFill>
+                  <a:srgbClr val="2A2320"/>
+                </a:solidFill>
+                <a:latin typeface="Nunito"/>
+              </a:rPr>
+              <a:t>Unsafe or stale results are withheld</a:t>
+            </a:r>
+          </a:p>
+        </p:txBody>
+      </p:sp>
+      <p:sp>
+        <p:nvSpPr>
+          <p:cNvPr id="10" name="Box: 6 · Persist and display"/>
+          <p:cNvSpPr/>
+          <p:nvPr/>
+        </p:nvSpPr>
+        <p:spPr>
+          <a:xfrm>
+            <a:off x="8636000" y="4699000"/>
+            <a:ext cx="3048000" cy="1206500"/>
+          </a:xfrm>
+          <a:prstGeom prst="roundRect">
+            <a:avLst>
+              <a:gd name="adj" fmla="val 11578"/>
+            </a:avLst>
+          </a:prstGeom>
+          <a:solidFill>
+            <a:srgbClr val="F3F0EA"/>
+          </a:solidFill>
+          <a:ln>
+            <a:noFill/>
+          </a:ln>
+        </p:spPr>
+        <p:txBody>
+          <a:bodyPr rtlCol="0" anchor="t" wrap="square" lIns="152400" rIns="152400" tIns="152400" bIns="152400"/>
+          <a:lstStyle/>
+          <a:p>
+            <a:pPr algn="l">
+              <a:spcAft>
+                <a:spcPts val="607"/>
+              </a:spcAft>
+            </a:pPr>
+            <a:r>
+              <a:rPr sz="1350" b="1">
+                <a:solidFill>
+                  <a:srgbClr val="2A2320"/>
+                </a:solidFill>
+                <a:latin typeface="Nunito"/>
+              </a:rPr>
+              <a:t>6 · Persist and display</a:t>
+            </a:r>
+          </a:p>
+          <a:p>
+            <a:pPr algn="l">
+              <a:spcAft>
+                <a:spcPts val="275"/>
+              </a:spcAft>
+            </a:pPr>
+            <a:r>
+              <a:rPr sz="1100" b="0">
+                <a:solidFill>
+                  <a:srgbClr val="2A2320"/>
+                </a:solidFill>
+                <a:latin typeface="Nunito"/>
+              </a:rPr>
+              <a:t>Answer, sources, How AURA looked</a:t>
+            </a:r>
+          </a:p>
+          <a:p>
+            <a:pPr algn="l">
+              <a:spcAft>
+                <a:spcPts val="275"/>
+              </a:spcAft>
+            </a:pPr>
+            <a:r>
+              <a:rPr sz="1100" b="0">
+                <a:solidFill>
+                  <a:srgbClr val="2A2320"/>
+                </a:solidFill>
+                <a:latin typeface="Nunito"/>
+              </a:rPr>
+              <a:t>No care-action or treatment-write tools</a:t>
+            </a:r>
+          </a:p>
+        </p:txBody>
+      </p:sp>
+      <p:cxnSp>
+        <p:nvCxnSpPr>
+          <p:cNvPr id="11" name="Arrow: “When did sleep timi → 1 · Approve the requ"/>
+          <p:cNvCxnSpPr>
+            <a:stCxn id="7" idx="0"/>
+            <a:endCxn id="4" idx="2"/>
+          </p:cNvCxnSpPr>
+          <p:nvPr/>
+        </p:nvCxnSpPr>
+        <p:spPr>
+          <a:xfrm flipV="1">
+            <a:off x="2032000" y="2476500"/>
+            <a:ext cx="1" cy="508000"/>
+          </a:xfrm>
+          <a:prstGeom prst="line">
+            <a:avLst/>
+          </a:prstGeom>
+          <a:ln w="25400">
+            <a:solidFill>
+              <a:srgbClr val="6B6258"/>
+            </a:solidFill>
+            <a:tailEnd type="triangle" w="med" len="med"/>
+          </a:ln>
+        </p:spPr>
+      </p:cxnSp>
+      <p:cxnSp>
+        <p:nvCxnSpPr>
+          <p:cNvPr id="12" name="Arrow: 1 · Approve the requ → 2 · Model chooses a "/>
+          <p:cNvCxnSpPr>
+            <a:stCxn id="4" idx="3"/>
+            <a:endCxn id="5" idx="1"/>
+          </p:cNvCxnSpPr>
+          <p:nvPr/>
+        </p:nvCxnSpPr>
+        <p:spPr>
+          <a:xfrm>
+            <a:off x="3556000" y="1873250"/>
+            <a:ext cx="1016000" cy="1"/>
+          </a:xfrm>
+          <a:prstGeom prst="line">
+            <a:avLst/>
+          </a:prstGeom>
+          <a:ln w="25400">
+            <a:solidFill>
+              <a:srgbClr val="6B6258"/>
+            </a:solidFill>
+            <a:tailEnd type="triangle" w="med" len="med"/>
+          </a:ln>
+        </p:spPr>
+      </p:cxnSp>
+      <p:cxnSp>
+        <p:nvCxnSpPr>
+          <p:cNvPr id="13" name="Arrow: 2 · Model chooses a  → 3 · Execute scoped t"/>
+          <p:cNvCxnSpPr>
+            <a:stCxn id="5" idx="3"/>
+            <a:endCxn id="6" idx="1"/>
+          </p:cNvCxnSpPr>
+          <p:nvPr/>
+        </p:nvCxnSpPr>
+        <p:spPr>
+          <a:xfrm>
+            <a:off x="7620000" y="1873250"/>
+            <a:ext cx="1016000" cy="1"/>
+          </a:xfrm>
+          <a:prstGeom prst="line">
+            <a:avLst/>
+          </a:prstGeom>
+          <a:ln w="25400">
+            <a:solidFill>
+              <a:srgbClr val="6B6258"/>
+            </a:solidFill>
+            <a:headEnd type="triangle" w="med" len="med"/>
+            <a:tailEnd type="triangle" w="med" len="med"/>
+          </a:ln>
+        </p:spPr>
+      </p:cxnSp>
+      <p:cxnSp>
+        <p:nvCxnSpPr>
+          <p:cNvPr id="14" name="Arrow: 2 · Model chooses a  → 4 · Ground and verif"/>
+          <p:cNvCxnSpPr>
+            <a:stCxn id="5" idx="2"/>
+            <a:endCxn id="8" idx="0"/>
+          </p:cNvCxnSpPr>
+          <p:nvPr/>
+        </p:nvCxnSpPr>
+        <p:spPr>
+          <a:xfrm>
+            <a:off x="6096000" y="2476500"/>
+            <a:ext cx="1" cy="508000"/>
+          </a:xfrm>
+          <a:prstGeom prst="line">
+            <a:avLst/>
+          </a:prstGeom>
+          <a:ln w="25400">
+            <a:solidFill>
+              <a:srgbClr val="6B6258"/>
+            </a:solidFill>
+            <a:tailEnd type="triangle" w="med" len="med"/>
+          </a:ln>
+        </p:spPr>
+      </p:cxnSp>
+      <p:cxnSp>
+        <p:nvCxnSpPr>
+          <p:cNvPr id="15" name="Arrow: 4 · Ground and verif → 5 · Recheck current "/>
+          <p:cNvCxnSpPr>
+            <a:stCxn id="8" idx="3"/>
+            <a:endCxn id="9" idx="1"/>
+          </p:cNvCxnSpPr>
+          <p:nvPr/>
+        </p:nvCxnSpPr>
+        <p:spPr>
+          <a:xfrm>
+            <a:off x="7620000" y="3587750"/>
+            <a:ext cx="1016000" cy="1"/>
+          </a:xfrm>
+          <a:prstGeom prst="line">
+            <a:avLst/>
+          </a:prstGeom>
+          <a:ln w="25400">
+            <a:solidFill>
+              <a:srgbClr val="6B6258"/>
+            </a:solidFill>
+            <a:tailEnd type="triangle" w="med" len="med"/>
+          </a:ln>
+        </p:spPr>
+      </p:cxnSp>
+      <p:cxnSp>
+        <p:nvCxnSpPr>
+          <p:cNvPr id="16" name="Arrow: 5 · Recheck current  → 6 · Persist and disp"/>
+          <p:cNvCxnSpPr>
+            <a:stCxn id="9" idx="2"/>
+            <a:endCxn id="10" idx="0"/>
+          </p:cNvCxnSpPr>
+          <p:nvPr/>
+        </p:nvCxnSpPr>
+        <p:spPr>
+          <a:xfrm>
+            <a:off x="10160000" y="4191000"/>
+            <a:ext cx="1" cy="508000"/>
+          </a:xfrm>
+          <a:prstGeom prst="line">
+            <a:avLst/>
+          </a:prstGeom>
+          <a:ln w="25400">
+            <a:solidFill>
+              <a:srgbClr val="6B6258"/>
+            </a:solidFill>
+            <a:tailEnd type="triangle" w="med" len="med"/>
+          </a:ln>
+        </p:spPr>
+      </p:cxnSp>
+      <p:sp>
+        <p:nvSpPr>
+          <p:cNvPr id="17" name="Text: tool calls,"/>
+          <p:cNvSpPr txBox="1"/>
+          <p:nvPr/>
+        </p:nvSpPr>
+        <p:spPr>
+          <a:xfrm>
+            <a:off x="7620000" y="1244600"/>
+            <a:ext cx="1016000" cy="381000"/>
+          </a:xfrm>
+          <a:prstGeom prst="rect">
+            <a:avLst/>
+          </a:prstGeom>
+          <a:noFill/>
+        </p:spPr>
+        <p:txBody>
+          <a:bodyPr wrap="square" anchor="t" lIns="0" rIns="0" tIns="0" bIns="0"/>
+          <a:lstStyle/>
+          <a:p>
+            <a:pPr algn="ctr">
+              <a:spcAft>
+                <a:spcPts val="405"/>
+              </a:spcAft>
+            </a:pPr>
+            <a:r>
+              <a:rPr sz="900" b="0">
+                <a:solidFill>
+                  <a:srgbClr val="6B6258"/>
+                </a:solidFill>
+                <a:latin typeface="Nunito"/>
+              </a:rPr>
+              <a:t>tool calls,</a:t>
+            </a:r>
+          </a:p>
+          <a:p>
+            <a:pPr algn="ctr">
+              <a:spcAft>
+                <a:spcPts val="225"/>
+              </a:spcAft>
+            </a:pPr>
+            <a:r>
+              <a:rPr sz="900" b="0">
+                <a:solidFill>
+                  <a:srgbClr val="6B6258"/>
+                </a:solidFill>
+                <a:latin typeface="Nunito"/>
+              </a:rPr>
+              <a:t>facts back</a:t>
+            </a:r>
+          </a:p>
+        </p:txBody>
+      </p:sp>
+      <p:sp>
+        <p:nvSpPr>
+          <p:cNvPr id="18" name="Text: cited draft"/>
+          <p:cNvSpPr txBox="1"/>
+          <p:nvPr/>
+        </p:nvSpPr>
+        <p:spPr>
+          <a:xfrm>
+            <a:off x="6134100" y="2540000"/>
+            <a:ext cx="1651000" cy="381000"/>
+          </a:xfrm>
+          <a:prstGeom prst="rect">
+            <a:avLst/>
+          </a:prstGeom>
+          <a:noFill/>
+        </p:spPr>
+        <p:txBody>
+          <a:bodyPr wrap="square" anchor="t" lIns="0" rIns="0" tIns="0" bIns="0"/>
+          <a:lstStyle/>
+          <a:p>
+            <a:pPr algn="l">
+              <a:spcAft>
+                <a:spcPts val="405"/>
+              </a:spcAft>
+            </a:pPr>
+            <a:r>
+              <a:rPr sz="900" b="0">
+                <a:solidFill>
+                  <a:srgbClr val="6B6258"/>
+                </a:solidFill>
+                <a:latin typeface="Nunito"/>
+              </a:rPr>
+              <a:t>cited draft</a:t>
+            </a:r>
+          </a:p>
+          <a:p>
+            <a:pPr algn="l">
+              <a:spcAft>
+                <a:spcPts val="225"/>
+              </a:spcAft>
+            </a:pPr>
+            <a:r>
+              <a:rPr sz="900" b="0">
+                <a:solidFill>
+                  <a:srgbClr val="6B6258"/>
+                </a:solidFill>
+                <a:latin typeface="Nunito"/>
+              </a:rPr>
+              <a:t>when ready</a:t>
+            </a:r>
+          </a:p>
+        </p:txBody>
+      </p:sp>
+      <p:sp>
+        <p:nvSpPr>
+          <p:cNvPr id="19" name="Text: Limits per answer: 8 model steps · 24 to"/>
+          <p:cNvSpPr txBox="1"/>
+          <p:nvPr/>
+        </p:nvSpPr>
+        <p:spPr>
+          <a:xfrm>
+            <a:off x="508000" y="4762500"/>
+            <a:ext cx="7493000" cy="381000"/>
+          </a:xfrm>
+          <a:prstGeom prst="rect">
+            <a:avLst/>
+          </a:prstGeom>
+          <a:noFill/>
+        </p:spPr>
+        <p:txBody>
+          <a:bodyPr wrap="square" anchor="t" lIns="0" rIns="0" tIns="0" bIns="0"/>
+          <a:lstStyle/>
+          <a:p>
+            <a:pPr algn="l">
+              <a:spcAft>
+                <a:spcPts val="630"/>
+              </a:spcAft>
+            </a:pPr>
+            <a:r>
+              <a:rPr sz="1400" b="1">
+                <a:solidFill>
+                  <a:srgbClr val="2A2320"/>
+                </a:solidFill>
+                <a:latin typeface="Nunito"/>
+              </a:rPr>
+              <a:t>Limits per answer: 8 model steps · 24 tool calls · 90 seconds</a:t>
+            </a:r>
+          </a:p>
+        </p:txBody>
+      </p:sp>
+      <p:sp>
+        <p:nvSpPr>
+          <p:cNvPr id="20" name="Text: Failure shows source-based related facts"/>
+          <p:cNvSpPr txBox="1"/>
+          <p:nvPr/>
+        </p:nvSpPr>
+        <p:spPr>
+          <a:xfrm>
+            <a:off x="508000" y="5156200"/>
+            <a:ext cx="7493000" cy="762000"/>
+          </a:xfrm>
+          <a:prstGeom prst="rect">
+            <a:avLst/>
+          </a:prstGeom>
+          <a:noFill/>
+        </p:spPr>
+        <p:txBody>
+          <a:bodyPr wrap="square" anchor="t" lIns="0" rIns="0" tIns="0" bIns="0"/>
+          <a:lstStyle/>
+          <a:p>
+            <a:pPr algn="l">
+              <a:spcAft>
+                <a:spcPts val="495"/>
+              </a:spcAft>
+            </a:pPr>
+            <a:r>
+              <a:rPr sz="1100" b="0">
+                <a:solidFill>
+                  <a:srgbClr val="6B6258"/>
+                </a:solidFill>
+                <a:latin typeface="Nunito"/>
+              </a:rPr>
+              <a:t>Failure shows source-based related facts and says so. The trail shows actions, not hidden reasoning.</a:t>
+            </a:r>
+          </a:p>
+          <a:p>
+            <a:pPr algn="l">
+              <a:spcAft>
+                <a:spcPts val="275"/>
+              </a:spcAft>
+            </a:pPr>
+            <a:r>
+              <a:rPr sz="1100" b="0">
+                <a:solidFill>
+                  <a:srgbClr val="6B6258"/>
+                </a:solidFill>
+                <a:latin typeface="Nunito"/>
+              </a:rPr>
+              <a:t>Verification is not clinical validation.</a:t>
+            </a:r>
+          </a:p>
+        </p:txBody>
+      </p:sp>
     </p:spTree>
   </p:cSld>
   <p:clrMapOvr>
@@ -5670,6 +7852,14 @@
 <file path=ppt/slides/slide13.xml><?xml version="1.0" encoding="utf-8"?>
 <p:sld xmlns:a="http://schemas.openxmlformats.org/drawingml/2006/main" xmlns:p="http://schemas.openxmlformats.org/presentationml/2006/main" xmlns:r="http://schemas.openxmlformats.org/officeDocument/2006/relationships">
   <p:cSld>
+    <p:bg>
+      <p:bgPr>
+        <a:solidFill>
+          <a:srgbClr val="FBFAF7"/>
+        </a:solidFill>
+        <a:effectLst/>
+      </p:bgPr>
+    </p:bg>
     <p:spTree>
       <p:nvGrpSpPr>
         <p:cNvPr id="1" name=""/>
@@ -5677,30 +7867,916 @@
         <p:nvPr/>
       </p:nvGrpSpPr>
       <p:grpSpPr/>
-      <p:pic>
-        <p:nvPicPr>
-          <p:cNvPr id="2" name="Background (art, cards, screenshots)" descr="image.jpg"/>
-          <p:cNvPicPr>
-            <a:picLocks noChangeAspect="1"/>
-          </p:cNvPicPr>
-          <p:nvPr/>
-        </p:nvPicPr>
-        <p:blipFill>
-          <a:blip r:embed="rId2"/>
-          <a:stretch>
-            <a:fillRect/>
-          </a:stretch>
-        </p:blipFill>
-        <p:spPr>
-          <a:xfrm>
-            <a:off x="0" y="0"/>
-            <a:ext cx="12192000" cy="6858000"/>
-          </a:xfrm>
-          <a:prstGeom prst="rect">
-            <a:avLst/>
-          </a:prstGeom>
-        </p:spPr>
-      </p:pic>
+      <p:sp>
+        <p:nvSpPr>
+          <p:cNvPr id="2" name="Text: Safety policy has the final say"/>
+          <p:cNvSpPr txBox="1"/>
+          <p:nvPr/>
+        </p:nvSpPr>
+        <p:spPr>
+          <a:xfrm>
+            <a:off x="508000" y="292100"/>
+            <a:ext cx="11176000" cy="444500"/>
+          </a:xfrm>
+          <a:prstGeom prst="rect">
+            <a:avLst/>
+          </a:prstGeom>
+          <a:noFill/>
+        </p:spPr>
+        <p:txBody>
+          <a:bodyPr wrap="square" anchor="t" lIns="0" rIns="0" tIns="0" bIns="0"/>
+          <a:lstStyle/>
+          <a:p>
+            <a:pPr algn="l">
+              <a:spcAft>
+                <a:spcPts val="1215"/>
+              </a:spcAft>
+            </a:pPr>
+            <a:r>
+              <a:rPr sz="2700" b="1">
+                <a:solidFill>
+                  <a:srgbClr val="2A2320"/>
+                </a:solidFill>
+                <a:latin typeface="Nunito"/>
+              </a:rPr>
+              <a:t>Safety policy has the final say</a:t>
+            </a:r>
+          </a:p>
+        </p:txBody>
+      </p:sp>
+      <p:sp>
+        <p:nvSpPr>
+          <p:cNvPr id="3" name="Text: Challenge 2 · Scenario 1: mental health "/>
+          <p:cNvSpPr txBox="1"/>
+          <p:nvPr/>
+        </p:nvSpPr>
+        <p:spPr>
+          <a:xfrm>
+            <a:off x="508000" y="774700"/>
+            <a:ext cx="11176000" cy="254000"/>
+          </a:xfrm>
+          <a:prstGeom prst="rect">
+            <a:avLst/>
+          </a:prstGeom>
+          <a:noFill/>
+        </p:spPr>
+        <p:txBody>
+          <a:bodyPr wrap="square" anchor="t" lIns="0" rIns="0" tIns="0" bIns="0"/>
+          <a:lstStyle/>
+          <a:p>
+            <a:pPr algn="l">
+              <a:spcAft>
+                <a:spcPts val="585"/>
+              </a:spcAft>
+            </a:pPr>
+            <a:r>
+              <a:rPr sz="1300" b="0">
+                <a:solidFill>
+                  <a:srgbClr val="6B6258"/>
+                </a:solidFill>
+                <a:latin typeface="Nunito"/>
+              </a:rPr>
+              <a:t>Challenge 2 · Scenario 1: mental health maintenance for working adults on antidepressants</a:t>
+            </a:r>
+          </a:p>
+        </p:txBody>
+      </p:sp>
+      <p:sp>
+        <p:nvSpPr>
+          <p:cNvPr id="4" name="Box: Patient input"/>
+          <p:cNvSpPr/>
+          <p:nvPr/>
+        </p:nvSpPr>
+        <p:spPr>
+          <a:xfrm>
+            <a:off x="508000" y="1270000"/>
+            <a:ext cx="2660650" cy="1270000"/>
+          </a:xfrm>
+          <a:prstGeom prst="roundRect">
+            <a:avLst>
+              <a:gd name="adj" fmla="val 11000"/>
+            </a:avLst>
+          </a:prstGeom>
+          <a:solidFill>
+            <a:srgbClr val="F3F0EA"/>
+          </a:solidFill>
+          <a:ln>
+            <a:noFill/>
+          </a:ln>
+        </p:spPr>
+        <p:txBody>
+          <a:bodyPr rtlCol="0" anchor="t" wrap="square" lIns="152400" rIns="152400" tIns="152400" bIns="152400"/>
+          <a:lstStyle/>
+          <a:p>
+            <a:pPr algn="l">
+              <a:spcAft>
+                <a:spcPts val="607"/>
+              </a:spcAft>
+            </a:pPr>
+            <a:r>
+              <a:rPr sz="1350" b="1">
+                <a:solidFill>
+                  <a:srgbClr val="2A2320"/>
+                </a:solidFill>
+                <a:latin typeface="Nunito"/>
+              </a:rPr>
+              <a:t>Patient input</a:t>
+            </a:r>
+          </a:p>
+          <a:p>
+            <a:pPr algn="l">
+              <a:spcAft>
+                <a:spcPts val="275"/>
+              </a:spcAft>
+            </a:pPr>
+            <a:r>
+              <a:rPr sz="1100" b="0">
+                <a:solidFill>
+                  <a:srgbClr val="2A2320"/>
+                </a:solidFill>
+                <a:latin typeface="Nunito"/>
+              </a:rPr>
+              <a:t>Typed notes and medication questions</a:t>
+            </a:r>
+          </a:p>
+          <a:p>
+            <a:pPr algn="l">
+              <a:spcAft>
+                <a:spcPts val="275"/>
+              </a:spcAft>
+            </a:pPr>
+            <a:r>
+              <a:rPr sz="1100" b="0">
+                <a:solidFill>
+                  <a:srgbClr val="2A2320"/>
+                </a:solidFill>
+                <a:latin typeface="Nunito"/>
+              </a:rPr>
+              <a:t>Safety-relevant path first</a:t>
+            </a:r>
+          </a:p>
+        </p:txBody>
+      </p:sp>
+      <p:sp>
+        <p:nvSpPr>
+          <p:cNvPr id="5" name="Box: Safety gate + proposals"/>
+          <p:cNvSpPr/>
+          <p:nvPr/>
+        </p:nvSpPr>
+        <p:spPr>
+          <a:xfrm>
+            <a:off x="3346450" y="1270000"/>
+            <a:ext cx="2660650" cy="1270000"/>
+          </a:xfrm>
+          <a:prstGeom prst="roundRect">
+            <a:avLst>
+              <a:gd name="adj" fmla="val 11000"/>
+            </a:avLst>
+          </a:prstGeom>
+          <a:solidFill>
+            <a:srgbClr val="E8E1F3"/>
+          </a:solidFill>
+          <a:ln>
+            <a:noFill/>
+          </a:ln>
+        </p:spPr>
+        <p:txBody>
+          <a:bodyPr rtlCol="0" anchor="t" wrap="square" lIns="152400" rIns="152400" tIns="152400" bIns="152400"/>
+          <a:lstStyle/>
+          <a:p>
+            <a:pPr algn="l">
+              <a:spcAft>
+                <a:spcPts val="607"/>
+              </a:spcAft>
+            </a:pPr>
+            <a:r>
+              <a:rPr sz="1350" b="1">
+                <a:solidFill>
+                  <a:srgbClr val="2A2320"/>
+                </a:solidFill>
+                <a:latin typeface="Nunito"/>
+              </a:rPr>
+              <a:t>Safety gate + proposals</a:t>
+            </a:r>
+          </a:p>
+          <a:p>
+            <a:pPr algn="l">
+              <a:spcAft>
+                <a:spcPts val="275"/>
+              </a:spcAft>
+            </a:pPr>
+            <a:r>
+              <a:rPr sz="1100" b="0">
+                <a:solidFill>
+                  <a:srgbClr val="2A2320"/>
+                </a:solidFill>
+                <a:latin typeface="Nunito"/>
+              </a:rPr>
+              <a:t>Rules / demo classifier → signals</a:t>
+            </a:r>
+          </a:p>
+          <a:p>
+            <a:pPr algn="l">
+              <a:spcAft>
+                <a:spcPts val="275"/>
+              </a:spcAft>
+            </a:pPr>
+            <a:r>
+              <a:rPr sz="1100" b="0">
+                <a:solidFill>
+                  <a:srgbClr val="2A2320"/>
+                </a:solidFill>
+                <a:latin typeface="Nunito"/>
+              </a:rPr>
+              <a:t>A detector cannot lower safety state</a:t>
+            </a:r>
+          </a:p>
+        </p:txBody>
+      </p:sp>
+      <p:sp>
+        <p:nvSpPr>
+          <p:cNvPr id="6" name="Box: Deterministic safety controller"/>
+          <p:cNvSpPr/>
+          <p:nvPr/>
+        </p:nvSpPr>
+        <p:spPr>
+          <a:xfrm>
+            <a:off x="6184900" y="1270000"/>
+            <a:ext cx="2660650" cy="1270000"/>
+          </a:xfrm>
+          <a:prstGeom prst="roundRect">
+            <a:avLst>
+              <a:gd name="adj" fmla="val 11000"/>
+            </a:avLst>
+          </a:prstGeom>
+          <a:solidFill>
+            <a:srgbClr val="FDE3DF"/>
+          </a:solidFill>
+          <a:ln>
+            <a:noFill/>
+          </a:ln>
+        </p:spPr>
+        <p:txBody>
+          <a:bodyPr rtlCol="0" anchor="t" wrap="square" lIns="152400" rIns="152400" tIns="152400" bIns="152400"/>
+          <a:lstStyle/>
+          <a:p>
+            <a:pPr algn="l">
+              <a:spcAft>
+                <a:spcPts val="607"/>
+              </a:spcAft>
+            </a:pPr>
+            <a:r>
+              <a:rPr sz="1350" b="1">
+                <a:solidFill>
+                  <a:srgbClr val="2A2320"/>
+                </a:solidFill>
+                <a:latin typeface="Nunito"/>
+              </a:rPr>
+              <a:t>Deterministic safety controller</a:t>
+            </a:r>
+          </a:p>
+          <a:p>
+            <a:pPr algn="l">
+              <a:spcAft>
+                <a:spcPts val="275"/>
+              </a:spcAft>
+            </a:pPr>
+            <a:r>
+              <a:rPr sz="1100" b="0">
+                <a:solidFill>
+                  <a:srgbClr val="2A2320"/>
+                </a:solidFill>
+                <a:latin typeface="Nunito"/>
+              </a:rPr>
+              <a:t>T0–T4 transitions → actions</a:t>
+            </a:r>
+          </a:p>
+          <a:p>
+            <a:pPr algn="l">
+              <a:spcAft>
+                <a:spcPts val="275"/>
+              </a:spcAft>
+            </a:pPr>
+            <a:r>
+              <a:rPr sz="1100" b="0">
+                <a:solidFill>
+                  <a:srgbClr val="2A2320"/>
+                </a:solidFill>
+                <a:latin typeface="Nunito"/>
+              </a:rPr>
+              <a:t>Fail closed when degraded</a:t>
+            </a:r>
+          </a:p>
+        </p:txBody>
+      </p:sp>
+      <p:sp>
+        <p:nvSpPr>
+          <p:cNvPr id="7" name="Box: Registry + built-in bundle"/>
+          <p:cNvSpPr/>
+          <p:nvPr/>
+        </p:nvSpPr>
+        <p:spPr>
+          <a:xfrm>
+            <a:off x="9023350" y="1270000"/>
+            <a:ext cx="2660650" cy="1270000"/>
+          </a:xfrm>
+          <a:prstGeom prst="roundRect">
+            <a:avLst>
+              <a:gd name="adj" fmla="val 11000"/>
+            </a:avLst>
+          </a:prstGeom>
+          <a:solidFill>
+            <a:srgbClr val="FDE3DF"/>
+          </a:solidFill>
+          <a:ln>
+            <a:noFill/>
+          </a:ln>
+        </p:spPr>
+        <p:txBody>
+          <a:bodyPr rtlCol="0" anchor="t" wrap="square" lIns="152400" rIns="152400" tIns="152400" bIns="152400"/>
+          <a:lstStyle/>
+          <a:p>
+            <a:pPr algn="l">
+              <a:spcAft>
+                <a:spcPts val="607"/>
+              </a:spcAft>
+            </a:pPr>
+            <a:r>
+              <a:rPr sz="1350" b="1">
+                <a:solidFill>
+                  <a:srgbClr val="2A2320"/>
+                </a:solidFill>
+                <a:latin typeface="Nunito"/>
+              </a:rPr>
+              <a:t>Registry + built-in bundle</a:t>
+            </a:r>
+          </a:p>
+          <a:p>
+            <a:pPr algn="l">
+              <a:spcAft>
+                <a:spcPts val="275"/>
+              </a:spcAft>
+            </a:pPr>
+            <a:r>
+              <a:rPr sz="1100" b="0">
+                <a:solidFill>
+                  <a:srgbClr val="2A2320"/>
+                </a:solidFill>
+                <a:latin typeface="Nunito"/>
+              </a:rPr>
+              <a:t>Lookup failure → fallback</a:t>
+            </a:r>
+          </a:p>
+          <a:p>
+            <a:pPr algn="l">
+              <a:spcAft>
+                <a:spcPts val="275"/>
+              </a:spcAft>
+            </a:pPr>
+            <a:r>
+              <a:rPr sz="1100" b="0">
+                <a:solidFill>
+                  <a:srgbClr val="2A2320"/>
+                </a:solidFill>
+                <a:latin typeface="Nunito"/>
+              </a:rPr>
+              <a:t>Old bundle stays visible + notice</a:t>
+            </a:r>
+          </a:p>
+        </p:txBody>
+      </p:sp>
+      <p:sp>
+        <p:nvSpPr>
+          <p:cNvPr id="8" name="Box: Longitudinal communication"/>
+          <p:cNvSpPr/>
+          <p:nvPr/>
+        </p:nvSpPr>
+        <p:spPr>
+          <a:xfrm>
+            <a:off x="3346450" y="3048000"/>
+            <a:ext cx="2660650" cy="1270000"/>
+          </a:xfrm>
+          <a:prstGeom prst="roundRect">
+            <a:avLst>
+              <a:gd name="adj" fmla="val 11000"/>
+            </a:avLst>
+          </a:prstGeom>
+          <a:solidFill>
+            <a:srgbClr val="DCEEF7"/>
+          </a:solidFill>
+          <a:ln>
+            <a:noFill/>
+          </a:ln>
+        </p:spPr>
+        <p:txBody>
+          <a:bodyPr rtlCol="0" anchor="t" wrap="square" lIns="152400" rIns="152400" tIns="152400" bIns="152400"/>
+          <a:lstStyle/>
+          <a:p>
+            <a:pPr algn="l">
+              <a:spcAft>
+                <a:spcPts val="607"/>
+              </a:spcAft>
+            </a:pPr>
+            <a:r>
+              <a:rPr sz="1350" b="1">
+                <a:solidFill>
+                  <a:srgbClr val="2A2320"/>
+                </a:solidFill>
+                <a:latin typeface="Nunito"/>
+              </a:rPr>
+              <a:t>Longitudinal communication</a:t>
+            </a:r>
+          </a:p>
+          <a:p>
+            <a:pPr algn="l">
+              <a:spcAft>
+                <a:spcPts val="275"/>
+              </a:spcAft>
+            </a:pPr>
+            <a:r>
+              <a:rPr sz="1100" b="0">
+                <a:solidFill>
+                  <a:srgbClr val="2A2320"/>
+                </a:solidFill>
+                <a:latin typeface="Nunito"/>
+              </a:rPr>
+              <a:t>Stay quiet / check in / clarify</a:t>
+            </a:r>
+          </a:p>
+          <a:p>
+            <a:pPr algn="l">
+              <a:spcAft>
+                <a:spcPts val="275"/>
+              </a:spcAft>
+            </a:pPr>
+            <a:r>
+              <a:rPr sz="1100" b="0">
+                <a:solidFill>
+                  <a:srgbClr val="2A2320"/>
+                </a:solidFill>
+                <a:latin typeface="Nunito"/>
+              </a:rPr>
+              <a:t>Describes personal changes</a:t>
+            </a:r>
+          </a:p>
+        </p:txBody>
+      </p:sp>
+      <p:sp>
+        <p:nvSpPr>
+          <p:cNvPr id="9" name="Box: Safety overrides ordinary messages"/>
+          <p:cNvSpPr/>
+          <p:nvPr/>
+        </p:nvSpPr>
+        <p:spPr>
+          <a:xfrm>
+            <a:off x="6184900" y="3048000"/>
+            <a:ext cx="2660650" cy="1270000"/>
+          </a:xfrm>
+          <a:prstGeom prst="roundRect">
+            <a:avLst>
+              <a:gd name="adj" fmla="val 11000"/>
+            </a:avLst>
+          </a:prstGeom>
+          <a:solidFill>
+            <a:srgbClr val="FDE3DF"/>
+          </a:solidFill>
+          <a:ln>
+            <a:noFill/>
+          </a:ln>
+        </p:spPr>
+        <p:txBody>
+          <a:bodyPr rtlCol="0" anchor="t" wrap="square" lIns="152400" rIns="152400" tIns="152400" bIns="152400"/>
+          <a:lstStyle/>
+          <a:p>
+            <a:pPr algn="l">
+              <a:spcAft>
+                <a:spcPts val="562"/>
+              </a:spcAft>
+            </a:pPr>
+            <a:r>
+              <a:rPr sz="1250" b="1">
+                <a:solidFill>
+                  <a:srgbClr val="2A2320"/>
+                </a:solidFill>
+                <a:latin typeface="Nunito"/>
+              </a:rPr>
+              <a:t>Safety overrides ordinary messages</a:t>
+            </a:r>
+          </a:p>
+          <a:p>
+            <a:pPr algn="l">
+              <a:spcAft>
+                <a:spcPts val="275"/>
+              </a:spcAft>
+            </a:pPr>
+            <a:r>
+              <a:rPr sz="1100" b="0">
+                <a:solidFill>
+                  <a:srgbClr val="2A2320"/>
+                </a:solidFill>
+                <a:latin typeface="Nunito"/>
+              </a:rPr>
+              <a:t>Applies the authoritative state</a:t>
+            </a:r>
+          </a:p>
+          <a:p>
+            <a:pPr algn="l">
+              <a:spcAft>
+                <a:spcPts val="275"/>
+              </a:spcAft>
+            </a:pPr>
+            <a:r>
+              <a:rPr sz="1100" b="0">
+                <a:solidFill>
+                  <a:srgbClr val="2A2320"/>
+                </a:solidFill>
+                <a:latin typeface="Nunito"/>
+              </a:rPr>
+              <a:t>The app does not assign tiers</a:t>
+            </a:r>
+          </a:p>
+        </p:txBody>
+      </p:sp>
+      <p:sp>
+        <p:nvSpPr>
+          <p:cNvPr id="10" name="Box: Pinned safety resources"/>
+          <p:cNvSpPr/>
+          <p:nvPr/>
+        </p:nvSpPr>
+        <p:spPr>
+          <a:xfrm>
+            <a:off x="9023350" y="3048000"/>
+            <a:ext cx="2660650" cy="1270000"/>
+          </a:xfrm>
+          <a:prstGeom prst="roundRect">
+            <a:avLst>
+              <a:gd name="adj" fmla="val 11000"/>
+            </a:avLst>
+          </a:prstGeom>
+          <a:solidFill>
+            <a:srgbClr val="FDE3DF"/>
+          </a:solidFill>
+          <a:ln>
+            <a:noFill/>
+          </a:ln>
+        </p:spPr>
+        <p:txBody>
+          <a:bodyPr rtlCol="0" anchor="t" wrap="square" lIns="152400" rIns="152400" tIns="152400" bIns="152400"/>
+          <a:lstStyle/>
+          <a:p>
+            <a:pPr algn="l">
+              <a:spcAft>
+                <a:spcPts val="607"/>
+              </a:spcAft>
+            </a:pPr>
+            <a:r>
+              <a:rPr sz="1350" b="1">
+                <a:solidFill>
+                  <a:srgbClr val="2A2320"/>
+                </a:solidFill>
+                <a:latin typeface="Nunito"/>
+              </a:rPr>
+              <a:t>Pinned safety resources</a:t>
+            </a:r>
+          </a:p>
+          <a:p>
+            <a:pPr algn="l">
+              <a:spcAft>
+                <a:spcPts val="275"/>
+              </a:spcAft>
+            </a:pPr>
+            <a:r>
+              <a:rPr sz="1100" b="0">
+                <a:solidFill>
+                  <a:srgbClr val="2A2320"/>
+                </a:solidFill>
+                <a:latin typeface="Nunito"/>
+              </a:rPr>
+              <a:t>Shown outside generated text</a:t>
+            </a:r>
+          </a:p>
+          <a:p>
+            <a:pPr algn="l">
+              <a:spcAft>
+                <a:spcPts val="275"/>
+              </a:spcAft>
+            </a:pPr>
+            <a:r>
+              <a:rPr sz="1100" b="0">
+                <a:solidFill>
+                  <a:srgbClr val="2A2320"/>
+                </a:solidFill>
+                <a:latin typeface="Nunito"/>
+              </a:rPr>
+              <a:t>Never waits for an AI model</a:t>
+            </a:r>
+          </a:p>
+        </p:txBody>
+      </p:sp>
+      <p:sp>
+        <p:nvSpPr>
+          <p:cNvPr id="11" name="Box: Render the allowed interaction"/>
+          <p:cNvSpPr/>
+          <p:nvPr/>
+        </p:nvSpPr>
+        <p:spPr>
+          <a:xfrm>
+            <a:off x="6184900" y="4826000"/>
+            <a:ext cx="2660650" cy="1333500"/>
+          </a:xfrm>
+          <a:prstGeom prst="roundRect">
+            <a:avLst>
+              <a:gd name="adj" fmla="val 10476"/>
+            </a:avLst>
+          </a:prstGeom>
+          <a:solidFill>
+            <a:srgbClr val="F3F0EA"/>
+          </a:solidFill>
+          <a:ln>
+            <a:noFill/>
+          </a:ln>
+        </p:spPr>
+        <p:txBody>
+          <a:bodyPr rtlCol="0" anchor="t" wrap="square" lIns="152400" rIns="152400" tIns="152400" bIns="152400"/>
+          <a:lstStyle/>
+          <a:p>
+            <a:pPr algn="l">
+              <a:spcAft>
+                <a:spcPts val="607"/>
+              </a:spcAft>
+            </a:pPr>
+            <a:r>
+              <a:rPr sz="1350" b="1">
+                <a:solidFill>
+                  <a:srgbClr val="2A2320"/>
+                </a:solidFill>
+                <a:latin typeface="Nunito"/>
+              </a:rPr>
+              <a:t>Render the allowed interaction</a:t>
+            </a:r>
+          </a:p>
+          <a:p>
+            <a:pPr algn="l">
+              <a:spcAft>
+                <a:spcPts val="262"/>
+              </a:spcAft>
+            </a:pPr>
+            <a:r>
+              <a:rPr sz="1050" b="0">
+                <a:solidFill>
+                  <a:srgbClr val="2A2320"/>
+                </a:solidFill>
+                <a:latin typeface="Nunito"/>
+              </a:rPr>
+              <a:t>Approved wording + checks</a:t>
+            </a:r>
+          </a:p>
+          <a:p>
+            <a:pPr algn="l">
+              <a:spcAft>
+                <a:spcPts val="262"/>
+              </a:spcAft>
+            </a:pPr>
+            <a:r>
+              <a:rPr sz="1050" b="0">
+                <a:solidFill>
+                  <a:srgbClr val="2A2320"/>
+                </a:solidFill>
+                <a:latin typeface="Nunito"/>
+              </a:rPr>
+              <a:t>T4 / offline: fixed text, no AI</a:t>
+            </a:r>
+          </a:p>
+        </p:txBody>
+      </p:sp>
+      <p:cxnSp>
+        <p:nvCxnSpPr>
+          <p:cNvPr id="12" name="Arrow: Patient input → Safety gate + propos"/>
+          <p:cNvCxnSpPr>
+            <a:stCxn id="4" idx="3"/>
+            <a:endCxn id="5" idx="1"/>
+          </p:cNvCxnSpPr>
+          <p:nvPr/>
+        </p:nvCxnSpPr>
+        <p:spPr>
+          <a:xfrm>
+            <a:off x="3168650" y="1905000"/>
+            <a:ext cx="177800" cy="1"/>
+          </a:xfrm>
+          <a:prstGeom prst="line">
+            <a:avLst/>
+          </a:prstGeom>
+          <a:ln w="25400">
+            <a:solidFill>
+              <a:srgbClr val="6B6258"/>
+            </a:solidFill>
+            <a:tailEnd type="triangle" w="med" len="med"/>
+          </a:ln>
+        </p:spPr>
+      </p:cxnSp>
+      <p:cxnSp>
+        <p:nvCxnSpPr>
+          <p:cNvPr id="13" name="Arrow: Safety gate + propos → Deterministic safety"/>
+          <p:cNvCxnSpPr>
+            <a:stCxn id="5" idx="3"/>
+            <a:endCxn id="6" idx="1"/>
+          </p:cNvCxnSpPr>
+          <p:nvPr/>
+        </p:nvCxnSpPr>
+        <p:spPr>
+          <a:xfrm>
+            <a:off x="6007100" y="1905000"/>
+            <a:ext cx="177800" cy="1"/>
+          </a:xfrm>
+          <a:prstGeom prst="line">
+            <a:avLst/>
+          </a:prstGeom>
+          <a:ln w="25400">
+            <a:solidFill>
+              <a:srgbClr val="6B6258"/>
+            </a:solidFill>
+            <a:tailEnd type="triangle" w="med" len="med"/>
+          </a:ln>
+        </p:spPr>
+      </p:cxnSp>
+      <p:cxnSp>
+        <p:nvCxnSpPr>
+          <p:cNvPr id="14" name="Arrow: Deterministic safety → Registry + built-in "/>
+          <p:cNvCxnSpPr>
+            <a:stCxn id="6" idx="3"/>
+            <a:endCxn id="7" idx="1"/>
+          </p:cNvCxnSpPr>
+          <p:nvPr/>
+        </p:nvCxnSpPr>
+        <p:spPr>
+          <a:xfrm>
+            <a:off x="8845550" y="1905000"/>
+            <a:ext cx="177800" cy="1"/>
+          </a:xfrm>
+          <a:prstGeom prst="line">
+            <a:avLst/>
+          </a:prstGeom>
+          <a:ln w="25400">
+            <a:solidFill>
+              <a:srgbClr val="6B6258"/>
+            </a:solidFill>
+            <a:tailEnd type="triangle" w="med" len="med"/>
+          </a:ln>
+        </p:spPr>
+      </p:cxnSp>
+      <p:cxnSp>
+        <p:nvCxnSpPr>
+          <p:cNvPr id="15" name="Arrow: Deterministic safety → Safety overrides ord"/>
+          <p:cNvCxnSpPr>
+            <a:stCxn id="6" idx="2"/>
+            <a:endCxn id="9" idx="0"/>
+          </p:cNvCxnSpPr>
+          <p:nvPr/>
+        </p:nvCxnSpPr>
+        <p:spPr>
+          <a:xfrm>
+            <a:off x="7515225" y="2540000"/>
+            <a:ext cx="1" cy="508000"/>
+          </a:xfrm>
+          <a:prstGeom prst="line">
+            <a:avLst/>
+          </a:prstGeom>
+          <a:ln w="25400">
+            <a:solidFill>
+              <a:srgbClr val="6B6258"/>
+            </a:solidFill>
+            <a:tailEnd type="triangle" w="med" len="med"/>
+          </a:ln>
+        </p:spPr>
+      </p:cxnSp>
+      <p:cxnSp>
+        <p:nvCxnSpPr>
+          <p:cNvPr id="16" name="Arrow: Longitudinal communi → Safety overrides ord"/>
+          <p:cNvCxnSpPr>
+            <a:stCxn id="8" idx="3"/>
+            <a:endCxn id="9" idx="1"/>
+          </p:cNvCxnSpPr>
+          <p:nvPr/>
+        </p:nvCxnSpPr>
+        <p:spPr>
+          <a:xfrm>
+            <a:off x="6007100" y="3683000"/>
+            <a:ext cx="177800" cy="1"/>
+          </a:xfrm>
+          <a:prstGeom prst="line">
+            <a:avLst/>
+          </a:prstGeom>
+          <a:ln w="25400">
+            <a:solidFill>
+              <a:srgbClr val="6B6258"/>
+            </a:solidFill>
+            <a:tailEnd type="triangle" w="med" len="med"/>
+          </a:ln>
+        </p:spPr>
+      </p:cxnSp>
+      <p:cxnSp>
+        <p:nvCxnSpPr>
+          <p:cNvPr id="17" name="Arrow: Registry + built-in  → Pinned safety resour"/>
+          <p:cNvCxnSpPr>
+            <a:stCxn id="7" idx="2"/>
+            <a:endCxn id="10" idx="0"/>
+          </p:cNvCxnSpPr>
+          <p:nvPr/>
+        </p:nvCxnSpPr>
+        <p:spPr>
+          <a:xfrm>
+            <a:off x="10353675" y="2540000"/>
+            <a:ext cx="1" cy="508000"/>
+          </a:xfrm>
+          <a:prstGeom prst="line">
+            <a:avLst/>
+          </a:prstGeom>
+          <a:ln w="25400">
+            <a:solidFill>
+              <a:srgbClr val="6B6258"/>
+            </a:solidFill>
+            <a:tailEnd type="triangle" w="med" len="med"/>
+          </a:ln>
+        </p:spPr>
+      </p:cxnSp>
+      <p:cxnSp>
+        <p:nvCxnSpPr>
+          <p:cNvPr id="18" name="Arrow: Safety overrides ord → Render the allowed i"/>
+          <p:cNvCxnSpPr>
+            <a:stCxn id="9" idx="2"/>
+            <a:endCxn id="11" idx="0"/>
+          </p:cNvCxnSpPr>
+          <p:nvPr/>
+        </p:nvCxnSpPr>
+        <p:spPr>
+          <a:xfrm>
+            <a:off x="7515225" y="4318000"/>
+            <a:ext cx="1" cy="508000"/>
+          </a:xfrm>
+          <a:prstGeom prst="line">
+            <a:avLst/>
+          </a:prstGeom>
+          <a:ln w="25400">
+            <a:solidFill>
+              <a:srgbClr val="6B6258"/>
+            </a:solidFill>
+            <a:tailEnd type="triangle" w="med" len="med"/>
+          </a:ln>
+        </p:spPr>
+      </p:cxnSp>
+      <p:sp>
+        <p:nvSpPr>
+          <p:cNvPr id="19" name="Text: The patient can't dismiss safety content"/>
+          <p:cNvSpPr txBox="1"/>
+          <p:nvPr/>
+        </p:nvSpPr>
+        <p:spPr>
+          <a:xfrm>
+            <a:off x="508000" y="4826000"/>
+            <a:ext cx="5334000" cy="1206500"/>
+          </a:xfrm>
+          <a:prstGeom prst="rect">
+            <a:avLst/>
+          </a:prstGeom>
+          <a:noFill/>
+        </p:spPr>
+        <p:txBody>
+          <a:bodyPr wrap="square" anchor="t" lIns="0" rIns="0" tIns="0" bIns="0"/>
+          <a:lstStyle/>
+          <a:p>
+            <a:pPr algn="l">
+              <a:spcAft>
+                <a:spcPts val="540"/>
+              </a:spcAft>
+            </a:pPr>
+            <a:r>
+              <a:rPr sz="1200" b="0">
+                <a:solidFill>
+                  <a:srgbClr val="2A2320"/>
+                </a:solidFill>
+                <a:latin typeface="Nunito"/>
+              </a:rPr>
+              <a:t>The patient can't dismiss safety content. The clinician sees the same state when they open the record. No alerts are sent in this prototype.</a:t>
+            </a:r>
+          </a:p>
+          <a:p>
+            <a:pPr algn="l">
+              <a:spcAft>
+                <a:spcPts val="262"/>
+              </a:spcAft>
+            </a:pPr>
+            <a:r>
+              <a:rPr sz="1050" b="0">
+                <a:solidFill>
+                  <a:srgbClr val="6B6258"/>
+                </a:solidFill>
+                <a:latin typeface="Nunito"/>
+              </a:rPr>
+              <a:t>Engineering demonstration · resource content still needs review · no emergency monitoring or suicide-risk determination</a:t>
+            </a:r>
+          </a:p>
+        </p:txBody>
+      </p:sp>
     </p:spTree>
   </p:cSld>
   <p:clrMapOvr>

</xml_diff>

<commit_message>
docs: cover shows 'Healthcare track' only; 3-minute short cut assembler
Co-Authored-By: Claude Opus 5.5 <noreply@anthropic.com>
</commit_message>
<xml_diff>
--- a/docs/submission/assets/aura-health-deck.pptx
+++ b/docs/submission/assets/aura-health-deck.pptx
@@ -5091,14 +5091,14 @@
       </p:sp>
       <p:sp>
         <p:nvSpPr>
-          <p:cNvPr id="5" name="Text: Healthcare track · Challenge Statement 2"/>
+          <p:cNvPr id="5" name="Text: Healthcare track"/>
           <p:cNvSpPr txBox="1"/>
           <p:nvPr/>
         </p:nvSpPr>
         <p:spPr>
           <a:xfrm>
             <a:off x="939800" y="4225230"/>
-            <a:ext cx="4265168" cy="222250"/>
+            <a:ext cx="1332992" cy="222250"/>
           </a:xfrm>
           <a:prstGeom prst="rect">
             <a:avLst/>
@@ -5121,7 +5121,7 @@
                 </a:solidFill>
                 <a:latin typeface="Nunito"/>
               </a:rPr>
-              <a:t>Healthcare track · Challenge Statement 2 · Scenario 1</a:t>
+              <a:t>Healthcare track</a:t>
             </a:r>
           </a:p>
         </p:txBody>

</xml_diff>

<commit_message>
docs: reconcile architecture PDF with implementation and update handover
</commit_message>
<xml_diff>
--- a/docs/submission/assets/aura-health-deck.pptx
+++ b/docs/submission/assets/aura-health-deck.pptx
@@ -698,6 +698,11 @@
               <a:t>"Our rule: signals propose, rules decide, AI words it. Deterministic engines own the personal baselines and the safety state. Medication information is curated; AI only matches a question to an approved topic. The clinician agent investigates with read-only tools, and every answer passes number, date and citation checks plus an independent verifier. In this demo the model runs on synthetic data only; a hospital would run it on its own private infrastructure."</a:t>
             </a:r>
           </a:p>
+          <a:p>
+            <a:r>
+              <a:t>Architecture audit 2026-10-14: implementation 90e31ea. See docs/submission/ARCHITECTURE_REVIEW.md. The 90-s budget is checked between calls; resource rendering has no model, but patient-input assessment may use one.</a:t>
+            </a:r>
+          </a:p>
         </p:txBody>
       </p:sp>
       <p:sp>
@@ -786,6 +791,11 @@
               <a:t>"Our rule: signals propose, rules decide, AI words it. Deterministic engines own the personal baselines and the safety state. Medication information is curated; AI only matches a question to an approved topic. The clinician agent investigates with read-only tools, and every answer passes number, date and citation checks plus an independent verifier. In this demo the model runs on synthetic data only; a hospital would run it on its own private infrastructure."</a:t>
             </a:r>
           </a:p>
+          <a:p>
+            <a:r>
+              <a:t>Architecture audit 2026-10-14: implementation 90e31ea. See docs/submission/ARCHITECTURE_REVIEW.md. The 90-s budget is checked between calls; resource rendering has no model, but patient-input assessment may use one.</a:t>
+            </a:r>
+          </a:p>
         </p:txBody>
       </p:sp>
       <p:sp>
@@ -872,6 +882,11 @@
           <a:p>
             <a:r>
               <a:t>"Our rule: signals propose, rules decide, AI words it. Deterministic engines own the personal baselines and the safety state. Medication information is curated; AI only matches a question to an approved topic. The clinician agent investigates with read-only tools, and every answer passes number, date and citation checks plus an independent verifier. In this demo the model runs on synthetic data only; a hospital would run it on its own private infrastructure."</a:t>
+            </a:r>
+          </a:p>
+          <a:p>
+            <a:r>
+              <a:t>Architecture audit 2026-10-14: implementation 90e31ea. See docs/submission/ARCHITECTURE_REVIEW.md. The 90-s budget is checked between calls; resource rendering has no model, but patient-input assessment may use one.</a:t>
             </a:r>
           </a:p>
         </p:txBody>
@@ -5836,7 +5851,7 @@
             <a:srgbClr val="F3F0EA"/>
           </a:solidFill>
           <a:ln>
-            <a:noFill/>
+            <a:solidFill/>
           </a:ln>
         </p:spPr>
         <p:txBody>
@@ -5887,7 +5902,7 @@
                 </a:solidFill>
                 <a:latin typeface="Nunito"/>
               </a:rPr>
-              <a:t>Today's dose + reasons</a:t>
+              <a:t>Dose + reasons, medication</a:t>
             </a:r>
           </a:p>
           <a:p>
@@ -5903,7 +5918,7 @@
                 </a:solidFill>
                 <a:latin typeface="Nunito"/>
               </a:rPr>
-              <a:t>Medication, Coming up</a:t>
+              <a:t>Dates + optional suggestions</a:t>
             </a:r>
           </a:p>
         </p:txBody>
@@ -5928,7 +5943,7 @@
             <a:srgbClr val="F3F0EA"/>
           </a:solidFill>
           <a:ln>
-            <a:noFill/>
+            <a:solidFill/>
           </a:ln>
         </p:spPr>
         <p:txBody>
@@ -6041,7 +6056,7 @@
             <a:srgbClr val="DCEEF7"/>
           </a:solidFill>
           <a:ln>
-            <a:noFill/>
+            <a:solidFill/>
           </a:ln>
         </p:spPr>
         <p:txBody>
@@ -6076,7 +6091,7 @@
                 </a:solidFill>
                 <a:latin typeface="Nunito"/>
               </a:rPr>
-              <a:t>Consent, atomic events · SQLite repository</a:t>
+              <a:t>Atomic + idempotent events · SQLite + audit</a:t>
             </a:r>
           </a:p>
         </p:txBody>
@@ -6101,7 +6116,7 @@
             <a:srgbClr val="DCEEF7"/>
           </a:solidFill>
           <a:ln>
-            <a:noFill/>
+            <a:solidFill/>
           </a:ln>
         </p:spPr>
         <p:txBody>
@@ -6161,7 +6176,7 @@
             <a:srgbClr val="FDE3DF"/>
           </a:solidFill>
           <a:ln>
-            <a:noFill/>
+            <a:solidFill/>
           </a:ln>
         </p:spPr>
         <p:txBody>
@@ -6221,7 +6236,7 @@
             <a:srgbClr val="DCEEF7"/>
           </a:solidFill>
           <a:ln>
-            <a:noFill/>
+            <a:solidFill/>
           </a:ln>
         </p:spPr>
         <p:txBody>
@@ -6281,7 +6296,7 @@
             <a:srgbClr val="E8E1F3"/>
           </a:solidFill>
           <a:ln>
-            <a:noFill/>
+            <a:solidFill/>
           </a:ln>
         </p:spPr>
         <p:txBody>
@@ -6323,7 +6338,7 @@
       </p:sp>
       <p:sp>
         <p:nvSpPr>
-          <p:cNvPr id="15" name="Box: Ground → verify → recheck"/>
+          <p:cNvPr id="15" name="Box: Ground · verify · recheck"/>
           <p:cNvSpPr/>
           <p:nvPr/>
         </p:nvSpPr>
@@ -6341,7 +6356,7 @@
             <a:srgbClr val="E8E1F3"/>
           </a:solidFill>
           <a:ln>
-            <a:noFill/>
+            <a:solidFill/>
           </a:ln>
         </p:spPr>
         <p:txBody>
@@ -6360,7 +6375,7 @@
                 </a:solidFill>
                 <a:latin typeface="Nunito"/>
               </a:rPr>
-              <a:t>Ground → verify → recheck</a:t>
+              <a:t>Ground · verify · recheck</a:t>
             </a:r>
           </a:p>
           <a:p>
@@ -6470,7 +6485,7 @@
             <a:srgbClr val="FDE3DF"/>
           </a:solidFill>
           <a:ln>
-            <a:noFill/>
+            <a:solidFill/>
           </a:ln>
         </p:spPr>
         <p:txBody>
@@ -6546,7 +6561,7 @@
             <a:srgbClr val="FFF0D0"/>
           </a:solidFill>
           <a:ln>
-            <a:noFill/>
+            <a:solidFill/>
           </a:ln>
         </p:spPr>
         <p:txBody>
@@ -6581,7 +6596,7 @@
                 </a:solidFill>
                 <a:latin typeface="Nunito"/>
               </a:rPr>
-              <a:t>Plans → seeded synthetic data</a:t>
+              <a:t>Plans + seeded synthetic data</a:t>
             </a:r>
           </a:p>
           <a:p>
@@ -6649,13 +6664,14 @@
             <a:solidFill>
               <a:srgbClr val="6B6258"/>
             </a:solidFill>
+            <a:headEnd type="triangle" w="med" len="med"/>
             <a:tailEnd type="triangle" w="med" len="med"/>
           </a:ln>
         </p:spPr>
       </p:cxnSp>
       <p:cxnSp>
         <p:nvCxnSpPr>
-          <p:cNvPr id="21" name="Arrow: Aura-Agent + patient → Ground → verify → re"/>
+          <p:cNvPr id="21" name="Arrow: Aura-Agent + patient → Ground · verify · re"/>
           <p:cNvCxnSpPr>
             <a:stCxn id="14" idx="2"/>
             <a:endCxn id="15" idx="0"/>
@@ -6738,8 +6754,8 @@
         </p:nvSpPr>
         <p:spPr>
           <a:xfrm>
-            <a:off x="2819400" y="2540000"/>
-            <a:ext cx="457200" cy="190500"/>
+            <a:off x="2806700" y="2476500"/>
+            <a:ext cx="482600" cy="368300"/>
           </a:xfrm>
           <a:prstGeom prst="rect">
             <a:avLst/>
@@ -6752,11 +6768,11 @@
           <a:p>
             <a:pPr algn="ctr">
               <a:spcAft>
-                <a:spcPts val="405"/>
+                <a:spcPts val="360"/>
               </a:spcAft>
             </a:pPr>
             <a:r>
-              <a:rPr sz="900" b="0">
+              <a:rPr sz="800" b="0">
                 <a:solidFill>
                   <a:srgbClr val="6B6258"/>
                 </a:solidFill>
@@ -6765,48 +6781,117 @@
               <a:t>inputs</a:t>
             </a:r>
           </a:p>
-        </p:txBody>
-      </p:sp>
-      <p:sp>
-        <p:nvSpPr>
-          <p:cNvPr id="25" name="Text: reads"/>
-          <p:cNvSpPr txBox="1"/>
-          <p:nvPr/>
-        </p:nvSpPr>
-        <p:spPr>
-          <a:xfrm>
-            <a:off x="7124700" y="2540000"/>
-            <a:ext cx="482600" cy="190500"/>
-          </a:xfrm>
-          <a:prstGeom prst="rect">
-            <a:avLst/>
-          </a:prstGeom>
-          <a:noFill/>
-        </p:spPr>
-        <p:txBody>
-          <a:bodyPr wrap="square" anchor="t" lIns="0" rIns="0" tIns="0" bIns="0"/>
-          <a:lstStyle/>
           <a:p>
             <a:pPr algn="ctr">
               <a:spcAft>
-                <a:spcPts val="405"/>
+                <a:spcPts val="200"/>
               </a:spcAft>
             </a:pPr>
             <a:r>
-              <a:rPr sz="900" b="0">
+              <a:rPr sz="800" b="0">
                 <a:solidFill>
                   <a:srgbClr val="6B6258"/>
                 </a:solidFill>
                 <a:latin typeface="Nunito"/>
               </a:rPr>
-              <a:t>reads</a:t>
-            </a:r>
-          </a:p>
-        </p:txBody>
-      </p:sp>
-      <p:sp>
-        <p:nvSpPr>
-          <p:cNvPr id="26" name="Text: Signals propose. Rules decide. AI words "/>
+              <a:t>views</a:t>
+            </a:r>
+          </a:p>
+        </p:txBody>
+      </p:sp>
+      <p:sp>
+        <p:nvSpPr>
+          <p:cNvPr id="25" name="Text: request"/>
+          <p:cNvSpPr txBox="1"/>
+          <p:nvPr/>
+        </p:nvSpPr>
+        <p:spPr>
+          <a:xfrm>
+            <a:off x="7124700" y="2463800"/>
+            <a:ext cx="482600" cy="406400"/>
+          </a:xfrm>
+          <a:prstGeom prst="rect">
+            <a:avLst/>
+          </a:prstGeom>
+          <a:noFill/>
+        </p:spPr>
+        <p:txBody>
+          <a:bodyPr wrap="square" anchor="t" lIns="0" rIns="0" tIns="0" bIns="0"/>
+          <a:lstStyle/>
+          <a:p>
+            <a:pPr algn="ctr">
+              <a:spcAft>
+                <a:spcPts val="360"/>
+              </a:spcAft>
+            </a:pPr>
+            <a:r>
+              <a:rPr sz="800" b="0">
+                <a:solidFill>
+                  <a:srgbClr val="6B6258"/>
+                </a:solidFill>
+                <a:latin typeface="Nunito"/>
+              </a:rPr>
+              <a:t>request</a:t>
+            </a:r>
+          </a:p>
+          <a:p>
+            <a:pPr algn="ctr">
+              <a:spcAft>
+                <a:spcPts val="200"/>
+              </a:spcAft>
+            </a:pPr>
+            <a:r>
+              <a:rPr sz="800" b="0">
+                <a:solidFill>
+                  <a:srgbClr val="6B6258"/>
+                </a:solidFill>
+                <a:latin typeface="Nunito"/>
+              </a:rPr>
+              <a:t>result</a:t>
+            </a:r>
+          </a:p>
+        </p:txBody>
+      </p:sp>
+      <p:sp>
+        <p:nvSpPr>
+          <p:cNvPr id="26" name="Text: Observable events via app ingestion"/>
+          <p:cNvSpPr txBox="1"/>
+          <p:nvPr/>
+        </p:nvSpPr>
+        <p:spPr>
+          <a:xfrm>
+            <a:off x="5346700" y="4394200"/>
+            <a:ext cx="2794000" cy="228600"/>
+          </a:xfrm>
+          <a:prstGeom prst="rect">
+            <a:avLst/>
+          </a:prstGeom>
+          <a:noFill/>
+        </p:spPr>
+        <p:txBody>
+          <a:bodyPr wrap="square" anchor="t" lIns="0" rIns="0" tIns="0" bIns="0"/>
+          <a:lstStyle/>
+          <a:p>
+            <a:pPr algn="l">
+              <a:spcAft>
+                <a:spcPts val="427"/>
+              </a:spcAft>
+            </a:pPr>
+            <a:r>
+              <a:rPr sz="950" b="0">
+                <a:solidFill>
+                  <a:srgbClr val="6B6258"/>
+                </a:solidFill>
+                <a:latin typeface="Nunito"/>
+              </a:rPr>
+              <a:t>Observable events via app ingestion</a:t>
+            </a:r>
+          </a:p>
+        </p:txBody>
+      </p:sp>
+      <p:sp>
+        <p:nvSpPr>
+          <p:cNvPr id="27" name="Text: Signals propose. Rules decide. AI words "/>
           <p:cNvSpPr txBox="1"/>
           <p:nvPr/>
         </p:nvSpPr>
@@ -6843,14 +6928,14 @@
       </p:sp>
       <p:sp>
         <p:nvSpPr>
-          <p:cNvPr id="27" name="Text: Implemented demo · one application deplo"/>
+          <p:cNvPr id="28" name="Text: One application · synthetic workspaces ·"/>
           <p:cNvSpPr txBox="1"/>
           <p:nvPr/>
         </p:nvSpPr>
         <p:spPr>
           <a:xfrm>
             <a:off x="8636000" y="4826000"/>
-            <a:ext cx="3048000" cy="1143000"/>
+            <a:ext cx="3048000" cy="1587500"/>
           </a:xfrm>
           <a:prstGeom prst="rect">
             <a:avLst/>
@@ -6873,7 +6958,39 @@
                 </a:solidFill>
                 <a:latin typeface="Nunito"/>
               </a:rPr>
-              <a:t>Implemented demo · one application deployment · development storage · institutional hosting is future work</a:t>
+              <a:t>One application · synthetic workspaces · development storage</a:t>
+            </a:r>
+          </a:p>
+          <a:p>
+            <a:pPr algn="l">
+              <a:spcAft>
+                <a:spcPts val="262"/>
+              </a:spcAft>
+            </a:pPr>
+            <a:r>
+              <a:rPr sz="1050" b="0">
+                <a:solidFill>
+                  <a:srgbClr val="6B6258"/>
+                </a:solidFill>
+                <a:latin typeface="Nunito"/>
+              </a:rPr>
+              <a:t>Demo roles, no clinical authentication. Visit preview: Not sent.</a:t>
+            </a:r>
+          </a:p>
+          <a:p>
+            <a:pPr algn="l">
+              <a:spcAft>
+                <a:spcPts val="262"/>
+              </a:spcAft>
+            </a:pPr>
+            <a:r>
+              <a:rPr sz="1050" b="0">
+                <a:solidFill>
+                  <a:srgbClr val="6B6258"/>
+                </a:solidFill>
+                <a:latin typeface="Nunito"/>
+              </a:rPr>
+              <a:t>Institutional hosting is future work</a:t>
             </a:r>
           </a:p>
         </p:txBody>
@@ -6980,7 +7097,7 @@
       </p:sp>
       <p:sp>
         <p:nvSpPr>
-          <p:cNvPr id="4" name="Box: 1 · Approve the request"/>
+          <p:cNvPr id="4" name="Box: 1 · Guard the request"/>
           <p:cNvSpPr/>
           <p:nvPr/>
         </p:nvSpPr>
@@ -6998,7 +7115,7 @@
             <a:srgbClr val="DCEEF7"/>
           </a:solidFill>
           <a:ln>
-            <a:noFill/>
+            <a:solidFill/>
           </a:ln>
         </p:spPr>
         <p:txBody>
@@ -7017,7 +7134,7 @@
                 </a:solidFill>
                 <a:latin typeface="Nunito"/>
               </a:rPr>
-              <a:t>1 · Approve the request</a:t>
+              <a:t>1 · Guard the request</a:t>
             </a:r>
           </a:p>
           <a:p>
@@ -7074,7 +7191,7 @@
             <a:srgbClr val="E8E1F3"/>
           </a:solidFill>
           <a:ln>
-            <a:noFill/>
+            <a:solidFill/>
           </a:ln>
         </p:spPr>
         <p:txBody>
@@ -7150,7 +7267,7 @@
             <a:srgbClr val="DCEEF7"/>
           </a:solidFill>
           <a:ln>
-            <a:noFill/>
+            <a:solidFill/>
           </a:ln>
         </p:spPr>
         <p:txBody>
@@ -7226,7 +7343,7 @@
             <a:srgbClr val="F3F0EA"/>
           </a:solidFill>
           <a:ln>
-            <a:noFill/>
+            <a:solidFill/>
           </a:ln>
         </p:spPr>
         <p:txBody>
@@ -7286,7 +7403,7 @@
             <a:srgbClr val="E8E1F3"/>
           </a:solidFill>
           <a:ln>
-            <a:noFill/>
+            <a:solidFill/>
           </a:ln>
         </p:spPr>
         <p:txBody>
@@ -7337,7 +7454,7 @@
                 </a:solidFill>
                 <a:latin typeface="Nunito"/>
               </a:rPr>
-              <a:t>A separate model call checks each statement</a:t>
+              <a:t>Live drafts: separate verification call</a:t>
             </a:r>
           </a:p>
         </p:txBody>
@@ -7362,7 +7479,7 @@
             <a:srgbClr val="DCEEF7"/>
           </a:solidFill>
           <a:ln>
-            <a:noFill/>
+            <a:solidFill/>
           </a:ln>
         </p:spPr>
         <p:txBody>
@@ -7397,7 +7514,7 @@
                 </a:solidFill>
                 <a:latin typeface="Nunito"/>
               </a:rPr>
-              <a:t>Has the record or safety state changed?</a:t>
+              <a:t>Record, safety + provider revision</a:t>
             </a:r>
           </a:p>
           <a:p>
@@ -7438,7 +7555,7 @@
             <a:srgbClr val="F3F0EA"/>
           </a:solidFill>
           <a:ln>
-            <a:noFill/>
+            <a:solidFill/>
           </a:ln>
         </p:spPr>
         <p:txBody>
@@ -7496,7 +7613,7 @@
       </p:sp>
       <p:cxnSp>
         <p:nvCxnSpPr>
-          <p:cNvPr id="11" name="Arrow: “When did sleep timi → 1 · Approve the requ"/>
+          <p:cNvPr id="11" name="Arrow: “When did sleep timi → 1 · Guard the reques"/>
           <p:cNvCxnSpPr>
             <a:stCxn id="7" idx="0"/>
             <a:endCxn id="4" idx="2"/>
@@ -7521,7 +7638,7 @@
       </p:cxnSp>
       <p:cxnSp>
         <p:nvCxnSpPr>
-          <p:cNvPr id="12" name="Arrow: 1 · Approve the requ → 2 · Model chooses a "/>
+          <p:cNvPr id="12" name="Arrow: 1 · Guard the reques → 2 · Model chooses a "/>
           <p:cNvCxnSpPr>
             <a:stCxn id="4" idx="3"/>
             <a:endCxn id="5" idx="1"/>
@@ -7753,7 +7870,7 @@
       </p:sp>
       <p:sp>
         <p:nvSpPr>
-          <p:cNvPr id="19" name="Text: Limits per answer: 8 model steps · 24 to"/>
+          <p:cNvPr id="19" name="Text: Loop budgets: 8 model steps · 24 tool ca"/>
           <p:cNvSpPr txBox="1"/>
           <p:nvPr/>
         </p:nvSpPr>
@@ -7783,21 +7900,21 @@
                 </a:solidFill>
                 <a:latin typeface="Nunito"/>
               </a:rPr>
-              <a:t>Limits per answer: 8 model steps · 24 tool calls · 90 seconds</a:t>
-            </a:r>
-          </a:p>
-        </p:txBody>
-      </p:sp>
-      <p:sp>
-        <p:nvSpPr>
-          <p:cNvPr id="20" name="Text: Failure shows source-based related facts"/>
+              <a:t>Loop budgets: 8 model steps · 24 tool calls · 90 seconds</a:t>
+            </a:r>
+          </a:p>
+        </p:txBody>
+      </p:sp>
+      <p:sp>
+        <p:nvSpPr>
+          <p:cNvPr id="20" name="Text: Time checked between calls; provider tim"/>
           <p:cNvSpPr txBox="1"/>
           <p:nvPr/>
         </p:nvSpPr>
         <p:spPr>
           <a:xfrm>
             <a:off x="508000" y="5156200"/>
-            <a:ext cx="7493000" cy="762000"/>
+            <a:ext cx="7493000" cy="1270000"/>
           </a:xfrm>
           <a:prstGeom prst="rect">
             <a:avLst/>
@@ -7820,7 +7937,7 @@
                 </a:solidFill>
                 <a:latin typeface="Nunito"/>
               </a:rPr>
-              <a:t>Failure shows source-based related facts and says so. The trail shows actions, not hidden reasoning.</a:t>
+              <a:t>Time checked between calls; provider timeout 30 s. Verifier is separate.</a:t>
             </a:r>
           </a:p>
           <a:p>
@@ -7836,7 +7953,23 @@
                 </a:solidFill>
                 <a:latin typeface="Nunito"/>
               </a:rPr>
-              <a:t>Verification is not clinical validation.</a:t>
+              <a:t>Failed drafts use related facts when available; blocked/stale requests show no answer.</a:t>
+            </a:r>
+          </a:p>
+          <a:p>
+            <a:pPr algn="l">
+              <a:spcAft>
+                <a:spcPts val="275"/>
+              </a:spcAft>
+            </a:pPr>
+            <a:r>
+              <a:rPr sz="1100" b="0">
+                <a:solidFill>
+                  <a:srgbClr val="6B6258"/>
+                </a:solidFill>
+                <a:latin typeface="Nunito"/>
+              </a:rPr>
+              <a:t>The trail shows actions, not hidden reasoning. Verification is not clinical validation.</a:t>
             </a:r>
           </a:p>
         </p:txBody>
@@ -7961,7 +8094,7 @@
             <a:srgbClr val="F3F0EA"/>
           </a:solidFill>
           <a:ln>
-            <a:noFill/>
+            <a:solidFill/>
           </a:ln>
         </p:spPr>
         <p:txBody>
@@ -8037,7 +8170,7 @@
             <a:srgbClr val="E8E1F3"/>
           </a:solidFill>
           <a:ln>
-            <a:noFill/>
+            <a:solidFill/>
           </a:ln>
         </p:spPr>
         <p:txBody>
@@ -8072,7 +8205,7 @@
                 </a:solidFill>
                 <a:latin typeface="Nunito"/>
               </a:rPr>
-              <a:t>Rules / demo classifier → signals</a:t>
+              <a:t>Demo fixtures or rules + model</a:t>
             </a:r>
           </a:p>
           <a:p>
@@ -8088,7 +8221,7 @@
                 </a:solidFill>
                 <a:latin typeface="Nunito"/>
               </a:rPr>
-              <a:t>A detector cannot lower safety state</a:t>
+              <a:t>Raise-only detector proposals</a:t>
             </a:r>
           </a:p>
         </p:txBody>
@@ -8113,7 +8246,7 @@
             <a:srgbClr val="FDE3DF"/>
           </a:solidFill>
           <a:ln>
-            <a:noFill/>
+            <a:solidFill/>
           </a:ln>
         </p:spPr>
         <p:txBody>
@@ -8148,7 +8281,7 @@
                 </a:solidFill>
                 <a:latin typeface="Nunito"/>
               </a:rPr>
-              <a:t>T0–T4 transitions → actions</a:t>
+              <a:t>T0–T4 transitions and actions</a:t>
             </a:r>
           </a:p>
           <a:p>
@@ -8189,7 +8322,7 @@
             <a:srgbClr val="FDE3DF"/>
           </a:solidFill>
           <a:ln>
-            <a:noFill/>
+            <a:solidFill/>
           </a:ln>
         </p:spPr>
         <p:txBody>
@@ -8224,7 +8357,7 @@
                 </a:solidFill>
                 <a:latin typeface="Nunito"/>
               </a:rPr>
-              <a:t>Lookup failure → fallback</a:t>
+              <a:t>Lookup failure: built-in fallback</a:t>
             </a:r>
           </a:p>
           <a:p>
@@ -8240,7 +8373,7 @@
                 </a:solidFill>
                 <a:latin typeface="Nunito"/>
               </a:rPr>
-              <a:t>Old bundle stays visible + notice</a:t>
+              <a:t>Stale/unverified: visible + notice</a:t>
             </a:r>
           </a:p>
         </p:txBody>
@@ -8265,7 +8398,7 @@
             <a:srgbClr val="DCEEF7"/>
           </a:solidFill>
           <a:ln>
-            <a:noFill/>
+            <a:solidFill/>
           </a:ln>
         </p:spPr>
         <p:txBody>
@@ -8341,7 +8474,7 @@
             <a:srgbClr val="FDE3DF"/>
           </a:solidFill>
           <a:ln>
-            <a:noFill/>
+            <a:solidFill/>
           </a:ln>
         </p:spPr>
         <p:txBody>
@@ -8417,7 +8550,7 @@
             <a:srgbClr val="FDE3DF"/>
           </a:solidFill>
           <a:ln>
-            <a:noFill/>
+            <a:solidFill/>
           </a:ln>
         </p:spPr>
         <p:txBody>
@@ -8468,7 +8601,7 @@
                 </a:solidFill>
                 <a:latin typeface="Nunito"/>
               </a:rPr>
-              <a:t>Never waits for an AI model</a:t>
+              <a:t>Resource rendering uses no model</a:t>
             </a:r>
           </a:p>
         </p:txBody>
@@ -8493,7 +8626,7 @@
             <a:srgbClr val="F3F0EA"/>
           </a:solidFill>
           <a:ln>
-            <a:noFill/>
+            <a:solidFill/>
           </a:ln>
         </p:spPr>
         <p:txBody>
@@ -8544,7 +8677,23 @@
                 </a:solidFill>
                 <a:latin typeface="Nunito"/>
               </a:rPr>
-              <a:t>T4 / offline: fixed text, no AI</a:t>
+              <a:t>T4 / offline / degraded:</a:t>
+            </a:r>
+          </a:p>
+          <a:p>
+            <a:pPr algn="l">
+              <a:spcAft>
+                <a:spcPts val="262"/>
+              </a:spcAft>
+            </a:pPr>
+            <a:r>
+              <a:rPr sz="1050" b="0">
+                <a:solidFill>
+                  <a:srgbClr val="2A2320"/>
+                </a:solidFill>
+                <a:latin typeface="Nunito"/>
+              </a:rPr>
+              <a:t>fixed wording</a:t>
             </a:r>
           </a:p>
         </p:txBody>
@@ -8772,7 +8921,23 @@
                 </a:solidFill>
                 <a:latin typeface="Nunito"/>
               </a:rPr>
-              <a:t>Engineering demonstration · resource content still needs review · no emergency monitoring or suicide-risk determination</a:t>
+              <a:t>Assessment may call a model; failure holds input and restricts ordinary output.</a:t>
+            </a:r>
+          </a:p>
+          <a:p>
+            <a:pPr algn="l">
+              <a:spcAft>
+                <a:spcPts val="262"/>
+              </a:spcAft>
+            </a:pPr>
+            <a:r>
+              <a:rPr sz="1050" b="0">
+                <a:solidFill>
+                  <a:srgbClr val="6B6258"/>
+                </a:solidFill>
+                <a:latin typeface="Nunito"/>
+              </a:rPr>
+              <a:t>Resources need review · no emergency monitoring or suicide-risk determination</a:t>
             </a:r>
           </a:p>
         </p:txBody>

</xml_diff>

<commit_message>
docs: validate Codex architecture audit; fix exporter outline side effect and slide 11 layout; regenerate deck, PNGs and reviewed PDF
Co-Authored-By: Claude Opus 5.5 <noreply@anthropic.com>
</commit_message>
<xml_diff>
--- a/docs/submission/assets/aura-health-deck.pptx
+++ b/docs/submission/assets/aura-health-deck.pptx
@@ -5851,7 +5851,7 @@
             <a:srgbClr val="F3F0EA"/>
           </a:solidFill>
           <a:ln>
-            <a:solidFill/>
+            <a:noFill/>
           </a:ln>
         </p:spPr>
         <p:txBody>
@@ -5886,7 +5886,7 @@
                 </a:solidFill>
                 <a:latin typeface="Nunito"/>
               </a:rPr>
-              <a:t>Breath + short recap</a:t>
+              <a:t>Recap, dose + reasons</a:t>
             </a:r>
           </a:p>
           <a:p>
@@ -5902,7 +5902,7 @@
                 </a:solidFill>
                 <a:latin typeface="Nunito"/>
               </a:rPr>
-              <a:t>Dose + reasons, medication</a:t>
+              <a:t>Medication, dates</a:t>
             </a:r>
           </a:p>
           <a:p>
@@ -5918,7 +5918,7 @@
                 </a:solidFill>
                 <a:latin typeface="Nunito"/>
               </a:rPr>
-              <a:t>Dates + optional suggestions</a:t>
+              <a:t>Optional small ideas</a:t>
             </a:r>
           </a:p>
         </p:txBody>
@@ -5943,7 +5943,7 @@
             <a:srgbClr val="F3F0EA"/>
           </a:solidFill>
           <a:ln>
-            <a:solidFill/>
+            <a:noFill/>
           </a:ln>
         </p:spPr>
         <p:txBody>
@@ -6056,7 +6056,7 @@
             <a:srgbClr val="DCEEF7"/>
           </a:solidFill>
           <a:ln>
-            <a:solidFill/>
+            <a:noFill/>
           </a:ln>
         </p:spPr>
         <p:txBody>
@@ -6116,7 +6116,7 @@
             <a:srgbClr val="DCEEF7"/>
           </a:solidFill>
           <a:ln>
-            <a:solidFill/>
+            <a:noFill/>
           </a:ln>
         </p:spPr>
         <p:txBody>
@@ -6176,7 +6176,7 @@
             <a:srgbClr val="FDE3DF"/>
           </a:solidFill>
           <a:ln>
-            <a:solidFill/>
+            <a:noFill/>
           </a:ln>
         </p:spPr>
         <p:txBody>
@@ -6236,7 +6236,7 @@
             <a:srgbClr val="DCEEF7"/>
           </a:solidFill>
           <a:ln>
-            <a:solidFill/>
+            <a:noFill/>
           </a:ln>
         </p:spPr>
         <p:txBody>
@@ -6296,7 +6296,7 @@
             <a:srgbClr val="E8E1F3"/>
           </a:solidFill>
           <a:ln>
-            <a:solidFill/>
+            <a:noFill/>
           </a:ln>
         </p:spPr>
         <p:txBody>
@@ -6356,7 +6356,7 @@
             <a:srgbClr val="E8E1F3"/>
           </a:solidFill>
           <a:ln>
-            <a:solidFill/>
+            <a:noFill/>
           </a:ln>
         </p:spPr>
         <p:txBody>
@@ -6485,7 +6485,7 @@
             <a:srgbClr val="FDE3DF"/>
           </a:solidFill>
           <a:ln>
-            <a:solidFill/>
+            <a:noFill/>
           </a:ln>
         </p:spPr>
         <p:txBody>
@@ -6561,7 +6561,7 @@
             <a:srgbClr val="FFF0D0"/>
           </a:solidFill>
           <a:ln>
-            <a:solidFill/>
+            <a:noFill/>
           </a:ln>
         </p:spPr>
         <p:txBody>
@@ -6854,14 +6854,14 @@
       </p:sp>
       <p:sp>
         <p:nvSpPr>
-          <p:cNvPr id="26" name="Text: Observable events via app ingestion"/>
-          <p:cNvSpPr txBox="1"/>
-          <p:nvPr/>
-        </p:nvSpPr>
-        <p:spPr>
-          <a:xfrm>
-            <a:off x="5346700" y="4394200"/>
-            <a:ext cx="2794000" cy="228600"/>
+          <p:cNvPr id="26" name="Text: Observable events"/>
+          <p:cNvSpPr txBox="1"/>
+          <p:nvPr/>
+        </p:nvSpPr>
+        <p:spPr>
+          <a:xfrm>
+            <a:off x="7137400" y="4445000"/>
+            <a:ext cx="1460500" cy="368300"/>
           </a:xfrm>
           <a:prstGeom prst="rect">
             <a:avLst/>
@@ -6874,17 +6874,33 @@
           <a:p>
             <a:pPr algn="l">
               <a:spcAft>
-                <a:spcPts val="427"/>
+                <a:spcPts val="405"/>
               </a:spcAft>
             </a:pPr>
             <a:r>
-              <a:rPr sz="950" b="0">
+              <a:rPr sz="900" b="0">
                 <a:solidFill>
                   <a:srgbClr val="6B6258"/>
                 </a:solidFill>
                 <a:latin typeface="Nunito"/>
               </a:rPr>
-              <a:t>Observable events via app ingestion</a:t>
+              <a:t>Observable events</a:t>
+            </a:r>
+          </a:p>
+          <a:p>
+            <a:pPr algn="l">
+              <a:spcAft>
+                <a:spcPts val="225"/>
+              </a:spcAft>
+            </a:pPr>
+            <a:r>
+              <a:rPr sz="900" b="0">
+                <a:solidFill>
+                  <a:srgbClr val="6B6258"/>
+                </a:solidFill>
+                <a:latin typeface="Nunito"/>
+              </a:rPr>
+              <a:t>via app ingestion</a:t>
             </a:r>
           </a:p>
         </p:txBody>
@@ -7115,7 +7131,7 @@
             <a:srgbClr val="DCEEF7"/>
           </a:solidFill>
           <a:ln>
-            <a:solidFill/>
+            <a:noFill/>
           </a:ln>
         </p:spPr>
         <p:txBody>
@@ -7191,7 +7207,7 @@
             <a:srgbClr val="E8E1F3"/>
           </a:solidFill>
           <a:ln>
-            <a:solidFill/>
+            <a:noFill/>
           </a:ln>
         </p:spPr>
         <p:txBody>
@@ -7267,7 +7283,7 @@
             <a:srgbClr val="DCEEF7"/>
           </a:solidFill>
           <a:ln>
-            <a:solidFill/>
+            <a:noFill/>
           </a:ln>
         </p:spPr>
         <p:txBody>
@@ -7343,7 +7359,7 @@
             <a:srgbClr val="F3F0EA"/>
           </a:solidFill>
           <a:ln>
-            <a:solidFill/>
+            <a:noFill/>
           </a:ln>
         </p:spPr>
         <p:txBody>
@@ -7403,7 +7419,7 @@
             <a:srgbClr val="E8E1F3"/>
           </a:solidFill>
           <a:ln>
-            <a:solidFill/>
+            <a:noFill/>
           </a:ln>
         </p:spPr>
         <p:txBody>
@@ -7479,7 +7495,7 @@
             <a:srgbClr val="DCEEF7"/>
           </a:solidFill>
           <a:ln>
-            <a:solidFill/>
+            <a:noFill/>
           </a:ln>
         </p:spPr>
         <p:txBody>
@@ -7555,7 +7571,7 @@
             <a:srgbClr val="F3F0EA"/>
           </a:solidFill>
           <a:ln>
-            <a:solidFill/>
+            <a:noFill/>
           </a:ln>
         </p:spPr>
         <p:txBody>
@@ -8094,7 +8110,7 @@
             <a:srgbClr val="F3F0EA"/>
           </a:solidFill>
           <a:ln>
-            <a:solidFill/>
+            <a:noFill/>
           </a:ln>
         </p:spPr>
         <p:txBody>
@@ -8170,7 +8186,7 @@
             <a:srgbClr val="E8E1F3"/>
           </a:solidFill>
           <a:ln>
-            <a:solidFill/>
+            <a:noFill/>
           </a:ln>
         </p:spPr>
         <p:txBody>
@@ -8246,7 +8262,7 @@
             <a:srgbClr val="FDE3DF"/>
           </a:solidFill>
           <a:ln>
-            <a:solidFill/>
+            <a:noFill/>
           </a:ln>
         </p:spPr>
         <p:txBody>
@@ -8322,7 +8338,7 @@
             <a:srgbClr val="FDE3DF"/>
           </a:solidFill>
           <a:ln>
-            <a:solidFill/>
+            <a:noFill/>
           </a:ln>
         </p:spPr>
         <p:txBody>
@@ -8398,7 +8414,7 @@
             <a:srgbClr val="DCEEF7"/>
           </a:solidFill>
           <a:ln>
-            <a:solidFill/>
+            <a:noFill/>
           </a:ln>
         </p:spPr>
         <p:txBody>
@@ -8474,7 +8490,7 @@
             <a:srgbClr val="FDE3DF"/>
           </a:solidFill>
           <a:ln>
-            <a:solidFill/>
+            <a:noFill/>
           </a:ln>
         </p:spPr>
         <p:txBody>
@@ -8550,7 +8566,7 @@
             <a:srgbClr val="FDE3DF"/>
           </a:solidFill>
           <a:ln>
-            <a:solidFill/>
+            <a:noFill/>
           </a:ln>
         </p:spPr>
         <p:txBody>
@@ -8626,7 +8642,7 @@
             <a:srgbClr val="F3F0EA"/>
           </a:solidFill>
           <a:ln>
-            <a:solidFill/>
+            <a:noFill/>
           </a:ln>
         </p:spPr>
         <p:txBody>

</xml_diff>

<commit_message>
docs: submission materials updated for sharing, agentic patient tasks and Q&A calculations; slide 11/14, reviewed PDF, script and voice-over
Co-Authored-By: Claude Opus 5.5 <noreply@anthropic.com>
</commit_message>
<xml_diff>
--- a/docs/submission/assets/aura-health-deck.pptx
+++ b/docs/submission/assets/aura-health-deck.pptx
@@ -519,7 +519,7 @@
           <a:lstStyle/>
           <a:p>
             <a:r>
-              <a:t>Scene 1 · The challenge — 0:00–0:25</a:t>
+              <a:t>Scene 1 · The challenge — 0:00–0:25 (live pitch)</a:t>
             </a:r>
           </a:p>
           <a:p/>
@@ -601,7 +601,7 @@
           <a:lstStyle/>
           <a:p>
             <a:r>
-              <a:t>Scene 8 · Safety first — 4:50–5:15</a:t>
+              <a:t>Scene 8 · Safety first — 4:50–5:15 (live pitch)</a:t>
             </a:r>
           </a:p>
           <a:p/>
@@ -683,7 +683,7 @@
           <a:lstStyle/>
           <a:p>
             <a:r>
-              <a:t>Scene 9 · How it's built — 5:15–6:00</a:t>
+              <a:t>Scene 9 · How it's built — 5:15–6:00 (live pitch)</a:t>
             </a:r>
           </a:p>
           <a:p/>
@@ -695,7 +695,7 @@
           <a:p/>
           <a:p>
             <a:r>
-              <a:t>"Our rule: signals propose, rules decide, AI words it. Deterministic engines own the personal baselines and the safety state. Medication information is curated; AI only matches a question to an approved topic. The clinician agent investigates with read-only tools, and every answer passes number, date and citation checks plus an independent verifier. In this demo the model runs on synthetic data only; a hospital would run it on its own private infrastructure."</a:t>
+              <a:t>"Our rule: signals propose, rules decide, AI words it. Deterministic engines own the personal baselines and the safety state. Medication information is curated; AI only matches a question to an approved topic. The clinician agent investigates with read-only tools, and every answer passes number, date and citation checks plus an independent verifier. In this demo the model runs on synthetic data only; a hospital would run it on its own private infrastructure. And the patient decides what their clinician sees: an agreed minimum, plus anything they choose to share, enforced on the server, so the agent says 'not shared, ask the patient' instead of guessing."</a:t>
             </a:r>
           </a:p>
           <a:p>
@@ -776,7 +776,7 @@
           <a:p/>
           <a:p>
             <a:r>
-              <a:t>Scene 9 · How it's built — 5:15–6:00</a:t>
+              <a:t>Scene 9 · How it's built — 5:15–6:00 (live pitch)</a:t>
             </a:r>
           </a:p>
           <a:p/>
@@ -788,7 +788,7 @@
           <a:p/>
           <a:p>
             <a:r>
-              <a:t>"Our rule: signals propose, rules decide, AI words it. Deterministic engines own the personal baselines and the safety state. Medication information is curated; AI only matches a question to an approved topic. The clinician agent investigates with read-only tools, and every answer passes number, date and citation checks plus an independent verifier. In this demo the model runs on synthetic data only; a hospital would run it on its own private infrastructure."</a:t>
+              <a:t>"Our rule: signals propose, rules decide, AI words it. Deterministic engines own the personal baselines and the safety state. Medication information is curated; AI only matches a question to an approved topic. The clinician agent investigates with read-only tools, and every answer passes number, date and citation checks plus an independent verifier. In this demo the model runs on synthetic data only; a hospital would run it on its own private infrastructure. And the patient decides what their clinician sees: an agreed minimum, plus anything they choose to share, enforced on the server, so the agent says 'not shared, ask the patient' instead of guessing."</a:t>
             </a:r>
           </a:p>
           <a:p>
@@ -869,7 +869,7 @@
           <a:p/>
           <a:p>
             <a:r>
-              <a:t>Scene 9 · How it's built — 5:15–6:00</a:t>
+              <a:t>Scene 9 · How it's built — 5:15–6:00 (live pitch)</a:t>
             </a:r>
           </a:p>
           <a:p/>
@@ -881,7 +881,7 @@
           <a:p/>
           <a:p>
             <a:r>
-              <a:t>"Our rule: signals propose, rules decide, AI words it. Deterministic engines own the personal baselines and the safety state. Medication information is curated; AI only matches a question to an approved topic. The clinician agent investigates with read-only tools, and every answer passes number, date and citation checks plus an independent verifier. In this demo the model runs on synthetic data only; a hospital would run it on its own private infrastructure."</a:t>
+              <a:t>"Our rule: signals propose, rules decide, AI words it. Deterministic engines own the personal baselines and the safety state. Medication information is curated; AI only matches a question to an approved topic. The clinician agent investigates with read-only tools, and every answer passes number, date and citation checks plus an independent verifier. In this demo the model runs on synthetic data only; a hospital would run it on its own private infrastructure. And the patient decides what their clinician sees: an agreed minimum, plus anything they choose to share, enforced on the server, so the agent says 'not shared, ask the patient' instead of guessing."</a:t>
             </a:r>
           </a:p>
           <a:p>
@@ -962,7 +962,7 @@
           <a:p/>
           <a:p>
             <a:r>
-              <a:t>Scene 9 · How it's built — 5:15–6:00</a:t>
+              <a:t>Scene 9 · How it's built — 5:15–6:00 (live pitch)</a:t>
             </a:r>
           </a:p>
           <a:p/>
@@ -974,7 +974,7 @@
           <a:p/>
           <a:p>
             <a:r>
-              <a:t>"Our rule: signals propose, rules decide, AI words it. Deterministic engines own the personal baselines and the safety state. Medication information is curated; AI only matches a question to an approved topic. The clinician agent investigates with read-only tools, and every answer passes number, date and citation checks plus an independent verifier. In this demo the model runs on synthetic data only; a hospital would run it on its own private infrastructure."</a:t>
+              <a:t>"Our rule: signals propose, rules decide, AI words it. Deterministic engines own the personal baselines and the safety state. Medication information is curated; AI only matches a question to an approved topic. The clinician agent investigates with read-only tools, and every answer passes number, date and citation checks plus an independent verifier. In this demo the model runs on synthetic data only; a hospital would run it on its own private infrastructure. And the patient decides what their clinician sees: an agreed minimum, plus anything they choose to share, enforced on the server, so the agent says 'not shared, ask the patient' instead of guessing."</a:t>
             </a:r>
           </a:p>
         </p:txBody>
@@ -1044,7 +1044,7 @@
           <a:lstStyle/>
           <a:p>
             <a:r>
-              <a:t>Scene 10 · Fit with the challenge — 6:00–6:25</a:t>
+              <a:t>Scene 10 · Fit with the challenge — 6:00–6:25 (live pitch)</a:t>
             </a:r>
           </a:p>
           <a:p/>
@@ -1126,7 +1126,7 @@
           <a:lstStyle/>
           <a:p>
             <a:r>
-              <a:t>Scene 11 · How we built it — 6:25–6:45</a:t>
+              <a:t>Scene 11 · How we built it — 6:25–6:45 (live pitch)</a:t>
             </a:r>
           </a:p>
           <a:p/>
@@ -1208,7 +1208,7 @@
           <a:lstStyle/>
           <a:p>
             <a:r>
-              <a:t>Scene 12 · Impact and close — 6:45–7:05</a:t>
+              <a:t>Scene 12 · Impact and close — 6:45–7:05 (live pitch)</a:t>
             </a:r>
           </a:p>
           <a:p/>
@@ -1296,7 +1296,7 @@
           <a:p/>
           <a:p>
             <a:r>
-              <a:t>Scene 12 · Impact and close — 6:45–7:05</a:t>
+              <a:t>Scene 12 · Impact and close — 6:45–7:05 (live pitch)</a:t>
             </a:r>
           </a:p>
           <a:p/>
@@ -1384,7 +1384,7 @@
           <a:p/>
           <a:p>
             <a:r>
-              <a:t>Scene 1 · The challenge — 0:00–0:25</a:t>
+              <a:t>Scene 1 · The challenge — 0:00–0:25 (live pitch)</a:t>
             </a:r>
           </a:p>
           <a:p/>
@@ -1466,7 +1466,7 @@
           <a:lstStyle/>
           <a:p>
             <a:r>
-              <a:t>Scene 2 · The problem — 0:25–0:55</a:t>
+              <a:t>Scene 2 · The problem — 0:25–0:55 (live pitch)</a:t>
             </a:r>
           </a:p>
           <a:p/>
@@ -1548,7 +1548,7 @@
           <a:lstStyle/>
           <a:p>
             <a:r>
-              <a:t>Scene 3 · A calm start — 0:55–1:35</a:t>
+              <a:t>Scene 3 · A calm start — 0:55–1:35 (live pitch)</a:t>
             </a:r>
           </a:p>
           <a:p/>
@@ -1636,7 +1636,7 @@
           <a:p/>
           <a:p>
             <a:r>
-              <a:t>Scene 3 · A calm start — 0:55–1:35</a:t>
+              <a:t>Scene 3 · A calm start — 0:55–1:35 (live pitch)</a:t>
             </a:r>
           </a:p>
           <a:p/>
@@ -1718,7 +1718,7 @@
           <a:lstStyle/>
           <a:p>
             <a:r>
-              <a:t>Scene 4 · My medication, my day — 1:35–2:35</a:t>
+              <a:t>Scene 4 · My medication, my day — 1:35–2:35 (live pitch)</a:t>
             </a:r>
           </a:p>
           <a:p/>
@@ -1812,7 +1812,7 @@
           <a:lstStyle/>
           <a:p>
             <a:r>
-              <a:t>Scene 5 · Ready for the appointment — 2:35–3:05</a:t>
+              <a:t>Scene 5 · Ready for the appointment — 2:35–3:05 (live pitch)</a:t>
             </a:r>
           </a:p>
           <a:p/>
@@ -1894,7 +1894,7 @@
           <a:lstStyle/>
           <a:p>
             <a:r>
-              <a:t>Scene 6 · What the clinician sees — the agent at work — 3:05–4:10</a:t>
+              <a:t>Scene 6 · What the clinician sees — the agent at work — 3:05–4:10 (live pitch)</a:t>
             </a:r>
           </a:p>
           <a:p/>
@@ -1988,7 +1988,7 @@
           <a:lstStyle/>
           <a:p>
             <a:r>
-              <a:t>Scene 7 · Something changes — 4:10–4:50</a:t>
+              <a:t>Scene 7 · Something changes — 4:10–4:50 (live pitch)</a:t>
             </a:r>
           </a:p>
           <a:p/>
@@ -5902,7 +5902,7 @@
                 </a:solidFill>
                 <a:latin typeface="Nunito"/>
               </a:rPr>
-              <a:t>Medication, dates</a:t>
+              <a:t>Replies, ideas, activities</a:t>
             </a:r>
           </a:p>
           <a:p>
@@ -5918,7 +5918,7 @@
                 </a:solidFill>
                 <a:latin typeface="Nunito"/>
               </a:rPr>
-              <a:t>Optional small ideas</a:t>
+              <a:t>Sharing choices</a:t>
             </a:r>
           </a:p>
         </p:txBody>
@@ -5978,7 +5978,7 @@
                 </a:solidFill>
                 <a:latin typeface="Nunito"/>
               </a:rPr>
-              <a:t>Findings with sources</a:t>
+              <a:t>Findings, Ask the record</a:t>
             </a:r>
           </a:p>
           <a:p>
@@ -5994,7 +5994,7 @@
                 </a:solidFill>
                 <a:latin typeface="Nunito"/>
               </a:rPr>
-              <a:t>Ask about the record</a:t>
+              <a:t>Only what is shared</a:t>
             </a:r>
           </a:p>
         </p:txBody>
@@ -6944,69 +6944,191 @@
       </p:sp>
       <p:sp>
         <p:nvSpPr>
-          <p:cNvPr id="28" name="Text: One application · synthetic workspaces ·"/>
-          <p:cNvSpPr txBox="1"/>
-          <p:nvPr/>
-        </p:nvSpPr>
-        <p:spPr>
-          <a:xfrm>
-            <a:off x="8636000" y="4826000"/>
-            <a:ext cx="3048000" cy="1587500"/>
-          </a:xfrm>
-          <a:prstGeom prst="rect">
-            <a:avLst/>
-          </a:prstGeom>
-          <a:noFill/>
-        </p:spPr>
-        <p:txBody>
-          <a:bodyPr wrap="square" anchor="t" lIns="0" rIns="0" tIns="0" bIns="0"/>
+          <p:cNvPr id="28" name="Box: Patient-controlled sharing"/>
+          <p:cNvSpPr/>
+          <p:nvPr/>
+        </p:nvSpPr>
+        <p:spPr>
+          <a:xfrm>
+            <a:off x="8509000" y="4826000"/>
+            <a:ext cx="2286000" cy="1270000"/>
+          </a:xfrm>
+          <a:prstGeom prst="roundRect">
+            <a:avLst>
+              <a:gd name="adj" fmla="val 11000"/>
+            </a:avLst>
+          </a:prstGeom>
+          <a:solidFill>
+            <a:srgbClr val="FFF0D0"/>
+          </a:solidFill>
+          <a:ln>
+            <a:noFill/>
+          </a:ln>
+        </p:spPr>
+        <p:txBody>
+          <a:bodyPr rtlCol="0" anchor="t" wrap="square" lIns="152400" rIns="152400" tIns="152400" bIns="152400"/>
           <a:lstStyle/>
           <a:p>
             <a:pPr algn="l">
               <a:spcAft>
-                <a:spcPts val="472"/>
+                <a:spcPts val="562"/>
               </a:spcAft>
             </a:pPr>
             <a:r>
-              <a:rPr sz="1050" b="0">
+              <a:rPr sz="1250" b="1">
+                <a:solidFill>
+                  <a:srgbClr val="2A2320"/>
+                </a:solidFill>
+                <a:latin typeface="Nunito"/>
+              </a:rPr>
+              <a:t>Patient-controlled sharing</a:t>
+            </a:r>
+          </a:p>
+          <a:p>
+            <a:pPr algn="l">
+              <a:spcAft>
+                <a:spcPts val="250"/>
+              </a:spcAft>
+            </a:pPr>
+            <a:r>
+              <a:rPr sz="1000" b="0">
+                <a:solidFill>
+                  <a:srgbClr val="2A2320"/>
+                </a:solidFill>
+                <a:latin typeface="Nunito"/>
+              </a:rPr>
+              <a:t>Minimum always; notes, readings,</a:t>
+            </a:r>
+          </a:p>
+          <a:p>
+            <a:pPr algn="l">
+              <a:spcAft>
+                <a:spcPts val="250"/>
+              </a:spcAft>
+            </a:pPr>
+            <a:r>
+              <a:rPr sz="1000" b="0">
+                <a:solidFill>
+                  <a:srgbClr val="2A2320"/>
+                </a:solidFill>
+                <a:latin typeface="Nunito"/>
+              </a:rPr>
+              <a:t>daily check-ins opt-in</a:t>
+            </a:r>
+          </a:p>
+        </p:txBody>
+      </p:sp>
+      <p:cxnSp>
+        <p:nvCxnSpPr>
+          <p:cNvPr id="29" name="Arrow: Patient-controlled s → Bounded AI · read-on"/>
+          <p:cNvCxnSpPr>
+            <a:stCxn id="28" idx="0"/>
+            <a:endCxn id="6" idx="2"/>
+          </p:cNvCxnSpPr>
+          <p:nvPr/>
+        </p:nvCxnSpPr>
+        <p:spPr>
+          <a:xfrm flipV="1">
+            <a:off x="9652000" y="4381500"/>
+            <a:ext cx="1" cy="444500"/>
+          </a:xfrm>
+          <a:prstGeom prst="line">
+            <a:avLst/>
+          </a:prstGeom>
+          <a:ln w="25400">
+            <a:solidFill>
+              <a:srgbClr val="6B6258"/>
+            </a:solidFill>
+            <a:tailEnd type="triangle" w="med" len="med"/>
+          </a:ln>
+        </p:spPr>
+      </p:cxnSp>
+      <p:sp>
+        <p:nvSpPr>
+          <p:cNvPr id="30" name="Text: limits what clinician"/>
+          <p:cNvSpPr txBox="1"/>
+          <p:nvPr/>
+        </p:nvSpPr>
+        <p:spPr>
+          <a:xfrm>
+            <a:off x="9715500" y="4445000"/>
+            <a:ext cx="1905000" cy="368300"/>
+          </a:xfrm>
+          <a:prstGeom prst="rect">
+            <a:avLst/>
+          </a:prstGeom>
+          <a:noFill/>
+        </p:spPr>
+        <p:txBody>
+          <a:bodyPr wrap="square" anchor="t" lIns="0" rIns="0" tIns="0" bIns="0"/>
+          <a:lstStyle/>
+          <a:p>
+            <a:pPr algn="l">
+              <a:spcAft>
+                <a:spcPts val="360"/>
+              </a:spcAft>
+            </a:pPr>
+            <a:r>
+              <a:rPr sz="800" b="0">
                 <a:solidFill>
                   <a:srgbClr val="6B6258"/>
                 </a:solidFill>
                 <a:latin typeface="Nunito"/>
               </a:rPr>
-              <a:t>One application · synthetic workspaces · development storage</a:t>
+              <a:t>limits what clinician</a:t>
             </a:r>
           </a:p>
           <a:p>
             <a:pPr algn="l">
               <a:spcAft>
-                <a:spcPts val="262"/>
+                <a:spcPts val="200"/>
               </a:spcAft>
             </a:pPr>
             <a:r>
-              <a:rPr sz="1050" b="0">
+              <a:rPr sz="800" b="0">
                 <a:solidFill>
                   <a:srgbClr val="6B6258"/>
                 </a:solidFill>
                 <a:latin typeface="Nunito"/>
               </a:rPr>
-              <a:t>Demo roles, no clinical authentication. Visit preview: Not sent.</a:t>
-            </a:r>
-          </a:p>
+              <a:t>runs can read</a:t>
+            </a:r>
+          </a:p>
+        </p:txBody>
+      </p:sp>
+      <p:sp>
+        <p:nvSpPr>
+          <p:cNvPr id="31" name="Text: One application · synthetic workspaces ·"/>
+          <p:cNvSpPr txBox="1"/>
+          <p:nvPr/>
+        </p:nvSpPr>
+        <p:spPr>
+          <a:xfrm>
+            <a:off x="508000" y="6254750"/>
+            <a:ext cx="11176000" cy="254000"/>
+          </a:xfrm>
+          <a:prstGeom prst="rect">
+            <a:avLst/>
+          </a:prstGeom>
+          <a:noFill/>
+        </p:spPr>
+        <p:txBody>
+          <a:bodyPr wrap="square" anchor="t" lIns="0" rIns="0" tIns="0" bIns="0"/>
+          <a:lstStyle/>
           <a:p>
             <a:pPr algn="l">
               <a:spcAft>
-                <a:spcPts val="262"/>
+                <a:spcPts val="427"/>
               </a:spcAft>
             </a:pPr>
             <a:r>
-              <a:rPr sz="1050" b="0">
+              <a:rPr sz="950" b="0">
                 <a:solidFill>
                   <a:srgbClr val="6B6258"/>
                 </a:solidFill>
                 <a:latin typeface="Nunito"/>
               </a:rPr>
-              <a:t>Institutional hosting is future work</a:t>
+              <a:t>One application · synthetic workspaces · development storage · demo roles, no clinical authentication · visit preview Not sent · institutional hosting is future work</a:t>
             </a:r>
           </a:p>
         </p:txBody>
@@ -9166,7 +9288,7 @@
         <p:spPr>
           <a:xfrm>
             <a:off x="876300" y="2637730"/>
-            <a:ext cx="7032244" cy="284480"/>
+            <a:ext cx="9654032" cy="568920"/>
           </a:xfrm>
           <a:prstGeom prst="rect">
             <a:avLst/>
@@ -9198,7 +9320,7 @@
                 </a:solidFill>
                 <a:latin typeface="Nunito"/>
               </a:rPr>
-              <a:t> — one record, two views.</a:t>
+              <a:t> — one record, two views; the patient decides what the clinician sees.</a:t>
             </a:r>
           </a:p>
         </p:txBody>
@@ -9211,7 +9333,7 @@
         </p:nvSpPr>
         <p:spPr>
           <a:xfrm>
-            <a:off x="876300" y="3087290"/>
+            <a:off x="876300" y="3371750"/>
             <a:ext cx="9654032" cy="568920"/>
           </a:xfrm>
           <a:prstGeom prst="rect">
@@ -9257,7 +9379,7 @@
         </p:nvSpPr>
         <p:spPr>
           <a:xfrm>
-            <a:off x="876300" y="3821310"/>
+            <a:off x="876300" y="4105771"/>
             <a:ext cx="8042656" cy="284480"/>
           </a:xfrm>
           <a:prstGeom prst="rect">
@@ -9303,7 +9425,7 @@
         </p:nvSpPr>
         <p:spPr>
           <a:xfrm>
-            <a:off x="876300" y="4270871"/>
+            <a:off x="876300" y="4555331"/>
             <a:ext cx="9654032" cy="568920"/>
           </a:xfrm>
           <a:prstGeom prst="rect">

</xml_diff>